<commit_message>
Ordena tabelas por desvio da tendência (maior estouro ao maior saving)
Co-Authored-By: Claude Opus 5.5 <noreply@anthropic.com>
Claude-Session: https://claude.ai/code/session_0185ssrhs1XpW9XHreWECmyp
</commit_message>
<xml_diff>
--- a/20261006 - Santo Antônio Energia - Resultados OM set26.pptx
+++ b/20261006 - Santo Antônio Energia - Resultados OM set26.pptx
@@ -16913,7 +16913,7 @@
                           </a:solidFill>
                           <a:latin typeface="+mn-lt"/>
                         </a:rPr>
-                        <a:t>Pessoal</a:t>
+                        <a:t>Logística</a:t>
                       </a:r>
                     </a:p>
                   </a:txBody>
@@ -17010,7 +17010,7 @@
                           </a:solidFill>
                           <a:latin typeface="+mn-lt"/>
                         </a:rPr>
-                        <a:t>8.868</a:t>
+                        <a:t>28</a:t>
                       </a:r>
                     </a:p>
                   </a:txBody>
@@ -17060,7 +17060,7 @@
                           </a:solidFill>
                           <a:latin typeface="+mn-lt"/>
                         </a:rPr>
-                        <a:t>8.480</a:t>
+                        <a:t>915</a:t>
                       </a:r>
                     </a:p>
                   </a:txBody>
@@ -17106,11 +17106,11 @@
                       <a:r>
                         <a:rPr lang="pt-BR" sz="1000" b="1" noProof="0" dirty="0">
                           <a:solidFill>
-                            <a:srgbClr val="00803C"/>
+                            <a:srgbClr val="C00000"/>
                           </a:solidFill>
                           <a:latin typeface="+mn-lt"/>
                         </a:rPr>
-                        <a:t>-388</a:t>
+                        <a:t>887</a:t>
                       </a:r>
                     </a:p>
                   </a:txBody>
@@ -17204,7 +17204,7 @@
                           </a:solidFill>
                           <a:latin typeface="+mn-lt"/>
                         </a:rPr>
-                        <a:t>77.351</a:t>
+                        <a:t>963</a:t>
                       </a:r>
                     </a:p>
                   </a:txBody>
@@ -17254,7 +17254,7 @@
                           </a:solidFill>
                           <a:latin typeface="+mn-lt"/>
                         </a:rPr>
-                        <a:t>74.198</a:t>
+                        <a:t>5.660</a:t>
                       </a:r>
                     </a:p>
                   </a:txBody>
@@ -17300,11 +17300,11 @@
                       <a:r>
                         <a:rPr lang="pt-BR" sz="1000" b="1" noProof="0" dirty="0">
                           <a:solidFill>
-                            <a:srgbClr val="00803C"/>
+                            <a:srgbClr val="C00000"/>
                           </a:solidFill>
                           <a:latin typeface="+mn-lt"/>
                         </a:rPr>
-                        <a:t>-3.153</a:t>
+                        <a:t>4.697</a:t>
                       </a:r>
                     </a:p>
                   </a:txBody>
@@ -17398,7 +17398,7 @@
                           </a:solidFill>
                           <a:latin typeface="+mn-lt"/>
                         </a:rPr>
-                        <a:t>26.630</a:t>
+                        <a:t>85</a:t>
                       </a:r>
                     </a:p>
                   </a:txBody>
@@ -17448,7 +17448,7 @@
                           </a:solidFill>
                           <a:latin typeface="+mn-lt"/>
                         </a:rPr>
-                        <a:t>26.737</a:t>
+                        <a:t>860</a:t>
                       </a:r>
                     </a:p>
                   </a:txBody>
@@ -17498,7 +17498,7 @@
                           </a:solidFill>
                           <a:latin typeface="+mn-lt"/>
                         </a:rPr>
-                        <a:t>107</a:t>
+                        <a:t>774</a:t>
                       </a:r>
                     </a:p>
                   </a:txBody>
@@ -17592,7 +17592,7 @@
                           </a:solidFill>
                           <a:latin typeface="+mn-lt"/>
                         </a:rPr>
-                        <a:t>103.981</a:t>
+                        <a:t>1.048</a:t>
                       </a:r>
                     </a:p>
                   </a:txBody>
@@ -17642,7 +17642,7 @@
                           </a:solidFill>
                           <a:latin typeface="+mn-lt"/>
                         </a:rPr>
-                        <a:t>100.934</a:t>
+                        <a:t>6.519</a:t>
                       </a:r>
                     </a:p>
                   </a:txBody>
@@ -17688,11 +17688,11 @@
                       <a:r>
                         <a:rPr lang="pt-BR" sz="1000" b="1" noProof="0" dirty="0">
                           <a:solidFill>
-                            <a:srgbClr val="00803C"/>
+                            <a:srgbClr val="C00000"/>
                           </a:solidFill>
                           <a:latin typeface="+mn-lt"/>
                         </a:rPr>
-                        <a:t>-3.046</a:t>
+                        <a:t>5.471</a:t>
                       </a:r>
                     </a:p>
                   </a:txBody>
@@ -17752,7 +17752,7 @@
                           </a:solidFill>
                           <a:latin typeface="+mn-lt"/>
                         </a:rPr>
-                        <a:t>Manutenção Operacional</a:t>
+                        <a:t>Não Recorrente</a:t>
                       </a:r>
                     </a:p>
                   </a:txBody>
@@ -17839,7 +17839,7 @@
                           </a:solidFill>
                           <a:latin typeface="+mn-lt"/>
                         </a:rPr>
-                        <a:t>8.937</a:t>
+                        <a:t>0</a:t>
                       </a:r>
                     </a:p>
                   </a:txBody>
@@ -17884,7 +17884,7 @@
                           </a:solidFill>
                           <a:latin typeface="+mn-lt"/>
                         </a:rPr>
-                        <a:t>8.693</a:t>
+                        <a:t>0</a:t>
                       </a:r>
                     </a:p>
                   </a:txBody>
@@ -17929,7 +17929,7 @@
                           </a:solidFill>
                           <a:latin typeface="+mn-lt"/>
                         </a:rPr>
-                        <a:t>-244</a:t>
+                        <a:t>0</a:t>
                       </a:r>
                     </a:p>
                   </a:txBody>
@@ -18013,7 +18013,7 @@
                           </a:solidFill>
                           <a:latin typeface="+mn-lt"/>
                         </a:rPr>
-                        <a:t>62.394</a:t>
+                        <a:t>75</a:t>
                       </a:r>
                     </a:p>
                   </a:txBody>
@@ -18058,7 +18058,7 @@
                           </a:solidFill>
                           <a:latin typeface="+mn-lt"/>
                         </a:rPr>
-                        <a:t>58.593</a:t>
+                        <a:t>0</a:t>
                       </a:r>
                     </a:p>
                   </a:txBody>
@@ -18103,7 +18103,7 @@
                           </a:solidFill>
                           <a:latin typeface="+mn-lt"/>
                         </a:rPr>
-                        <a:t>-3.801</a:t>
+                        <a:t>-75</a:t>
                       </a:r>
                     </a:p>
                   </a:txBody>
@@ -18187,7 +18187,7 @@
                           </a:solidFill>
                           <a:latin typeface="+mn-lt"/>
                         </a:rPr>
-                        <a:t>27.557</a:t>
+                        <a:t>0</a:t>
                       </a:r>
                     </a:p>
                   </a:txBody>
@@ -18232,7 +18232,7 @@
                           </a:solidFill>
                           <a:latin typeface="+mn-lt"/>
                         </a:rPr>
-                        <a:t>32.252</a:t>
+                        <a:t>3.377</a:t>
                       </a:r>
                     </a:p>
                   </a:txBody>
@@ -18277,7 +18277,7 @@
                           </a:solidFill>
                           <a:latin typeface="+mn-lt"/>
                         </a:rPr>
-                        <a:t>4.696</a:t>
+                        <a:t>3.377</a:t>
                       </a:r>
                     </a:p>
                   </a:txBody>
@@ -18361,7 +18361,7 @@
                           </a:solidFill>
                           <a:latin typeface="+mn-lt"/>
                         </a:rPr>
-                        <a:t>89.951</a:t>
+                        <a:t>75</a:t>
                       </a:r>
                     </a:p>
                   </a:txBody>
@@ -18406,7 +18406,7 @@
                           </a:solidFill>
                           <a:latin typeface="+mn-lt"/>
                         </a:rPr>
-                        <a:t>90.845</a:t>
+                        <a:t>3.377</a:t>
                       </a:r>
                     </a:p>
                   </a:txBody>
@@ -18451,7 +18451,7 @@
                           </a:solidFill>
                           <a:latin typeface="+mn-lt"/>
                         </a:rPr>
-                        <a:t>894</a:t>
+                        <a:t>3.302</a:t>
                       </a:r>
                     </a:p>
                   </a:txBody>
@@ -18506,7 +18506,7 @@
                           </a:solidFill>
                           <a:latin typeface="+mn-lt"/>
                         </a:rPr>
-                        <a:t>Consultoria e Serv. Legais/Fin.</a:t>
+                        <a:t>Manutenção Operacional</a:t>
                       </a:r>
                     </a:p>
                   </a:txBody>
@@ -18593,7 +18593,7 @@
                           </a:solidFill>
                           <a:latin typeface="+mn-lt"/>
                         </a:rPr>
-                        <a:t>2.628</a:t>
+                        <a:t>8.937</a:t>
                       </a:r>
                     </a:p>
                   </a:txBody>
@@ -18638,7 +18638,7 @@
                           </a:solidFill>
                           <a:latin typeface="+mn-lt"/>
                         </a:rPr>
-                        <a:t>3.976</a:t>
+                        <a:t>8.693</a:t>
                       </a:r>
                     </a:p>
                   </a:txBody>
@@ -18679,11 +18679,11 @@
                       <a:r>
                         <a:rPr lang="pt-BR" sz="1000" b="1" noProof="0" dirty="0">
                           <a:solidFill>
-                            <a:srgbClr val="C00000"/>
+                            <a:srgbClr val="00803C"/>
                           </a:solidFill>
                           <a:latin typeface="+mn-lt"/>
                         </a:rPr>
-                        <a:t>1.348</a:t>
+                        <a:t>-244</a:t>
                       </a:r>
                     </a:p>
                   </a:txBody>
@@ -18767,7 +18767,7 @@
                           </a:solidFill>
                           <a:latin typeface="+mn-lt"/>
                         </a:rPr>
-                        <a:t>25.286</a:t>
+                        <a:t>62.394</a:t>
                       </a:r>
                     </a:p>
                   </a:txBody>
@@ -18812,7 +18812,7 @@
                           </a:solidFill>
                           <a:latin typeface="+mn-lt"/>
                         </a:rPr>
-                        <a:t>22.928</a:t>
+                        <a:t>58.593</a:t>
                       </a:r>
                     </a:p>
                   </a:txBody>
@@ -18857,7 +18857,7 @@
                           </a:solidFill>
                           <a:latin typeface="+mn-lt"/>
                         </a:rPr>
-                        <a:t>-2.359</a:t>
+                        <a:t>-3.801</a:t>
                       </a:r>
                     </a:p>
                   </a:txBody>
@@ -18941,7 +18941,7 @@
                           </a:solidFill>
                           <a:latin typeface="+mn-lt"/>
                         </a:rPr>
-                        <a:t>8.805</a:t>
+                        <a:t>27.557</a:t>
                       </a:r>
                     </a:p>
                   </a:txBody>
@@ -18986,7 +18986,7 @@
                           </a:solidFill>
                           <a:latin typeface="+mn-lt"/>
                         </a:rPr>
-                        <a:t>10.223</a:t>
+                        <a:t>32.252</a:t>
                       </a:r>
                     </a:p>
                   </a:txBody>
@@ -19031,7 +19031,7 @@
                           </a:solidFill>
                           <a:latin typeface="+mn-lt"/>
                         </a:rPr>
-                        <a:t>1.419</a:t>
+                        <a:t>4.696</a:t>
                       </a:r>
                     </a:p>
                   </a:txBody>
@@ -19115,7 +19115,7 @@
                           </a:solidFill>
                           <a:latin typeface="+mn-lt"/>
                         </a:rPr>
-                        <a:t>34.091</a:t>
+                        <a:t>89.951</a:t>
                       </a:r>
                     </a:p>
                   </a:txBody>
@@ -19160,7 +19160,7 @@
                           </a:solidFill>
                           <a:latin typeface="+mn-lt"/>
                         </a:rPr>
-                        <a:t>33.151</a:t>
+                        <a:t>90.845</a:t>
                       </a:r>
                     </a:p>
                   </a:txBody>
@@ -19201,11 +19201,11 @@
                       <a:r>
                         <a:rPr lang="pt-BR" sz="1000" b="1" noProof="0" dirty="0">
                           <a:solidFill>
-                            <a:srgbClr val="00803C"/>
+                            <a:srgbClr val="C00000"/>
                           </a:solidFill>
                           <a:latin typeface="+mn-lt"/>
                         </a:rPr>
-                        <a:t>-940</a:t>
+                        <a:t>894</a:t>
                       </a:r>
                     </a:p>
                   </a:txBody>
@@ -19260,7 +19260,7 @@
                           </a:solidFill>
                           <a:latin typeface="+mn-lt"/>
                         </a:rPr>
-                        <a:t>TI</a:t>
+                        <a:t>Imóveis</a:t>
                       </a:r>
                     </a:p>
                   </a:txBody>
@@ -19347,7 +19347,7 @@
                           </a:solidFill>
                           <a:latin typeface="+mn-lt"/>
                         </a:rPr>
-                        <a:t>2.891</a:t>
+                        <a:t>917</a:t>
                       </a:r>
                     </a:p>
                   </a:txBody>
@@ -19392,7 +19392,7 @@
                           </a:solidFill>
                           <a:latin typeface="+mn-lt"/>
                         </a:rPr>
-                        <a:t>3.484</a:t>
+                        <a:t>727</a:t>
                       </a:r>
                     </a:p>
                   </a:txBody>
@@ -19433,11 +19433,11 @@
                       <a:r>
                         <a:rPr lang="pt-BR" sz="1000" b="1" noProof="0" dirty="0">
                           <a:solidFill>
-                            <a:srgbClr val="C00000"/>
+                            <a:srgbClr val="00803C"/>
                           </a:solidFill>
                           <a:latin typeface="+mn-lt"/>
                         </a:rPr>
-                        <a:t>592</a:t>
+                        <a:t>-190</a:t>
                       </a:r>
                     </a:p>
                   </a:txBody>
@@ -19521,7 +19521,7 @@
                           </a:solidFill>
                           <a:latin typeface="+mn-lt"/>
                         </a:rPr>
-                        <a:t>12.778</a:t>
+                        <a:t>7.285</a:t>
                       </a:r>
                     </a:p>
                   </a:txBody>
@@ -19566,7 +19566,7 @@
                           </a:solidFill>
                           <a:latin typeface="+mn-lt"/>
                         </a:rPr>
-                        <a:t>13.237</a:t>
+                        <a:t>7.338</a:t>
                       </a:r>
                     </a:p>
                   </a:txBody>
@@ -19611,7 +19611,7 @@
                           </a:solidFill>
                           <a:latin typeface="+mn-lt"/>
                         </a:rPr>
-                        <a:t>459</a:t>
+                        <a:t>53</a:t>
                       </a:r>
                     </a:p>
                   </a:txBody>
@@ -19695,7 +19695,7 @@
                           </a:solidFill>
                           <a:latin typeface="+mn-lt"/>
                         </a:rPr>
-                        <a:t>5.761</a:t>
+                        <a:t>2.418</a:t>
                       </a:r>
                     </a:p>
                   </a:txBody>
@@ -19740,7 +19740,7 @@
                           </a:solidFill>
                           <a:latin typeface="+mn-lt"/>
                         </a:rPr>
-                        <a:t>5.302</a:t>
+                        <a:t>2.888</a:t>
                       </a:r>
                     </a:p>
                   </a:txBody>
@@ -19781,11 +19781,11 @@
                       <a:r>
                         <a:rPr lang="pt-BR" sz="1000" b="1" noProof="0" dirty="0">
                           <a:solidFill>
-                            <a:srgbClr val="00803C"/>
+                            <a:srgbClr val="C00000"/>
                           </a:solidFill>
                           <a:latin typeface="+mn-lt"/>
                         </a:rPr>
-                        <a:t>-458</a:t>
+                        <a:t>470</a:t>
                       </a:r>
                     </a:p>
                   </a:txBody>
@@ -19869,7 +19869,7 @@
                           </a:solidFill>
                           <a:latin typeface="+mn-lt"/>
                         </a:rPr>
-                        <a:t>18.539</a:t>
+                        <a:t>9.703</a:t>
                       </a:r>
                     </a:p>
                   </a:txBody>
@@ -19914,7 +19914,7 @@
                           </a:solidFill>
                           <a:latin typeface="+mn-lt"/>
                         </a:rPr>
-                        <a:t>18.540</a:t>
+                        <a:t>10.226</a:t>
                       </a:r>
                     </a:p>
                   </a:txBody>
@@ -19959,7 +19959,7 @@
                           </a:solidFill>
                           <a:latin typeface="+mn-lt"/>
                         </a:rPr>
-                        <a:t>1</a:t>
+                        <a:t>523</a:t>
                       </a:r>
                     </a:p>
                   </a:txBody>
@@ -20014,7 +20014,7 @@
                           </a:solidFill>
                           <a:latin typeface="+mn-lt"/>
                         </a:rPr>
-                        <a:t>Imóveis</a:t>
+                        <a:t>Custos Capt. Financeira</a:t>
                       </a:r>
                     </a:p>
                   </a:txBody>
@@ -20101,7 +20101,7 @@
                           </a:solidFill>
                           <a:latin typeface="+mn-lt"/>
                         </a:rPr>
-                        <a:t>917</a:t>
+                        <a:t>0</a:t>
                       </a:r>
                     </a:p>
                   </a:txBody>
@@ -20146,7 +20146,7 @@
                           </a:solidFill>
                           <a:latin typeface="+mn-lt"/>
                         </a:rPr>
-                        <a:t>727</a:t>
+                        <a:t>9</a:t>
                       </a:r>
                     </a:p>
                   </a:txBody>
@@ -20187,11 +20187,11 @@
                       <a:r>
                         <a:rPr lang="pt-BR" sz="1000" b="1" noProof="0" dirty="0">
                           <a:solidFill>
-                            <a:srgbClr val="00803C"/>
+                            <a:srgbClr val="C00000"/>
                           </a:solidFill>
                           <a:latin typeface="+mn-lt"/>
                         </a:rPr>
-                        <a:t>-190</a:t>
+                        <a:t>9</a:t>
                       </a:r>
                     </a:p>
                   </a:txBody>
@@ -20275,7 +20275,7 @@
                           </a:solidFill>
                           <a:latin typeface="+mn-lt"/>
                         </a:rPr>
-                        <a:t>7.285</a:t>
+                        <a:t>0</a:t>
                       </a:r>
                     </a:p>
                   </a:txBody>
@@ -20320,7 +20320,7 @@
                           </a:solidFill>
                           <a:latin typeface="+mn-lt"/>
                         </a:rPr>
-                        <a:t>7.338</a:t>
+                        <a:t>77</a:t>
                       </a:r>
                     </a:p>
                   </a:txBody>
@@ -20365,7 +20365,7 @@
                           </a:solidFill>
                           <a:latin typeface="+mn-lt"/>
                         </a:rPr>
-                        <a:t>53</a:t>
+                        <a:t>77</a:t>
                       </a:r>
                     </a:p>
                   </a:txBody>
@@ -20449,7 +20449,7 @@
                           </a:solidFill>
                           <a:latin typeface="+mn-lt"/>
                         </a:rPr>
-                        <a:t>2.418</a:t>
+                        <a:t>0</a:t>
                       </a:r>
                     </a:p>
                   </a:txBody>
@@ -20494,7 +20494,7 @@
                           </a:solidFill>
                           <a:latin typeface="+mn-lt"/>
                         </a:rPr>
-                        <a:t>2.888</a:t>
+                        <a:t>26</a:t>
                       </a:r>
                     </a:p>
                   </a:txBody>
@@ -20539,7 +20539,7 @@
                           </a:solidFill>
                           <a:latin typeface="+mn-lt"/>
                         </a:rPr>
-                        <a:t>470</a:t>
+                        <a:t>26</a:t>
                       </a:r>
                     </a:p>
                   </a:txBody>
@@ -20623,7 +20623,7 @@
                           </a:solidFill>
                           <a:latin typeface="+mn-lt"/>
                         </a:rPr>
-                        <a:t>9.703</a:t>
+                        <a:t>0</a:t>
                       </a:r>
                     </a:p>
                   </a:txBody>
@@ -20668,7 +20668,7 @@
                           </a:solidFill>
                           <a:latin typeface="+mn-lt"/>
                         </a:rPr>
-                        <a:t>10.226</a:t>
+                        <a:t>102</a:t>
                       </a:r>
                     </a:p>
                   </a:txBody>
@@ -20713,7 +20713,7 @@
                           </a:solidFill>
                           <a:latin typeface="+mn-lt"/>
                         </a:rPr>
-                        <a:t>523</a:t>
+                        <a:t>102</a:t>
                       </a:r>
                     </a:p>
                   </a:txBody>
@@ -20768,7 +20768,7 @@
                           </a:solidFill>
                           <a:latin typeface="+mn-lt"/>
                         </a:rPr>
-                        <a:t>Meio Ambiente</a:t>
+                        <a:t>TI</a:t>
                       </a:r>
                     </a:p>
                   </a:txBody>
@@ -20855,7 +20855,7 @@
                           </a:solidFill>
                           <a:latin typeface="+mn-lt"/>
                         </a:rPr>
-                        <a:t>788</a:t>
+                        <a:t>2.891</a:t>
                       </a:r>
                     </a:p>
                   </a:txBody>
@@ -20900,7 +20900,7 @@
                           </a:solidFill>
                           <a:latin typeface="+mn-lt"/>
                         </a:rPr>
-                        <a:t>655</a:t>
+                        <a:t>3.484</a:t>
                       </a:r>
                     </a:p>
                   </a:txBody>
@@ -20941,11 +20941,11 @@
                       <a:r>
                         <a:rPr lang="pt-BR" sz="1000" b="1" noProof="0" dirty="0">
                           <a:solidFill>
-                            <a:srgbClr val="00803C"/>
+                            <a:srgbClr val="C00000"/>
                           </a:solidFill>
                           <a:latin typeface="+mn-lt"/>
                         </a:rPr>
-                        <a:t>-134</a:t>
+                        <a:t>592</a:t>
                       </a:r>
                     </a:p>
                   </a:txBody>
@@ -21029,7 +21029,7 @@
                           </a:solidFill>
                           <a:latin typeface="+mn-lt"/>
                         </a:rPr>
-                        <a:t>5.088</a:t>
+                        <a:t>12.778</a:t>
                       </a:r>
                     </a:p>
                   </a:txBody>
@@ -21074,7 +21074,7 @@
                           </a:solidFill>
                           <a:latin typeface="+mn-lt"/>
                         </a:rPr>
-                        <a:t>4.192</a:t>
+                        <a:t>13.237</a:t>
                       </a:r>
                     </a:p>
                   </a:txBody>
@@ -21115,11 +21115,11 @@
                       <a:r>
                         <a:rPr lang="pt-BR" sz="1000" b="1" noProof="0" dirty="0">
                           <a:solidFill>
-                            <a:srgbClr val="00803C"/>
+                            <a:srgbClr val="C00000"/>
                           </a:solidFill>
                           <a:latin typeface="+mn-lt"/>
                         </a:rPr>
-                        <a:t>-895</a:t>
+                        <a:t>459</a:t>
                       </a:r>
                     </a:p>
                   </a:txBody>
@@ -21203,7 +21203,7 @@
                           </a:solidFill>
                           <a:latin typeface="+mn-lt"/>
                         </a:rPr>
-                        <a:t>1.693</a:t>
+                        <a:t>5.761</a:t>
                       </a:r>
                     </a:p>
                   </a:txBody>
@@ -21248,7 +21248,7 @@
                           </a:solidFill>
                           <a:latin typeface="+mn-lt"/>
                         </a:rPr>
-                        <a:t>2.396</a:t>
+                        <a:t>5.302</a:t>
                       </a:r>
                     </a:p>
                   </a:txBody>
@@ -21289,11 +21289,11 @@
                       <a:r>
                         <a:rPr lang="pt-BR" sz="1000" b="1" noProof="0" dirty="0">
                           <a:solidFill>
-                            <a:srgbClr val="C00000"/>
+                            <a:srgbClr val="00803C"/>
                           </a:solidFill>
                           <a:latin typeface="+mn-lt"/>
                         </a:rPr>
-                        <a:t>703</a:t>
+                        <a:t>-458</a:t>
                       </a:r>
                     </a:p>
                   </a:txBody>
@@ -21377,7 +21377,7 @@
                           </a:solidFill>
                           <a:latin typeface="+mn-lt"/>
                         </a:rPr>
-                        <a:t>6.781</a:t>
+                        <a:t>18.539</a:t>
                       </a:r>
                     </a:p>
                   </a:txBody>
@@ -21422,7 +21422,7 @@
                           </a:solidFill>
                           <a:latin typeface="+mn-lt"/>
                         </a:rPr>
-                        <a:t>6.589</a:t>
+                        <a:t>18.540</a:t>
                       </a:r>
                     </a:p>
                   </a:txBody>
@@ -21463,11 +21463,11 @@
                       <a:r>
                         <a:rPr lang="pt-BR" sz="1000" b="1" noProof="0" dirty="0">
                           <a:solidFill>
-                            <a:srgbClr val="00803C"/>
+                            <a:srgbClr val="C00000"/>
                           </a:solidFill>
                           <a:latin typeface="+mn-lt"/>
                         </a:rPr>
-                        <a:t>-192</a:t>
+                        <a:t>1</a:t>
                       </a:r>
                     </a:p>
                   </a:txBody>
@@ -22276,7 +22276,7 @@
                           </a:solidFill>
                           <a:latin typeface="+mn-lt"/>
                         </a:rPr>
-                        <a:t>Viagens</a:t>
+                        <a:t>Marketing</a:t>
                       </a:r>
                     </a:p>
                   </a:txBody>
@@ -22363,7 +22363,7 @@
                           </a:solidFill>
                           <a:latin typeface="+mn-lt"/>
                         </a:rPr>
-                        <a:t>234</a:t>
+                        <a:t>180</a:t>
                       </a:r>
                     </a:p>
                   </a:txBody>
@@ -22408,7 +22408,7 @@
                           </a:solidFill>
                           <a:latin typeface="+mn-lt"/>
                         </a:rPr>
-                        <a:t>106</a:t>
+                        <a:t>150</a:t>
                       </a:r>
                     </a:p>
                   </a:txBody>
@@ -22453,7 +22453,7 @@
                           </a:solidFill>
                           <a:latin typeface="+mn-lt"/>
                         </a:rPr>
-                        <a:t>-128</a:t>
+                        <a:t>-30</a:t>
                       </a:r>
                     </a:p>
                   </a:txBody>
@@ -22537,7 +22537,7 @@
                           </a:solidFill>
                           <a:latin typeface="+mn-lt"/>
                         </a:rPr>
-                        <a:t>2.012</a:t>
+                        <a:t>1.815</a:t>
                       </a:r>
                     </a:p>
                   </a:txBody>
@@ -22582,7 +22582,7 @@
                           </a:solidFill>
                           <a:latin typeface="+mn-lt"/>
                         </a:rPr>
-                        <a:t>1.185</a:t>
+                        <a:t>1.192</a:t>
                       </a:r>
                     </a:p>
                   </a:txBody>
@@ -22627,7 +22627,7 @@
                           </a:solidFill>
                           <a:latin typeface="+mn-lt"/>
                         </a:rPr>
-                        <a:t>-827</a:t>
+                        <a:t>-623</a:t>
                       </a:r>
                     </a:p>
                   </a:txBody>
@@ -22711,7 +22711,7 @@
                           </a:solidFill>
                           <a:latin typeface="+mn-lt"/>
                         </a:rPr>
-                        <a:t>643</a:t>
+                        <a:t>824</a:t>
                       </a:r>
                     </a:p>
                   </a:txBody>
@@ -22756,7 +22756,7 @@
                           </a:solidFill>
                           <a:latin typeface="+mn-lt"/>
                         </a:rPr>
-                        <a:t>924</a:t>
+                        <a:t>1.347</a:t>
                       </a:r>
                     </a:p>
                   </a:txBody>
@@ -22801,7 +22801,7 @@
                           </a:solidFill>
                           <a:latin typeface="+mn-lt"/>
                         </a:rPr>
-                        <a:t>281</a:t>
+                        <a:t>523</a:t>
                       </a:r>
                     </a:p>
                   </a:txBody>
@@ -22885,7 +22885,7 @@
                           </a:solidFill>
                           <a:latin typeface="+mn-lt"/>
                         </a:rPr>
-                        <a:t>2.655</a:t>
+                        <a:t>2.640</a:t>
                       </a:r>
                     </a:p>
                   </a:txBody>
@@ -22930,7 +22930,7 @@
                           </a:solidFill>
                           <a:latin typeface="+mn-lt"/>
                         </a:rPr>
-                        <a:t>2.108</a:t>
+                        <a:t>2.540</a:t>
                       </a:r>
                     </a:p>
                   </a:txBody>
@@ -22975,7 +22975,7 @@
                           </a:solidFill>
                           <a:latin typeface="+mn-lt"/>
                         </a:rPr>
-                        <a:t>-546</a:t>
+                        <a:t>-100</a:t>
                       </a:r>
                     </a:p>
                   </a:txBody>
@@ -23030,7 +23030,7 @@
                           </a:solidFill>
                           <a:latin typeface="+mn-lt"/>
                         </a:rPr>
-                        <a:t>Marketing</a:t>
+                        <a:t>Meio Ambiente</a:t>
                       </a:r>
                     </a:p>
                   </a:txBody>
@@ -23117,7 +23117,7 @@
                           </a:solidFill>
                           <a:latin typeface="+mn-lt"/>
                         </a:rPr>
-                        <a:t>180</a:t>
+                        <a:t>788</a:t>
                       </a:r>
                     </a:p>
                   </a:txBody>
@@ -23162,7 +23162,7 @@
                           </a:solidFill>
                           <a:latin typeface="+mn-lt"/>
                         </a:rPr>
-                        <a:t>150</a:t>
+                        <a:t>655</a:t>
                       </a:r>
                     </a:p>
                   </a:txBody>
@@ -23207,7 +23207,7 @@
                           </a:solidFill>
                           <a:latin typeface="+mn-lt"/>
                         </a:rPr>
-                        <a:t>-30</a:t>
+                        <a:t>-134</a:t>
                       </a:r>
                     </a:p>
                   </a:txBody>
@@ -23291,7 +23291,7 @@
                           </a:solidFill>
                           <a:latin typeface="+mn-lt"/>
                         </a:rPr>
-                        <a:t>1.815</a:t>
+                        <a:t>5.088</a:t>
                       </a:r>
                     </a:p>
                   </a:txBody>
@@ -23336,7 +23336,7 @@
                           </a:solidFill>
                           <a:latin typeface="+mn-lt"/>
                         </a:rPr>
-                        <a:t>1.192</a:t>
+                        <a:t>4.192</a:t>
                       </a:r>
                     </a:p>
                   </a:txBody>
@@ -23381,7 +23381,7 @@
                           </a:solidFill>
                           <a:latin typeface="+mn-lt"/>
                         </a:rPr>
-                        <a:t>-623</a:t>
+                        <a:t>-895</a:t>
                       </a:r>
                     </a:p>
                   </a:txBody>
@@ -23465,7 +23465,7 @@
                           </a:solidFill>
                           <a:latin typeface="+mn-lt"/>
                         </a:rPr>
-                        <a:t>824</a:t>
+                        <a:t>1.693</a:t>
                       </a:r>
                     </a:p>
                   </a:txBody>
@@ -23510,7 +23510,7 @@
                           </a:solidFill>
                           <a:latin typeface="+mn-lt"/>
                         </a:rPr>
-                        <a:t>1.347</a:t>
+                        <a:t>2.396</a:t>
                       </a:r>
                     </a:p>
                   </a:txBody>
@@ -23555,7 +23555,7 @@
                           </a:solidFill>
                           <a:latin typeface="+mn-lt"/>
                         </a:rPr>
-                        <a:t>523</a:t>
+                        <a:t>703</a:t>
                       </a:r>
                     </a:p>
                   </a:txBody>
@@ -23639,7 +23639,7 @@
                           </a:solidFill>
                           <a:latin typeface="+mn-lt"/>
                         </a:rPr>
-                        <a:t>2.640</a:t>
+                        <a:t>6.781</a:t>
                       </a:r>
                     </a:p>
                   </a:txBody>
@@ -23684,7 +23684,7 @@
                           </a:solidFill>
                           <a:latin typeface="+mn-lt"/>
                         </a:rPr>
-                        <a:t>2.540</a:t>
+                        <a:t>6.589</a:t>
                       </a:r>
                     </a:p>
                   </a:txBody>
@@ -23729,7 +23729,7 @@
                           </a:solidFill>
                           <a:latin typeface="+mn-lt"/>
                         </a:rPr>
-                        <a:t>-100</a:t>
+                        <a:t>-192</a:t>
                       </a:r>
                     </a:p>
                   </a:txBody>
@@ -24538,7 +24538,7 @@
                           </a:solidFill>
                           <a:latin typeface="+mn-lt"/>
                         </a:rPr>
-                        <a:t>Logística</a:t>
+                        <a:t>Viagens</a:t>
                       </a:r>
                     </a:p>
                   </a:txBody>
@@ -24625,7 +24625,7 @@
                           </a:solidFill>
                           <a:latin typeface="+mn-lt"/>
                         </a:rPr>
-                        <a:t>28</a:t>
+                        <a:t>234</a:t>
                       </a:r>
                     </a:p>
                   </a:txBody>
@@ -24670,7 +24670,7 @@
                           </a:solidFill>
                           <a:latin typeface="+mn-lt"/>
                         </a:rPr>
-                        <a:t>915</a:t>
+                        <a:t>106</a:t>
                       </a:r>
                     </a:p>
                   </a:txBody>
@@ -24711,11 +24711,11 @@
                       <a:r>
                         <a:rPr lang="pt-BR" sz="1000" b="1" noProof="0" dirty="0">
                           <a:solidFill>
-                            <a:srgbClr val="C00000"/>
+                            <a:srgbClr val="00803C"/>
                           </a:solidFill>
                           <a:latin typeface="+mn-lt"/>
                         </a:rPr>
-                        <a:t>887</a:t>
+                        <a:t>-128</a:t>
                       </a:r>
                     </a:p>
                   </a:txBody>
@@ -24799,7 +24799,7 @@
                           </a:solidFill>
                           <a:latin typeface="+mn-lt"/>
                         </a:rPr>
-                        <a:t>963</a:t>
+                        <a:t>2.012</a:t>
                       </a:r>
                     </a:p>
                   </a:txBody>
@@ -24844,7 +24844,7 @@
                           </a:solidFill>
                           <a:latin typeface="+mn-lt"/>
                         </a:rPr>
-                        <a:t>5.660</a:t>
+                        <a:t>1.185</a:t>
                       </a:r>
                     </a:p>
                   </a:txBody>
@@ -24885,11 +24885,11 @@
                       <a:r>
                         <a:rPr lang="pt-BR" sz="1000" b="1" noProof="0" dirty="0">
                           <a:solidFill>
-                            <a:srgbClr val="C00000"/>
+                            <a:srgbClr val="00803C"/>
                           </a:solidFill>
                           <a:latin typeface="+mn-lt"/>
                         </a:rPr>
-                        <a:t>4.697</a:t>
+                        <a:t>-827</a:t>
                       </a:r>
                     </a:p>
                   </a:txBody>
@@ -24973,7 +24973,7 @@
                           </a:solidFill>
                           <a:latin typeface="+mn-lt"/>
                         </a:rPr>
-                        <a:t>85</a:t>
+                        <a:t>643</a:t>
                       </a:r>
                     </a:p>
                   </a:txBody>
@@ -25018,7 +25018,7 @@
                           </a:solidFill>
                           <a:latin typeface="+mn-lt"/>
                         </a:rPr>
-                        <a:t>860</a:t>
+                        <a:t>924</a:t>
                       </a:r>
                     </a:p>
                   </a:txBody>
@@ -25063,7 +25063,7 @@
                           </a:solidFill>
                           <a:latin typeface="+mn-lt"/>
                         </a:rPr>
-                        <a:t>774</a:t>
+                        <a:t>281</a:t>
                       </a:r>
                     </a:p>
                   </a:txBody>
@@ -25147,7 +25147,7 @@
                           </a:solidFill>
                           <a:latin typeface="+mn-lt"/>
                         </a:rPr>
-                        <a:t>1.048</a:t>
+                        <a:t>2.655</a:t>
                       </a:r>
                     </a:p>
                   </a:txBody>
@@ -25192,7 +25192,7 @@
                           </a:solidFill>
                           <a:latin typeface="+mn-lt"/>
                         </a:rPr>
-                        <a:t>6.519</a:t>
+                        <a:t>2.108</a:t>
                       </a:r>
                     </a:p>
                   </a:txBody>
@@ -25233,11 +25233,11 @@
                       <a:r>
                         <a:rPr lang="pt-BR" sz="1000" b="1" noProof="0" dirty="0">
                           <a:solidFill>
-                            <a:srgbClr val="C00000"/>
+                            <a:srgbClr val="00803C"/>
                           </a:solidFill>
                           <a:latin typeface="+mn-lt"/>
                         </a:rPr>
-                        <a:t>5.471</a:t>
+                        <a:t>-546</a:t>
                       </a:r>
                     </a:p>
                   </a:txBody>
@@ -25292,7 +25292,7 @@
                           </a:solidFill>
                           <a:latin typeface="+mn-lt"/>
                         </a:rPr>
-                        <a:t>Não Recorrente</a:t>
+                        <a:t>Consultoria e Serv. Legais/Fin.</a:t>
                       </a:r>
                     </a:p>
                   </a:txBody>
@@ -25379,7 +25379,7 @@
                           </a:solidFill>
                           <a:latin typeface="+mn-lt"/>
                         </a:rPr>
-                        <a:t>0</a:t>
+                        <a:t>2.628</a:t>
                       </a:r>
                     </a:p>
                   </a:txBody>
@@ -25424,7 +25424,7 @@
                           </a:solidFill>
                           <a:latin typeface="+mn-lt"/>
                         </a:rPr>
-                        <a:t>0</a:t>
+                        <a:t>3.976</a:t>
                       </a:r>
                     </a:p>
                   </a:txBody>
@@ -25465,11 +25465,11 @@
                       <a:r>
                         <a:rPr lang="pt-BR" sz="1000" b="1" noProof="0" dirty="0">
                           <a:solidFill>
-                            <a:srgbClr val="00803C"/>
+                            <a:srgbClr val="C00000"/>
                           </a:solidFill>
                           <a:latin typeface="+mn-lt"/>
                         </a:rPr>
-                        <a:t>0</a:t>
+                        <a:t>1.348</a:t>
                       </a:r>
                     </a:p>
                   </a:txBody>
@@ -25553,7 +25553,7 @@
                           </a:solidFill>
                           <a:latin typeface="+mn-lt"/>
                         </a:rPr>
-                        <a:t>75</a:t>
+                        <a:t>25.286</a:t>
                       </a:r>
                     </a:p>
                   </a:txBody>
@@ -25598,7 +25598,7 @@
                           </a:solidFill>
                           <a:latin typeface="+mn-lt"/>
                         </a:rPr>
-                        <a:t>0</a:t>
+                        <a:t>22.928</a:t>
                       </a:r>
                     </a:p>
                   </a:txBody>
@@ -25643,7 +25643,7 @@
                           </a:solidFill>
                           <a:latin typeface="+mn-lt"/>
                         </a:rPr>
-                        <a:t>-75</a:t>
+                        <a:t>-2.359</a:t>
                       </a:r>
                     </a:p>
                   </a:txBody>
@@ -25727,7 +25727,7 @@
                           </a:solidFill>
                           <a:latin typeface="+mn-lt"/>
                         </a:rPr>
-                        <a:t>0</a:t>
+                        <a:t>8.805</a:t>
                       </a:r>
                     </a:p>
                   </a:txBody>
@@ -25772,7 +25772,7 @@
                           </a:solidFill>
                           <a:latin typeface="+mn-lt"/>
                         </a:rPr>
-                        <a:t>3.377</a:t>
+                        <a:t>10.223</a:t>
                       </a:r>
                     </a:p>
                   </a:txBody>
@@ -25817,7 +25817,7 @@
                           </a:solidFill>
                           <a:latin typeface="+mn-lt"/>
                         </a:rPr>
-                        <a:t>3.377</a:t>
+                        <a:t>1.419</a:t>
                       </a:r>
                     </a:p>
                   </a:txBody>
@@ -25901,7 +25901,7 @@
                           </a:solidFill>
                           <a:latin typeface="+mn-lt"/>
                         </a:rPr>
-                        <a:t>75</a:t>
+                        <a:t>34.091</a:t>
                       </a:r>
                     </a:p>
                   </a:txBody>
@@ -25946,7 +25946,7 @@
                           </a:solidFill>
                           <a:latin typeface="+mn-lt"/>
                         </a:rPr>
-                        <a:t>3.377</a:t>
+                        <a:t>33.151</a:t>
                       </a:r>
                     </a:p>
                   </a:txBody>
@@ -25987,11 +25987,11 @@
                       <a:r>
                         <a:rPr lang="pt-BR" sz="1000" b="1" noProof="0" dirty="0">
                           <a:solidFill>
-                            <a:srgbClr val="C00000"/>
+                            <a:srgbClr val="00803C"/>
                           </a:solidFill>
                           <a:latin typeface="+mn-lt"/>
                         </a:rPr>
-                        <a:t>3.302</a:t>
+                        <a:t>-940</a:t>
                       </a:r>
                     </a:p>
                   </a:txBody>
@@ -26046,7 +26046,7 @@
                           </a:solidFill>
                           <a:latin typeface="+mn-lt"/>
                         </a:rPr>
-                        <a:t>Custos Capt. Financeira</a:t>
+                        <a:t>Pessoal</a:t>
                       </a:r>
                     </a:p>
                   </a:txBody>
@@ -26143,7 +26143,7 @@
                           </a:solidFill>
                           <a:latin typeface="+mn-lt"/>
                         </a:rPr>
-                        <a:t>0</a:t>
+                        <a:t>8.868</a:t>
                       </a:r>
                     </a:p>
                   </a:txBody>
@@ -26193,7 +26193,7 @@
                           </a:solidFill>
                           <a:latin typeface="+mn-lt"/>
                         </a:rPr>
-                        <a:t>9</a:t>
+                        <a:t>8.480</a:t>
                       </a:r>
                     </a:p>
                   </a:txBody>
@@ -26239,11 +26239,11 @@
                       <a:r>
                         <a:rPr lang="pt-BR" sz="1000" b="1" noProof="0" dirty="0">
                           <a:solidFill>
-                            <a:srgbClr val="C00000"/>
+                            <a:srgbClr val="00803C"/>
                           </a:solidFill>
                           <a:latin typeface="+mn-lt"/>
                         </a:rPr>
-                        <a:t>9</a:t>
+                        <a:t>-388</a:t>
                       </a:r>
                     </a:p>
                   </a:txBody>
@@ -26337,7 +26337,7 @@
                           </a:solidFill>
                           <a:latin typeface="+mn-lt"/>
                         </a:rPr>
-                        <a:t>0</a:t>
+                        <a:t>77.351</a:t>
                       </a:r>
                     </a:p>
                   </a:txBody>
@@ -26387,7 +26387,7 @@
                           </a:solidFill>
                           <a:latin typeface="+mn-lt"/>
                         </a:rPr>
-                        <a:t>77</a:t>
+                        <a:t>74.198</a:t>
                       </a:r>
                     </a:p>
                   </a:txBody>
@@ -26433,11 +26433,11 @@
                       <a:r>
                         <a:rPr lang="pt-BR" sz="1000" b="1" noProof="0" dirty="0">
                           <a:solidFill>
-                            <a:srgbClr val="C00000"/>
+                            <a:srgbClr val="00803C"/>
                           </a:solidFill>
                           <a:latin typeface="+mn-lt"/>
                         </a:rPr>
-                        <a:t>77</a:t>
+                        <a:t>-3.153</a:t>
                       </a:r>
                     </a:p>
                   </a:txBody>
@@ -26531,7 +26531,7 @@
                           </a:solidFill>
                           <a:latin typeface="+mn-lt"/>
                         </a:rPr>
-                        <a:t>0</a:t>
+                        <a:t>26.630</a:t>
                       </a:r>
                     </a:p>
                   </a:txBody>
@@ -26581,7 +26581,7 @@
                           </a:solidFill>
                           <a:latin typeface="+mn-lt"/>
                         </a:rPr>
-                        <a:t>26</a:t>
+                        <a:t>26.737</a:t>
                       </a:r>
                     </a:p>
                   </a:txBody>
@@ -26631,7 +26631,7 @@
                           </a:solidFill>
                           <a:latin typeface="+mn-lt"/>
                         </a:rPr>
-                        <a:t>26</a:t>
+                        <a:t>107</a:t>
                       </a:r>
                     </a:p>
                   </a:txBody>
@@ -26725,7 +26725,7 @@
                           </a:solidFill>
                           <a:latin typeface="+mn-lt"/>
                         </a:rPr>
-                        <a:t>0</a:t>
+                        <a:t>103.981</a:t>
                       </a:r>
                     </a:p>
                   </a:txBody>
@@ -26775,7 +26775,7 @@
                           </a:solidFill>
                           <a:latin typeface="+mn-lt"/>
                         </a:rPr>
-                        <a:t>102</a:t>
+                        <a:t>100.934</a:t>
                       </a:r>
                     </a:p>
                   </a:txBody>
@@ -26821,11 +26821,11 @@
                       <a:r>
                         <a:rPr lang="pt-BR" sz="1000" b="1" noProof="0" dirty="0">
                           <a:solidFill>
-                            <a:srgbClr val="C00000"/>
+                            <a:srgbClr val="00803C"/>
                           </a:solidFill>
                           <a:latin typeface="+mn-lt"/>
                         </a:rPr>
-                        <a:t>102</a:t>
+                        <a:t>-3.046</a:t>
                       </a:r>
                     </a:p>
                   </a:txBody>
@@ -29103,7 +29103,7 @@
                           </a:solidFill>
                           <a:latin typeface="+mn-lt"/>
                         </a:rPr>
-                        <a:t>COO – Operações e Segurança</a:t>
+                        <a:t>VGS – Suprimento e Serviços</a:t>
                       </a:r>
                     </a:p>
                   </a:txBody>
@@ -29200,7 +29200,7 @@
                           </a:solidFill>
                           <a:latin typeface="+mn-lt"/>
                         </a:rPr>
-                        <a:t>14.178</a:t>
+                        <a:t>2.470</a:t>
                       </a:r>
                     </a:p>
                   </a:txBody>
@@ -29250,7 +29250,7 @@
                           </a:solidFill>
                           <a:latin typeface="+mn-lt"/>
                         </a:rPr>
-                        <a:t>14.262</a:t>
+                        <a:t>2.933</a:t>
                       </a:r>
                     </a:p>
                   </a:txBody>
@@ -29300,7 +29300,7 @@
                           </a:solidFill>
                           <a:latin typeface="+mn-lt"/>
                         </a:rPr>
-                        <a:t>85</a:t>
+                        <a:t>463</a:t>
                       </a:r>
                     </a:p>
                   </a:txBody>
@@ -29394,7 +29394,7 @@
                           </a:solidFill>
                           <a:latin typeface="+mn-lt"/>
                         </a:rPr>
-                        <a:t>107.652</a:t>
+                        <a:t>21.360</a:t>
                       </a:r>
                     </a:p>
                   </a:txBody>
@@ -29444,7 +29444,7 @@
                           </a:solidFill>
                           <a:latin typeface="+mn-lt"/>
                         </a:rPr>
-                        <a:t>101.790</a:t>
+                        <a:t>25.608</a:t>
                       </a:r>
                     </a:p>
                   </a:txBody>
@@ -29490,11 +29490,11 @@
                       <a:r>
                         <a:rPr lang="pt-BR" sz="1100" b="1" noProof="0" dirty="0">
                           <a:solidFill>
-                            <a:srgbClr val="00803C"/>
+                            <a:srgbClr val="C00000"/>
                           </a:solidFill>
                           <a:latin typeface="+mn-lt"/>
                         </a:rPr>
-                        <a:t>-5.862</a:t>
+                        <a:t>4.247</a:t>
                       </a:r>
                     </a:p>
                   </a:txBody>
@@ -29588,7 +29588,7 @@
                           </a:solidFill>
                           <a:latin typeface="+mn-lt"/>
                         </a:rPr>
-                        <a:t>42.408</a:t>
+                        <a:t>7.034</a:t>
                       </a:r>
                     </a:p>
                   </a:txBody>
@@ -29638,7 +29638,7 @@
                           </a:solidFill>
                           <a:latin typeface="+mn-lt"/>
                         </a:rPr>
-                        <a:t>47.692</a:t>
+                        <a:t>8.799</a:t>
                       </a:r>
                     </a:p>
                   </a:txBody>
@@ -29688,7 +29688,7 @@
                           </a:solidFill>
                           <a:latin typeface="+mn-lt"/>
                         </a:rPr>
-                        <a:t>5.284</a:t>
+                        <a:t>1.765</a:t>
                       </a:r>
                     </a:p>
                   </a:txBody>
@@ -29782,7 +29782,7 @@
                           </a:solidFill>
                           <a:latin typeface="+mn-lt"/>
                         </a:rPr>
-                        <a:t>150.060</a:t>
+                        <a:t>28.394</a:t>
                       </a:r>
                     </a:p>
                   </a:txBody>
@@ -29832,7 +29832,7 @@
                           </a:solidFill>
                           <a:latin typeface="+mn-lt"/>
                         </a:rPr>
-                        <a:t>149.482</a:t>
+                        <a:t>34.407</a:t>
                       </a:r>
                     </a:p>
                   </a:txBody>
@@ -29878,11 +29878,11 @@
                       <a:r>
                         <a:rPr lang="pt-BR" sz="1100" b="1" noProof="0" dirty="0">
                           <a:solidFill>
-                            <a:srgbClr val="00803C"/>
+                            <a:srgbClr val="C00000"/>
                           </a:solidFill>
                           <a:latin typeface="+mn-lt"/>
                         </a:rPr>
-                        <a:t>-578</a:t>
+                        <a:t>6.012</a:t>
                       </a:r>
                     </a:p>
                   </a:txBody>
@@ -29942,7 +29942,7 @@
                           </a:solidFill>
                           <a:latin typeface="+mn-lt"/>
                         </a:rPr>
-                        <a:t>VGS – Suprimento e Serviços</a:t>
+                        <a:t>VGR – Governança e Sustent.</a:t>
                       </a:r>
                     </a:p>
                   </a:txBody>
@@ -30029,7 +30029,7 @@
                           </a:solidFill>
                           <a:latin typeface="+mn-lt"/>
                         </a:rPr>
-                        <a:t>2.470</a:t>
+                        <a:t>1.648</a:t>
                       </a:r>
                     </a:p>
                   </a:txBody>
@@ -30074,7 +30074,7 @@
                           </a:solidFill>
                           <a:latin typeface="+mn-lt"/>
                         </a:rPr>
-                        <a:t>2.933</a:t>
+                        <a:t>1.191</a:t>
                       </a:r>
                     </a:p>
                   </a:txBody>
@@ -30115,11 +30115,11 @@
                       <a:r>
                         <a:rPr lang="pt-BR" sz="1100" b="1" noProof="0" dirty="0">
                           <a:solidFill>
-                            <a:srgbClr val="C00000"/>
+                            <a:srgbClr val="00803C"/>
                           </a:solidFill>
                           <a:latin typeface="+mn-lt"/>
                         </a:rPr>
-                        <a:t>463</a:t>
+                        <a:t>-456</a:t>
                       </a:r>
                     </a:p>
                   </a:txBody>
@@ -30203,7 +30203,7 @@
                           </a:solidFill>
                           <a:latin typeface="+mn-lt"/>
                         </a:rPr>
-                        <a:t>21.360</a:t>
+                        <a:t>12.838</a:t>
                       </a:r>
                     </a:p>
                   </a:txBody>
@@ -30248,7 +30248,7 @@
                           </a:solidFill>
                           <a:latin typeface="+mn-lt"/>
                         </a:rPr>
-                        <a:t>25.608</a:t>
+                        <a:t>10.365</a:t>
                       </a:r>
                     </a:p>
                   </a:txBody>
@@ -30289,11 +30289,11 @@
                       <a:r>
                         <a:rPr lang="pt-BR" sz="1100" b="1" noProof="0" dirty="0">
                           <a:solidFill>
-                            <a:srgbClr val="C00000"/>
+                            <a:srgbClr val="00803C"/>
                           </a:solidFill>
                           <a:latin typeface="+mn-lt"/>
                         </a:rPr>
-                        <a:t>4.247</a:t>
+                        <a:t>-2.473</a:t>
                       </a:r>
                     </a:p>
                   </a:txBody>
@@ -30377,7 +30377,7 @@
                           </a:solidFill>
                           <a:latin typeface="+mn-lt"/>
                         </a:rPr>
-                        <a:t>7.034</a:t>
+                        <a:t>4.461</a:t>
                       </a:r>
                     </a:p>
                   </a:txBody>
@@ -30422,7 +30422,7 @@
                           </a:solidFill>
                           <a:latin typeface="+mn-lt"/>
                         </a:rPr>
-                        <a:t>8.799</a:t>
+                        <a:t>8.716</a:t>
                       </a:r>
                     </a:p>
                   </a:txBody>
@@ -30467,7 +30467,7 @@
                           </a:solidFill>
                           <a:latin typeface="+mn-lt"/>
                         </a:rPr>
-                        <a:t>1.765</a:t>
+                        <a:t>4.255</a:t>
                       </a:r>
                     </a:p>
                   </a:txBody>
@@ -30551,7 +30551,7 @@
                           </a:solidFill>
                           <a:latin typeface="+mn-lt"/>
                         </a:rPr>
-                        <a:t>28.394</a:t>
+                        <a:t>17.299</a:t>
                       </a:r>
                     </a:p>
                   </a:txBody>
@@ -30596,7 +30596,7 @@
                           </a:solidFill>
                           <a:latin typeface="+mn-lt"/>
                         </a:rPr>
-                        <a:t>34.407</a:t>
+                        <a:t>19.081</a:t>
                       </a:r>
                     </a:p>
                   </a:txBody>
@@ -30641,7 +30641,7 @@
                           </a:solidFill>
                           <a:latin typeface="+mn-lt"/>
                         </a:rPr>
-                        <a:t>6.012</a:t>
+                        <a:t>1.781</a:t>
                       </a:r>
                     </a:p>
                   </a:txBody>
@@ -30696,7 +30696,7 @@
                           </a:solidFill>
                           <a:latin typeface="+mn-lt"/>
                         </a:rPr>
-                        <a:t>VFR – Financeiro e RI</a:t>
+                        <a:t>VGC – Gente, Gestão e Cultura</a:t>
                       </a:r>
                     </a:p>
                   </a:txBody>
@@ -30783,7 +30783,7 @@
                           </a:solidFill>
                           <a:latin typeface="+mn-lt"/>
                         </a:rPr>
-                        <a:t>1.936</a:t>
+                        <a:t>615</a:t>
                       </a:r>
                     </a:p>
                   </a:txBody>
@@ -30828,7 +30828,7 @@
                           </a:solidFill>
                           <a:latin typeface="+mn-lt"/>
                         </a:rPr>
-                        <a:t>2.227</a:t>
+                        <a:t>599</a:t>
                       </a:r>
                     </a:p>
                   </a:txBody>
@@ -30869,11 +30869,11 @@
                       <a:r>
                         <a:rPr lang="pt-BR" sz="1100" b="1" noProof="0" dirty="0">
                           <a:solidFill>
-                            <a:srgbClr val="C00000"/>
+                            <a:srgbClr val="00803C"/>
                           </a:solidFill>
                           <a:latin typeface="+mn-lt"/>
                         </a:rPr>
-                        <a:t>291</a:t>
+                        <a:t>-16</a:t>
                       </a:r>
                     </a:p>
                   </a:txBody>
@@ -30957,7 +30957,7 @@
                           </a:solidFill>
                           <a:latin typeface="+mn-lt"/>
                         </a:rPr>
-                        <a:t>16.983</a:t>
+                        <a:t>5.856</a:t>
                       </a:r>
                     </a:p>
                   </a:txBody>
@@ -31002,7 +31002,7 @@
                           </a:solidFill>
                           <a:latin typeface="+mn-lt"/>
                         </a:rPr>
-                        <a:t>16.542</a:t>
+                        <a:t>6.078</a:t>
                       </a:r>
                     </a:p>
                   </a:txBody>
@@ -31043,11 +31043,11 @@
                       <a:r>
                         <a:rPr lang="pt-BR" sz="1100" b="1" noProof="0" dirty="0">
                           <a:solidFill>
-                            <a:srgbClr val="00803C"/>
+                            <a:srgbClr val="C00000"/>
                           </a:solidFill>
                           <a:latin typeface="+mn-lt"/>
                         </a:rPr>
-                        <a:t>-440</a:t>
+                        <a:t>222</a:t>
                       </a:r>
                     </a:p>
                   </a:txBody>
@@ -31131,7 +31131,7 @@
                           </a:solidFill>
                           <a:latin typeface="+mn-lt"/>
                         </a:rPr>
-                        <a:t>6.034</a:t>
+                        <a:t>1.880</a:t>
                       </a:r>
                     </a:p>
                   </a:txBody>
@@ -31176,7 +31176,7 @@
                           </a:solidFill>
                           <a:latin typeface="+mn-lt"/>
                         </a:rPr>
-                        <a:t>5.967</a:t>
+                        <a:t>2.083</a:t>
                       </a:r>
                     </a:p>
                   </a:txBody>
@@ -31217,11 +31217,11 @@
                       <a:r>
                         <a:rPr lang="pt-BR" sz="1100" b="1" noProof="0" dirty="0">
                           <a:solidFill>
-                            <a:srgbClr val="00803C"/>
+                            <a:srgbClr val="C00000"/>
                           </a:solidFill>
                           <a:latin typeface="+mn-lt"/>
                         </a:rPr>
-                        <a:t>-67</a:t>
+                        <a:t>204</a:t>
                       </a:r>
                     </a:p>
                   </a:txBody>
@@ -31305,7 +31305,7 @@
                           </a:solidFill>
                           <a:latin typeface="+mn-lt"/>
                         </a:rPr>
-                        <a:t>23.017</a:t>
+                        <a:t>7.735</a:t>
                       </a:r>
                     </a:p>
                   </a:txBody>
@@ -31350,7 +31350,7 @@
                           </a:solidFill>
                           <a:latin typeface="+mn-lt"/>
                         </a:rPr>
-                        <a:t>22.509</a:t>
+                        <a:t>8.161</a:t>
                       </a:r>
                     </a:p>
                   </a:txBody>
@@ -31391,11 +31391,11 @@
                       <a:r>
                         <a:rPr lang="pt-BR" sz="1100" b="1" noProof="0" dirty="0">
                           <a:solidFill>
-                            <a:srgbClr val="00803C"/>
+                            <a:srgbClr val="C00000"/>
                           </a:solidFill>
                           <a:latin typeface="+mn-lt"/>
                         </a:rPr>
-                        <a:t>-508</a:t>
+                        <a:t>426</a:t>
                       </a:r>
                     </a:p>
                   </a:txBody>
@@ -31450,7 +31450,7 @@
                           </a:solidFill>
                           <a:latin typeface="+mn-lt"/>
                         </a:rPr>
-                        <a:t>VID – Inovação, P&amp;D, Digital e TI</a:t>
+                        <a:t>VEE – Engenharia</a:t>
                       </a:r>
                     </a:p>
                   </a:txBody>
@@ -31537,7 +31537,7 @@
                           </a:solidFill>
                           <a:latin typeface="+mn-lt"/>
                         </a:rPr>
-                        <a:t>3.213</a:t>
+                        <a:t>757</a:t>
                       </a:r>
                     </a:p>
                   </a:txBody>
@@ -31582,7 +31582,7 @@
                           </a:solidFill>
                           <a:latin typeface="+mn-lt"/>
                         </a:rPr>
-                        <a:t>3.757</a:t>
+                        <a:t>1.094</a:t>
                       </a:r>
                     </a:p>
                   </a:txBody>
@@ -31627,7 +31627,7 @@
                           </a:solidFill>
                           <a:latin typeface="+mn-lt"/>
                         </a:rPr>
-                        <a:t>545</a:t>
+                        <a:t>337</a:t>
                       </a:r>
                     </a:p>
                   </a:txBody>
@@ -31711,7 +31711,7 @@
                           </a:solidFill>
                           <a:latin typeface="+mn-lt"/>
                         </a:rPr>
-                        <a:t>15.924</a:t>
+                        <a:t>7.986</a:t>
                       </a:r>
                     </a:p>
                   </a:txBody>
@@ -31756,7 +31756,7 @@
                           </a:solidFill>
                           <a:latin typeface="+mn-lt"/>
                         </a:rPr>
-                        <a:t>15.408</a:t>
+                        <a:t>7.760</a:t>
                       </a:r>
                     </a:p>
                   </a:txBody>
@@ -31801,7 +31801,7 @@
                           </a:solidFill>
                           <a:latin typeface="+mn-lt"/>
                         </a:rPr>
-                        <a:t>-516</a:t>
+                        <a:t>-225</a:t>
                       </a:r>
                     </a:p>
                   </a:txBody>
@@ -31885,7 +31885,7 @@
                           </a:solidFill>
                           <a:latin typeface="+mn-lt"/>
                         </a:rPr>
-                        <a:t>6.774</a:t>
+                        <a:t>2.307</a:t>
                       </a:r>
                     </a:p>
                   </a:txBody>
@@ -31930,7 +31930,7 @@
                           </a:solidFill>
                           <a:latin typeface="+mn-lt"/>
                         </a:rPr>
-                        <a:t>5.996</a:t>
+                        <a:t>2.503</a:t>
                       </a:r>
                     </a:p>
                   </a:txBody>
@@ -31971,11 +31971,11 @@
                       <a:r>
                         <a:rPr lang="pt-BR" sz="1100" b="1" noProof="0" dirty="0">
                           <a:solidFill>
-                            <a:srgbClr val="00803C"/>
+                            <a:srgbClr val="C00000"/>
                           </a:solidFill>
                           <a:latin typeface="+mn-lt"/>
                         </a:rPr>
-                        <a:t>-778</a:t>
+                        <a:t>197</a:t>
                       </a:r>
                     </a:p>
                   </a:txBody>
@@ -32059,7 +32059,7 @@
                           </a:solidFill>
                           <a:latin typeface="+mn-lt"/>
                         </a:rPr>
-                        <a:t>22.698</a:t>
+                        <a:t>10.292</a:t>
                       </a:r>
                     </a:p>
                   </a:txBody>
@@ -32104,7 +32104,7 @@
                           </a:solidFill>
                           <a:latin typeface="+mn-lt"/>
                         </a:rPr>
-                        <a:t>21.404</a:t>
+                        <a:t>10.264</a:t>
                       </a:r>
                     </a:p>
                   </a:txBody>
@@ -32149,7 +32149,7 @@
                           </a:solidFill>
                           <a:latin typeface="+mn-lt"/>
                         </a:rPr>
-                        <a:t>-1.294</a:t>
+                        <a:t>-28</a:t>
                       </a:r>
                     </a:p>
                   </a:txBody>
@@ -32204,7 +32204,7 @@
                           </a:solidFill>
                           <a:latin typeface="+mn-lt"/>
                         </a:rPr>
-                        <a:t>VGR – Governança e Sustent.</a:t>
+                        <a:t>DCO – Comunicação</a:t>
                       </a:r>
                     </a:p>
                   </a:txBody>
@@ -32291,7 +32291,7 @@
                           </a:solidFill>
                           <a:latin typeface="+mn-lt"/>
                         </a:rPr>
-                        <a:t>1.648</a:t>
+                        <a:t>181</a:t>
                       </a:r>
                     </a:p>
                   </a:txBody>
@@ -32336,7 +32336,7 @@
                           </a:solidFill>
                           <a:latin typeface="+mn-lt"/>
                         </a:rPr>
-                        <a:t>1.191</a:t>
+                        <a:t>186</a:t>
                       </a:r>
                     </a:p>
                   </a:txBody>
@@ -32377,11 +32377,11 @@
                       <a:r>
                         <a:rPr lang="pt-BR" sz="1100" b="1" noProof="0" dirty="0">
                           <a:solidFill>
-                            <a:srgbClr val="00803C"/>
+                            <a:srgbClr val="C00000"/>
                           </a:solidFill>
                           <a:latin typeface="+mn-lt"/>
                         </a:rPr>
-                        <a:t>-456</a:t>
+                        <a:t>5</a:t>
                       </a:r>
                     </a:p>
                   </a:txBody>
@@ -32465,7 +32465,7 @@
                           </a:solidFill>
                           <a:latin typeface="+mn-lt"/>
                         </a:rPr>
-                        <a:t>12.838</a:t>
+                        <a:t>1.841</a:t>
                       </a:r>
                     </a:p>
                   </a:txBody>
@@ -32510,7 +32510,7 @@
                           </a:solidFill>
                           <a:latin typeface="+mn-lt"/>
                         </a:rPr>
-                        <a:t>10.365</a:t>
+                        <a:t>1.302</a:t>
                       </a:r>
                     </a:p>
                   </a:txBody>
@@ -32555,7 +32555,7 @@
                           </a:solidFill>
                           <a:latin typeface="+mn-lt"/>
                         </a:rPr>
-                        <a:t>-2.473</a:t>
+                        <a:t>-539</a:t>
                       </a:r>
                     </a:p>
                   </a:txBody>
@@ -32639,7 +32639,7 @@
                           </a:solidFill>
                           <a:latin typeface="+mn-lt"/>
                         </a:rPr>
-                        <a:t>4.461</a:t>
+                        <a:t>786</a:t>
                       </a:r>
                     </a:p>
                   </a:txBody>
@@ -32684,7 +32684,7 @@
                           </a:solidFill>
                           <a:latin typeface="+mn-lt"/>
                         </a:rPr>
-                        <a:t>8.716</a:t>
+                        <a:t>1.264</a:t>
                       </a:r>
                     </a:p>
                   </a:txBody>
@@ -32729,7 +32729,7 @@
                           </a:solidFill>
                           <a:latin typeface="+mn-lt"/>
                         </a:rPr>
-                        <a:t>4.255</a:t>
+                        <a:t>478</a:t>
                       </a:r>
                     </a:p>
                   </a:txBody>
@@ -32813,7 +32813,7 @@
                           </a:solidFill>
                           <a:latin typeface="+mn-lt"/>
                         </a:rPr>
-                        <a:t>17.299</a:t>
+                        <a:t>2.627</a:t>
                       </a:r>
                     </a:p>
                   </a:txBody>
@@ -32858,7 +32858,7 @@
                           </a:solidFill>
                           <a:latin typeface="+mn-lt"/>
                         </a:rPr>
-                        <a:t>19.081</a:t>
+                        <a:t>2.566</a:t>
                       </a:r>
                     </a:p>
                   </a:txBody>
@@ -32899,11 +32899,11 @@
                       <a:r>
                         <a:rPr lang="pt-BR" sz="1100" b="1" noProof="0" dirty="0">
                           <a:solidFill>
-                            <a:srgbClr val="C00000"/>
+                            <a:srgbClr val="00803C"/>
                           </a:solidFill>
                           <a:latin typeface="+mn-lt"/>
                         </a:rPr>
-                        <a:t>1.781</a:t>
+                        <a:t>-61</a:t>
                       </a:r>
                     </a:p>
                   </a:txBody>
@@ -32958,7 +32958,7 @@
                           </a:solidFill>
                           <a:latin typeface="+mn-lt"/>
                         </a:rPr>
-                        <a:t>VJR – Jurídico</a:t>
+                        <a:t>VCM – Comercialização</a:t>
                       </a:r>
                     </a:p>
                   </a:txBody>
@@ -33045,7 +33045,7 @@
                           </a:solidFill>
                           <a:latin typeface="+mn-lt"/>
                         </a:rPr>
-                        <a:t>917</a:t>
+                        <a:t>92</a:t>
                       </a:r>
                     </a:p>
                   </a:txBody>
@@ -33090,7 +33090,7 @@
                           </a:solidFill>
                           <a:latin typeface="+mn-lt"/>
                         </a:rPr>
-                        <a:t>1.369</a:t>
+                        <a:t>94</a:t>
                       </a:r>
                     </a:p>
                   </a:txBody>
@@ -33135,7 +33135,7 @@
                           </a:solidFill>
                           <a:latin typeface="+mn-lt"/>
                         </a:rPr>
-                        <a:t>452</a:t>
+                        <a:t>1</a:t>
                       </a:r>
                     </a:p>
                   </a:txBody>
@@ -33219,7 +33219,7 @@
                           </a:solidFill>
                           <a:latin typeface="+mn-lt"/>
                         </a:rPr>
-                        <a:t>8.292</a:t>
+                        <a:t>794</a:t>
                       </a:r>
                     </a:p>
                   </a:txBody>
@@ -33264,7 +33264,7 @@
                           </a:solidFill>
                           <a:latin typeface="+mn-lt"/>
                         </a:rPr>
-                        <a:t>6.876</a:t>
+                        <a:t>811</a:t>
                       </a:r>
                     </a:p>
                   </a:txBody>
@@ -33305,11 +33305,11 @@
                       <a:r>
                         <a:rPr lang="pt-BR" sz="1100" b="1" noProof="0" dirty="0">
                           <a:solidFill>
-                            <a:srgbClr val="00803C"/>
+                            <a:srgbClr val="C00000"/>
                           </a:solidFill>
                           <a:latin typeface="+mn-lt"/>
                         </a:rPr>
-                        <a:t>-1.416</a:t>
+                        <a:t>16</a:t>
                       </a:r>
                     </a:p>
                   </a:txBody>
@@ -33393,7 +33393,7 @@
                           </a:solidFill>
                           <a:latin typeface="+mn-lt"/>
                         </a:rPr>
-                        <a:t>3.938</a:t>
+                        <a:t>280</a:t>
                       </a:r>
                     </a:p>
                   </a:txBody>
@@ -33438,7 +33438,7 @@
                           </a:solidFill>
                           <a:latin typeface="+mn-lt"/>
                         </a:rPr>
-                        <a:t>4.917</a:t>
+                        <a:t>99</a:t>
                       </a:r>
                     </a:p>
                   </a:txBody>
@@ -33479,11 +33479,11 @@
                       <a:r>
                         <a:rPr lang="pt-BR" sz="1100" b="1" noProof="0" dirty="0">
                           <a:solidFill>
-                            <a:srgbClr val="C00000"/>
+                            <a:srgbClr val="00803C"/>
                           </a:solidFill>
                           <a:latin typeface="+mn-lt"/>
                         </a:rPr>
-                        <a:t>979</a:t>
+                        <a:t>-181</a:t>
                       </a:r>
                     </a:p>
                   </a:txBody>
@@ -33567,7 +33567,7 @@
                           </a:solidFill>
                           <a:latin typeface="+mn-lt"/>
                         </a:rPr>
-                        <a:t>12.230</a:t>
+                        <a:t>1.074</a:t>
                       </a:r>
                     </a:p>
                   </a:txBody>
@@ -33612,7 +33612,7 @@
                           </a:solidFill>
                           <a:latin typeface="+mn-lt"/>
                         </a:rPr>
-                        <a:t>11.793</a:t>
+                        <a:t>909</a:t>
                       </a:r>
                     </a:p>
                   </a:txBody>
@@ -33657,7 +33657,7 @@
                           </a:solidFill>
                           <a:latin typeface="+mn-lt"/>
                         </a:rPr>
-                        <a:t>-437</a:t>
+                        <a:t>-165</a:t>
                       </a:r>
                     </a:p>
                   </a:txBody>
@@ -33712,7 +33712,7 @@
                           </a:solidFill>
                           <a:latin typeface="+mn-lt"/>
                         </a:rPr>
-                        <a:t>VEE – Engenharia</a:t>
+                        <a:t>VJR – Jurídico</a:t>
                       </a:r>
                     </a:p>
                   </a:txBody>
@@ -33799,7 +33799,7 @@
                           </a:solidFill>
                           <a:latin typeface="+mn-lt"/>
                         </a:rPr>
-                        <a:t>757</a:t>
+                        <a:t>917</a:t>
                       </a:r>
                     </a:p>
                   </a:txBody>
@@ -33844,7 +33844,7 @@
                           </a:solidFill>
                           <a:latin typeface="+mn-lt"/>
                         </a:rPr>
-                        <a:t>1.094</a:t>
+                        <a:t>1.369</a:t>
                       </a:r>
                     </a:p>
                   </a:txBody>
@@ -33889,7 +33889,7 @@
                           </a:solidFill>
                           <a:latin typeface="+mn-lt"/>
                         </a:rPr>
-                        <a:t>337</a:t>
+                        <a:t>452</a:t>
                       </a:r>
                     </a:p>
                   </a:txBody>
@@ -33973,7 +33973,7 @@
                           </a:solidFill>
                           <a:latin typeface="+mn-lt"/>
                         </a:rPr>
-                        <a:t>7.986</a:t>
+                        <a:t>8.292</a:t>
                       </a:r>
                     </a:p>
                   </a:txBody>
@@ -34018,7 +34018,7 @@
                           </a:solidFill>
                           <a:latin typeface="+mn-lt"/>
                         </a:rPr>
-                        <a:t>7.760</a:t>
+                        <a:t>6.876</a:t>
                       </a:r>
                     </a:p>
                   </a:txBody>
@@ -34063,7 +34063,7 @@
                           </a:solidFill>
                           <a:latin typeface="+mn-lt"/>
                         </a:rPr>
-                        <a:t>-225</a:t>
+                        <a:t>-1.416</a:t>
                       </a:r>
                     </a:p>
                   </a:txBody>
@@ -34147,7 +34147,7 @@
                           </a:solidFill>
                           <a:latin typeface="+mn-lt"/>
                         </a:rPr>
-                        <a:t>2.307</a:t>
+                        <a:t>3.938</a:t>
                       </a:r>
                     </a:p>
                   </a:txBody>
@@ -34192,7 +34192,7 @@
                           </a:solidFill>
                           <a:latin typeface="+mn-lt"/>
                         </a:rPr>
-                        <a:t>2.503</a:t>
+                        <a:t>4.917</a:t>
                       </a:r>
                     </a:p>
                   </a:txBody>
@@ -34237,7 +34237,7 @@
                           </a:solidFill>
                           <a:latin typeface="+mn-lt"/>
                         </a:rPr>
-                        <a:t>197</a:t>
+                        <a:t>979</a:t>
                       </a:r>
                     </a:p>
                   </a:txBody>
@@ -34321,7 +34321,7 @@
                           </a:solidFill>
                           <a:latin typeface="+mn-lt"/>
                         </a:rPr>
-                        <a:t>10.292</a:t>
+                        <a:t>12.230</a:t>
                       </a:r>
                     </a:p>
                   </a:txBody>
@@ -34366,7 +34366,7 @@
                           </a:solidFill>
                           <a:latin typeface="+mn-lt"/>
                         </a:rPr>
-                        <a:t>10.264</a:t>
+                        <a:t>11.793</a:t>
                       </a:r>
                     </a:p>
                   </a:txBody>
@@ -34411,7 +34411,7 @@
                           </a:solidFill>
                           <a:latin typeface="+mn-lt"/>
                         </a:rPr>
-                        <a:t>-28</a:t>
+                        <a:t>-437</a:t>
                       </a:r>
                     </a:p>
                   </a:txBody>
@@ -34466,7 +34466,7 @@
                           </a:solidFill>
                           <a:latin typeface="+mn-lt"/>
                         </a:rPr>
-                        <a:t>VGC – Gente, Gestão e Cultura</a:t>
+                        <a:t>VFR – Financeiro e RI</a:t>
                       </a:r>
                     </a:p>
                   </a:txBody>
@@ -34553,7 +34553,7 @@
                           </a:solidFill>
                           <a:latin typeface="+mn-lt"/>
                         </a:rPr>
-                        <a:t>615</a:t>
+                        <a:t>1.936</a:t>
                       </a:r>
                     </a:p>
                   </a:txBody>
@@ -34598,7 +34598,7 @@
                           </a:solidFill>
                           <a:latin typeface="+mn-lt"/>
                         </a:rPr>
-                        <a:t>599</a:t>
+                        <a:t>2.227</a:t>
                       </a:r>
                     </a:p>
                   </a:txBody>
@@ -34639,11 +34639,11 @@
                       <a:r>
                         <a:rPr lang="pt-BR" sz="1100" b="1" noProof="0" dirty="0">
                           <a:solidFill>
-                            <a:srgbClr val="00803C"/>
+                            <a:srgbClr val="C00000"/>
                           </a:solidFill>
                           <a:latin typeface="+mn-lt"/>
                         </a:rPr>
-                        <a:t>-16</a:t>
+                        <a:t>291</a:t>
                       </a:r>
                     </a:p>
                   </a:txBody>
@@ -34727,7 +34727,7 @@
                           </a:solidFill>
                           <a:latin typeface="+mn-lt"/>
                         </a:rPr>
-                        <a:t>5.856</a:t>
+                        <a:t>16.983</a:t>
                       </a:r>
                     </a:p>
                   </a:txBody>
@@ -34772,7 +34772,7 @@
                           </a:solidFill>
                           <a:latin typeface="+mn-lt"/>
                         </a:rPr>
-                        <a:t>6.078</a:t>
+                        <a:t>16.542</a:t>
                       </a:r>
                     </a:p>
                   </a:txBody>
@@ -34813,11 +34813,11 @@
                       <a:r>
                         <a:rPr lang="pt-BR" sz="1100" b="1" noProof="0" dirty="0">
                           <a:solidFill>
-                            <a:srgbClr val="C00000"/>
+                            <a:srgbClr val="00803C"/>
                           </a:solidFill>
                           <a:latin typeface="+mn-lt"/>
                         </a:rPr>
-                        <a:t>222</a:t>
+                        <a:t>-440</a:t>
                       </a:r>
                     </a:p>
                   </a:txBody>
@@ -34901,7 +34901,7 @@
                           </a:solidFill>
                           <a:latin typeface="+mn-lt"/>
                         </a:rPr>
-                        <a:t>1.880</a:t>
+                        <a:t>6.034</a:t>
                       </a:r>
                     </a:p>
                   </a:txBody>
@@ -34946,7 +34946,7 @@
                           </a:solidFill>
                           <a:latin typeface="+mn-lt"/>
                         </a:rPr>
-                        <a:t>2.083</a:t>
+                        <a:t>5.967</a:t>
                       </a:r>
                     </a:p>
                   </a:txBody>
@@ -34987,11 +34987,11 @@
                       <a:r>
                         <a:rPr lang="pt-BR" sz="1100" b="1" noProof="0" dirty="0">
                           <a:solidFill>
-                            <a:srgbClr val="C00000"/>
+                            <a:srgbClr val="00803C"/>
                           </a:solidFill>
                           <a:latin typeface="+mn-lt"/>
                         </a:rPr>
-                        <a:t>204</a:t>
+                        <a:t>-67</a:t>
                       </a:r>
                     </a:p>
                   </a:txBody>
@@ -35075,7 +35075,7 @@
                           </a:solidFill>
                           <a:latin typeface="+mn-lt"/>
                         </a:rPr>
-                        <a:t>7.735</a:t>
+                        <a:t>23.017</a:t>
                       </a:r>
                     </a:p>
                   </a:txBody>
@@ -35120,7 +35120,7 @@
                           </a:solidFill>
                           <a:latin typeface="+mn-lt"/>
                         </a:rPr>
-                        <a:t>8.161</a:t>
+                        <a:t>22.509</a:t>
                       </a:r>
                     </a:p>
                   </a:txBody>
@@ -35161,11 +35161,11 @@
                       <a:r>
                         <a:rPr lang="pt-BR" sz="1100" b="1" noProof="0" dirty="0">
                           <a:solidFill>
-                            <a:srgbClr val="C00000"/>
+                            <a:srgbClr val="00803C"/>
                           </a:solidFill>
                           <a:latin typeface="+mn-lt"/>
                         </a:rPr>
-                        <a:t>426</a:t>
+                        <a:t>-508</a:t>
                       </a:r>
                     </a:p>
                   </a:txBody>
@@ -35220,7 +35220,7 @@
                           </a:solidFill>
                           <a:latin typeface="+mn-lt"/>
                         </a:rPr>
-                        <a:t>DCO – Comunicação</a:t>
+                        <a:t>COO – Operações e Segurança</a:t>
                       </a:r>
                     </a:p>
                   </a:txBody>
@@ -35307,7 +35307,7 @@
                           </a:solidFill>
                           <a:latin typeface="+mn-lt"/>
                         </a:rPr>
-                        <a:t>181</a:t>
+                        <a:t>14.178</a:t>
                       </a:r>
                     </a:p>
                   </a:txBody>
@@ -35352,7 +35352,7 @@
                           </a:solidFill>
                           <a:latin typeface="+mn-lt"/>
                         </a:rPr>
-                        <a:t>186</a:t>
+                        <a:t>14.262</a:t>
                       </a:r>
                     </a:p>
                   </a:txBody>
@@ -35397,7 +35397,7 @@
                           </a:solidFill>
                           <a:latin typeface="+mn-lt"/>
                         </a:rPr>
-                        <a:t>5</a:t>
+                        <a:t>85</a:t>
                       </a:r>
                     </a:p>
                   </a:txBody>
@@ -35481,7 +35481,7 @@
                           </a:solidFill>
                           <a:latin typeface="+mn-lt"/>
                         </a:rPr>
-                        <a:t>1.841</a:t>
+                        <a:t>107.652</a:t>
                       </a:r>
                     </a:p>
                   </a:txBody>
@@ -35526,7 +35526,7 @@
                           </a:solidFill>
                           <a:latin typeface="+mn-lt"/>
                         </a:rPr>
-                        <a:t>1.302</a:t>
+                        <a:t>101.790</a:t>
                       </a:r>
                     </a:p>
                   </a:txBody>
@@ -35571,7 +35571,7 @@
                           </a:solidFill>
                           <a:latin typeface="+mn-lt"/>
                         </a:rPr>
-                        <a:t>-539</a:t>
+                        <a:t>-5.862</a:t>
                       </a:r>
                     </a:p>
                   </a:txBody>
@@ -35655,7 +35655,7 @@
                           </a:solidFill>
                           <a:latin typeface="+mn-lt"/>
                         </a:rPr>
-                        <a:t>786</a:t>
+                        <a:t>42.408</a:t>
                       </a:r>
                     </a:p>
                   </a:txBody>
@@ -35700,7 +35700,7 @@
                           </a:solidFill>
                           <a:latin typeface="+mn-lt"/>
                         </a:rPr>
-                        <a:t>1.264</a:t>
+                        <a:t>47.692</a:t>
                       </a:r>
                     </a:p>
                   </a:txBody>
@@ -35745,7 +35745,7 @@
                           </a:solidFill>
                           <a:latin typeface="+mn-lt"/>
                         </a:rPr>
-                        <a:t>478</a:t>
+                        <a:t>5.284</a:t>
                       </a:r>
                     </a:p>
                   </a:txBody>
@@ -35829,7 +35829,7 @@
                           </a:solidFill>
                           <a:latin typeface="+mn-lt"/>
                         </a:rPr>
-                        <a:t>2.627</a:t>
+                        <a:t>150.060</a:t>
                       </a:r>
                     </a:p>
                   </a:txBody>
@@ -35874,7 +35874,7 @@
                           </a:solidFill>
                           <a:latin typeface="+mn-lt"/>
                         </a:rPr>
-                        <a:t>2.566</a:t>
+                        <a:t>149.482</a:t>
                       </a:r>
                     </a:p>
                   </a:txBody>
@@ -35919,7 +35919,7 @@
                           </a:solidFill>
                           <a:latin typeface="+mn-lt"/>
                         </a:rPr>
-                        <a:t>-61</a:t>
+                        <a:t>-578</a:t>
                       </a:r>
                     </a:p>
                   </a:txBody>
@@ -35974,7 +35974,7 @@
                           </a:solidFill>
                           <a:latin typeface="+mn-lt"/>
                         </a:rPr>
-                        <a:t>VCM – Comercialização</a:t>
+                        <a:t>VID – Inovação, P&amp;D, Digital e TI</a:t>
                       </a:r>
                     </a:p>
                   </a:txBody>
@@ -36071,7 +36071,7 @@
                           </a:solidFill>
                           <a:latin typeface="+mn-lt"/>
                         </a:rPr>
-                        <a:t>92</a:t>
+                        <a:t>3.213</a:t>
                       </a:r>
                     </a:p>
                   </a:txBody>
@@ -36121,7 +36121,7 @@
                           </a:solidFill>
                           <a:latin typeface="+mn-lt"/>
                         </a:rPr>
-                        <a:t>94</a:t>
+                        <a:t>3.757</a:t>
                       </a:r>
                     </a:p>
                   </a:txBody>
@@ -36171,7 +36171,7 @@
                           </a:solidFill>
                           <a:latin typeface="+mn-lt"/>
                         </a:rPr>
-                        <a:t>1</a:t>
+                        <a:t>545</a:t>
                       </a:r>
                     </a:p>
                   </a:txBody>
@@ -36265,7 +36265,7 @@
                           </a:solidFill>
                           <a:latin typeface="+mn-lt"/>
                         </a:rPr>
-                        <a:t>794</a:t>
+                        <a:t>15.924</a:t>
                       </a:r>
                     </a:p>
                   </a:txBody>
@@ -36315,7 +36315,7 @@
                           </a:solidFill>
                           <a:latin typeface="+mn-lt"/>
                         </a:rPr>
-                        <a:t>811</a:t>
+                        <a:t>15.408</a:t>
                       </a:r>
                     </a:p>
                   </a:txBody>
@@ -36361,11 +36361,11 @@
                       <a:r>
                         <a:rPr lang="pt-BR" sz="1100" b="1" noProof="0" dirty="0">
                           <a:solidFill>
-                            <a:srgbClr val="C00000"/>
+                            <a:srgbClr val="00803C"/>
                           </a:solidFill>
                           <a:latin typeface="+mn-lt"/>
                         </a:rPr>
-                        <a:t>16</a:t>
+                        <a:t>-516</a:t>
                       </a:r>
                     </a:p>
                   </a:txBody>
@@ -36459,7 +36459,7 @@
                           </a:solidFill>
                           <a:latin typeface="+mn-lt"/>
                         </a:rPr>
-                        <a:t>280</a:t>
+                        <a:t>6.774</a:t>
                       </a:r>
                     </a:p>
                   </a:txBody>
@@ -36509,7 +36509,7 @@
                           </a:solidFill>
                           <a:latin typeface="+mn-lt"/>
                         </a:rPr>
-                        <a:t>99</a:t>
+                        <a:t>5.996</a:t>
                       </a:r>
                     </a:p>
                   </a:txBody>
@@ -36559,7 +36559,7 @@
                           </a:solidFill>
                           <a:latin typeface="+mn-lt"/>
                         </a:rPr>
-                        <a:t>-181</a:t>
+                        <a:t>-778</a:t>
                       </a:r>
                     </a:p>
                   </a:txBody>
@@ -36653,7 +36653,7 @@
                           </a:solidFill>
                           <a:latin typeface="+mn-lt"/>
                         </a:rPr>
-                        <a:t>1.074</a:t>
+                        <a:t>22.698</a:t>
                       </a:r>
                     </a:p>
                   </a:txBody>
@@ -36703,7 +36703,7 @@
                           </a:solidFill>
                           <a:latin typeface="+mn-lt"/>
                         </a:rPr>
-                        <a:t>909</a:t>
+                        <a:t>21.404</a:t>
                       </a:r>
                     </a:p>
                   </a:txBody>
@@ -36753,7 +36753,7 @@
                           </a:solidFill>
                           <a:latin typeface="+mn-lt"/>
                         </a:rPr>
-                        <a:t>-165</a:t>
+                        <a:t>-1.294</a:t>
                       </a:r>
                     </a:p>
                   </a:txBody>

</xml_diff>

<commit_message>
Adiciona slide plurianual 2018–2026 ajustado pelo IPCA
Co-Authored-By: Claude Opus 5.5 <noreply@anthropic.com>
Claude-Session: https://claude.ai/code/session_0185ssrhs1XpW9XHreWECmyp
</commit_message>
<xml_diff>
--- a/20261006 - Santo Antônio Energia - Resultados OM set26.pptx
+++ b/20261006 - Santo Antônio Energia - Resultados OM set26.pptx
@@ -16,6 +16,7 @@
     <p:sldId id="263" r:id="rId9"/>
     <p:sldId id="257" r:id="rId10"/>
     <p:sldId id="258" r:id="rId11"/>
+    <p:sldId id="265" r:id="rId26"/>
   </p:sldIdLst>
   <p:sldSz cx="12195175" cy="6859588"/>
   <p:notesSz cx="7105650" cy="10236200"/>
@@ -131,6 +132,7 @@
             <p14:sldId id="264"/>
             <p14:sldId id="260"/>
             <p14:sldId id="261"/>
+            <p14:sldId id="265"/>
           </p14:sldIdLst>
         </p14:section>
       </p14:sectionLst>
@@ -4227,6 +4229,447 @@
           <c:orientation val="minMax"/>
           <c:max val="118"/>
           <c:min val="90"/>
+        </c:scaling>
+        <c:delete val="1"/>
+        <c:axPos val="l"/>
+        <c:numFmt formatCode="General" sourceLinked="1"/>
+        <c:majorTickMark val="out"/>
+        <c:minorTickMark val="none"/>
+        <c:tickLblPos val="nextTo"/>
+        <c:crossAx val="-2068027336"/>
+        <c:crosses val="autoZero"/>
+        <c:crossBetween val="between"/>
+      </c:valAx>
+    </c:plotArea>
+    <c:legend>
+      <c:legendPos val="b"/>
+      <c:overlay val="0"/>
+      <c:txPr>
+        <a:bodyPr/>
+        <a:lstStyle/>
+        <a:p>
+          <a:pPr>
+            <a:defRPr sz="800">
+              <a:latin typeface="Gadugi"/>
+            </a:defRPr>
+          </a:pPr>
+          <a:endParaRPr lang="pt-BR"/>
+        </a:p>
+      </c:txPr>
+    </c:legend>
+    <c:plotVisOnly val="1"/>
+    <c:dispBlanksAs val="gap"/>
+    <c:showDLblsOverMax val="1"/>
+  </c:chart>
+  <c:txPr>
+    <a:bodyPr/>
+    <a:lstStyle/>
+    <a:p>
+      <a:pPr>
+        <a:defRPr sz="1800"/>
+      </a:pPr>
+      <a:endParaRPr lang="en-US"/>
+    </a:p>
+  </c:txPr>
+  <c:externalData r:id="rId1">
+    <c:autoUpdate val="0"/>
+  </c:externalData>
+</c:chartSpace>
+</file>
+
+<file path=ppt/charts/chart5.xml><?xml version="1.0" encoding="utf-8"?>
+<c:chartSpace xmlns:c="http://schemas.openxmlformats.org/drawingml/2006/chart" xmlns:a="http://schemas.openxmlformats.org/drawingml/2006/main" xmlns:r="http://schemas.openxmlformats.org/officeDocument/2006/relationships" xmlns:c16r2="http://schemas.microsoft.com/office/drawing/2015/06/chart">
+  <c:date1904 val="0"/>
+  <c:lang val="pt-BR"/>
+  <c:roundedCorners val="1"/>
+  <c:style val="2"/>
+  <c:chart>
+    <c:title>
+      <c:tx>
+        <c:rich>
+          <a:bodyPr/>
+          <a:lstStyle/>
+          <a:p>
+            <a:r>
+              <a:rPr lang="pt-BR" sz="900" b="1" dirty="0">
+                <a:solidFill>
+                  <a:srgbClr val="002060"/>
+                </a:solidFill>
+                <a:latin typeface="Gadugi"/>
+              </a:rPr>
+              <a:t>Realizado anual, R$ MM:</a:t>
+            </a:r>
+          </a:p>
+          <a:p>
+            <a:r>
+              <a:rPr lang="pt-BR" sz="900" b="1" dirty="0">
+                <a:solidFill>
+                  <a:srgbClr val="002060"/>
+                </a:solidFill>
+                <a:latin typeface="Gadugi"/>
+              </a:rPr>
+              <a:t> -34% real de 2019 a 2026</a:t>
+            </a:r>
+          </a:p>
+        </c:rich>
+      </c:tx>
+      <c:overlay val="0"/>
+    </c:title>
+    <c:autoTitleDeleted val="0"/>
+    <c:plotArea>
+      <c:layout/>
+      <c:barChart>
+        <c:barDir val="col"/>
+        <c:grouping val="clustered"/>
+        <c:varyColors val="1"/>
+        <c:ser>
+          <c:idx val="0"/>
+          <c:order val="0"/>
+          <c:tx>
+            <c:strRef>
+              <c:f>Sheet1!$B$1</c:f>
+              <c:strCache>
+                <c:ptCount val="1"/>
+                <c:pt idx="0">
+                  <c:v>Nominal</c:v>
+                </c:pt>
+              </c:strCache>
+            </c:strRef>
+          </c:tx>
+          <c:spPr>
+            <a:solidFill>
+              <a:srgbClr val="A6A6A6"/>
+            </a:solidFill>
+            <a:ln>
+              <a:noFill/>
+            </a:ln>
+          </c:spPr>
+          <c:invertIfNegative val="1"/>
+          <c:dLbls>
+            <c:numFmt formatCode="#,##0" sourceLinked="0"/>
+            <c:spPr>
+              <a:noFill/>
+              <a:ln>
+                <a:noFill/>
+              </a:ln>
+              <a:effectLst/>
+            </c:spPr>
+            <c:txPr>
+              <a:bodyPr/>
+              <a:lstStyle/>
+              <a:p>
+                <a:pPr>
+                  <a:defRPr sz="800">
+                    <a:latin typeface="Gadugi"/>
+                  </a:defRPr>
+                </a:pPr>
+                <a:endParaRPr lang="pt-BR"/>
+              </a:p>
+            </c:txPr>
+            <c:dLblPos val="outEnd"/>
+            <c:showLegendKey val="0"/>
+            <c:showVal val="1"/>
+            <c:showCatName val="0"/>
+            <c:showSerName val="0"/>
+            <c:showPercent val="0"/>
+            <c:showBubbleSize val="0"/>
+            <c:showLeaderLines val="0"/>
+            <c:extLst>
+              <c:ext xmlns:c15="http://schemas.microsoft.com/office/drawing/2012/chart" uri="{CE6537A1-D6FC-4f65-9D91-7224C49458BB}">
+                <c15:showLeaderLines val="0"/>
+              </c:ext>
+            </c:extLst>
+          </c:dLbls>
+          <c:cat>
+            <c:strRef>
+              <c:f>Sheet1!$A$2:$A$10</c:f>
+              <c:strCache>
+                <c:ptCount val="9"/>
+                <c:pt idx="0">
+                  <c:v>2018¹</c:v>
+                </c:pt>
+                <c:pt idx="1">
+                  <c:v>2019</c:v>
+                </c:pt>
+                <c:pt idx="2">
+                  <c:v>2020</c:v>
+                </c:pt>
+                <c:pt idx="3">
+                  <c:v>2021</c:v>
+                </c:pt>
+                <c:pt idx="4">
+                  <c:v>2022</c:v>
+                </c:pt>
+                <c:pt idx="5">
+                  <c:v>2023</c:v>
+                </c:pt>
+                <c:pt idx="6">
+                  <c:v>2024</c:v>
+                </c:pt>
+                <c:pt idx="7">
+                  <c:v>2025</c:v>
+                </c:pt>
+                <c:pt idx="8">
+                  <c:v>2026²</c:v>
+                </c:pt>
+              </c:strCache>
+            </c:strRef>
+          </c:cat>
+          <c:val>
+            <c:numRef>
+              <c:f>Sheet1!$B$2:$B$10</c:f>
+              <c:numCache>
+                <c:formatCode>General</c:formatCode>
+                <c:ptCount val="9"/>
+                <c:pt idx="0">
+                  <c:v>184.1272</c:v>
+                </c:pt>
+                <c:pt idx="1">
+                  <c:v>294.6051</c:v>
+                </c:pt>
+                <c:pt idx="2">
+                  <c:v>252.5881</c:v>
+                </c:pt>
+                <c:pt idx="3">
+                  <c:v>254.9048</c:v>
+                </c:pt>
+                <c:pt idx="4">
+                  <c:v>351.3041</c:v>
+                </c:pt>
+                <c:pt idx="5">
+                  <c:v>364.6931</c:v>
+                </c:pt>
+                <c:pt idx="6">
+                  <c:v>288.1034</c:v>
+                </c:pt>
+                <c:pt idx="7">
+                  <c:v>302.8917</c:v>
+                </c:pt>
+                <c:pt idx="8">
+                  <c:v>280.5751</c:v>
+                </c:pt>
+              </c:numCache>
+            </c:numRef>
+          </c:val>
+          <c:extLst>
+            <c:ext xmlns:c14="http://schemas.microsoft.com/office/drawing/2007/8/2/chart" uri="{6F2FDCE9-48DA-4B69-8628-5D25D57E5C99}">
+              <c14:invertSolidFillFmt>
+                <c14:spPr xmlns:c14="http://schemas.microsoft.com/office/drawing/2007/8/2/chart">
+                  <a:solidFill>
+                    <a:srgbClr val="FFFFFF"/>
+                  </a:solidFill>
+                  <a:ln>
+                    <a:noFill/>
+                  </a:ln>
+                </c14:spPr>
+              </c14:invertSolidFillFmt>
+            </c:ext>
+            <c:ext xmlns:c16="http://schemas.microsoft.com/office/drawing/2014/chart" uri="{C3380CC4-5D6E-409C-BE32-E72D297353CC}">
+              <c16:uniqueId val="{00000000-90D8-498B-8039-9D33AD78AD40}"/>
+            </c:ext>
+          </c:extLst>
+        </c:ser>
+        <c:ser>
+          <c:idx val="1"/>
+          <c:order val="1"/>
+          <c:tx>
+            <c:strRef>
+              <c:f>Sheet1!$C$1</c:f>
+              <c:strCache>
+                <c:ptCount val="1"/>
+                <c:pt idx="0">
+                  <c:v>A preços de 2026</c:v>
+                </c:pt>
+              </c:strCache>
+            </c:strRef>
+          </c:tx>
+          <c:spPr>
+            <a:solidFill>
+              <a:srgbClr val="002060"/>
+            </a:solidFill>
+            <a:ln>
+              <a:noFill/>
+            </a:ln>
+          </c:spPr>
+          <c:invertIfNegative val="1"/>
+          <c:dLbls>
+            <c:numFmt formatCode="#,##0" sourceLinked="0"/>
+            <c:spPr>
+              <a:noFill/>
+              <a:ln>
+                <a:noFill/>
+              </a:ln>
+              <a:effectLst/>
+            </c:spPr>
+            <c:txPr>
+              <a:bodyPr/>
+              <a:lstStyle/>
+              <a:p>
+                <a:pPr>
+                  <a:defRPr sz="800">
+                    <a:latin typeface="Gadugi"/>
+                  </a:defRPr>
+                </a:pPr>
+                <a:endParaRPr lang="pt-BR"/>
+              </a:p>
+            </c:txPr>
+            <c:dLblPos val="outEnd"/>
+            <c:showLegendKey val="0"/>
+            <c:showVal val="1"/>
+            <c:showCatName val="0"/>
+            <c:showSerName val="0"/>
+            <c:showPercent val="0"/>
+            <c:showBubbleSize val="0"/>
+            <c:showLeaderLines val="0"/>
+            <c:extLst>
+              <c:ext xmlns:c15="http://schemas.microsoft.com/office/drawing/2012/chart" uri="{CE6537A1-D6FC-4f65-9D91-7224C49458BB}">
+                <c15:showLeaderLines val="0"/>
+              </c:ext>
+            </c:extLst>
+          </c:dLbls>
+          <c:cat>
+            <c:strRef>
+              <c:f>Sheet1!$A$2:$A$10</c:f>
+              <c:strCache>
+                <c:ptCount val="9"/>
+                <c:pt idx="0">
+                  <c:v>2018¹</c:v>
+                </c:pt>
+                <c:pt idx="1">
+                  <c:v>2019</c:v>
+                </c:pt>
+                <c:pt idx="2">
+                  <c:v>2020</c:v>
+                </c:pt>
+                <c:pt idx="3">
+                  <c:v>2021</c:v>
+                </c:pt>
+                <c:pt idx="4">
+                  <c:v>2022</c:v>
+                </c:pt>
+                <c:pt idx="5">
+                  <c:v>2023</c:v>
+                </c:pt>
+                <c:pt idx="6">
+                  <c:v>2024</c:v>
+                </c:pt>
+                <c:pt idx="7">
+                  <c:v>2025</c:v>
+                </c:pt>
+                <c:pt idx="8">
+                  <c:v>2026²</c:v>
+                </c:pt>
+              </c:strCache>
+            </c:strRef>
+          </c:cat>
+          <c:val>
+            <c:numRef>
+              <c:f>Sheet1!$C$2:$C$10</c:f>
+              <c:numCache>
+                <c:formatCode>General</c:formatCode>
+                <c:ptCount val="9"/>
+                <c:pt idx="0">
+                  <c:v>278.5393</c:v>
+                </c:pt>
+                <c:pt idx="1">
+                  <c:v>427.2507</c:v>
+                </c:pt>
+                <c:pt idx="2">
+                  <c:v>350.4743</c:v>
+                </c:pt>
+                <c:pt idx="3">
+                  <c:v>321.3600</c:v>
+                </c:pt>
+                <c:pt idx="4">
+                  <c:v>418.6511</c:v>
+                </c:pt>
+                <c:pt idx="5">
+                  <c:v>415.4148</c:v>
+                </c:pt>
+                <c:pt idx="6">
+                  <c:v>313.0524</c:v>
+                </c:pt>
+                <c:pt idx="7">
+                  <c:v>315.6738</c:v>
+                </c:pt>
+                <c:pt idx="8">
+                  <c:v>280.5751</c:v>
+                </c:pt>
+              </c:numCache>
+            </c:numRef>
+          </c:val>
+          <c:extLst>
+            <c:ext xmlns:c14="http://schemas.microsoft.com/office/drawing/2007/8/2/chart" uri="{6F2FDCE9-48DA-4B69-8628-5D25D57E5C99}">
+              <c14:invertSolidFillFmt>
+                <c14:spPr xmlns:c14="http://schemas.microsoft.com/office/drawing/2007/8/2/chart">
+                  <a:solidFill>
+                    <a:srgbClr val="FFFFFF"/>
+                  </a:solidFill>
+                  <a:ln>
+                    <a:noFill/>
+                  </a:ln>
+                </c14:spPr>
+              </c14:invertSolidFillFmt>
+            </c:ext>
+            <c:ext xmlns:c16="http://schemas.microsoft.com/office/drawing/2014/chart" uri="{C3380CC4-5D6E-409C-BE32-E72D297353CC}">
+              <c16:uniqueId val="{00000001-90D8-498B-8039-9D33AD78AD40}"/>
+            </c:ext>
+          </c:extLst>
+        </c:ser>
+        <c:dLbls>
+          <c:showLegendKey val="0"/>
+          <c:showVal val="0"/>
+          <c:showCatName val="0"/>
+          <c:showSerName val="0"/>
+          <c:showPercent val="0"/>
+          <c:showBubbleSize val="0"/>
+        </c:dLbls>
+        <c:gapWidth val="50"/>
+        <c:overlap val="-10"/>
+        <c:axId val="-2068027336"/>
+        <c:axId val="-2113994440"/>
+      </c:barChart>
+      <c:catAx>
+        <c:axId val="-2068027336"/>
+        <c:scaling>
+          <c:orientation val="minMax"/>
+        </c:scaling>
+        <c:delete val="0"/>
+        <c:axPos val="b"/>
+        <c:numFmt formatCode="General" sourceLinked="0"/>
+        <c:majorTickMark val="out"/>
+        <c:minorTickMark val="none"/>
+        <c:tickLblPos val="nextTo"/>
+        <c:spPr>
+          <a:ln>
+            <a:solidFill>
+              <a:srgbClr val="A6A6A6"/>
+            </a:solidFill>
+          </a:ln>
+        </c:spPr>
+        <c:txPr>
+          <a:bodyPr/>
+          <a:lstStyle/>
+          <a:p>
+            <a:pPr>
+              <a:defRPr sz="800">
+                <a:latin typeface="Gadugi"/>
+              </a:defRPr>
+            </a:pPr>
+            <a:endParaRPr lang="pt-BR"/>
+          </a:p>
+        </c:txPr>
+        <c:crossAx val="-2113994440"/>
+        <c:crosses val="autoZero"/>
+        <c:auto val="1"/>
+        <c:lblAlgn val="ctr"/>
+        <c:lblOffset val="100"/>
+        <c:noMultiLvlLbl val="0"/>
+      </c:catAx>
+      <c:valAx>
+        <c:axId val="-2113994440"/>
+        <c:scaling>
+          <c:orientation val="minMax"/>
         </c:scaling>
         <c:delete val="1"/>
         <c:axPos val="l"/>
@@ -45103,6 +45546,3807 @@
 </p:sld>
 </file>
 
+<file path=ppt/slides/slide6.xml><?xml version="1.0" encoding="utf-8"?>
+<p:sld xmlns:a="http://schemas.openxmlformats.org/drawingml/2006/main" xmlns:r="http://schemas.openxmlformats.org/officeDocument/2006/relationships" xmlns:p="http://schemas.openxmlformats.org/presentationml/2006/main">
+  <p:cSld>
+    <p:spTree>
+      <p:nvGrpSpPr>
+        <p:cNvPr id="1" name=""/>
+        <p:cNvGrpSpPr/>
+        <p:nvPr/>
+      </p:nvGrpSpPr>
+      <p:grpSpPr>
+        <a:xfrm>
+          <a:off x="0" y="0"/>
+          <a:ext cx="0" cy="0"/>
+          <a:chOff x="0" y="0"/>
+          <a:chExt cx="0" cy="0"/>
+        </a:xfrm>
+      </p:grpSpPr>
+      <p:sp>
+        <p:nvSpPr>
+          <p:cNvPr id="2" name="Title 1"/>
+          <p:cNvSpPr>
+            <a:spLocks noGrp="1"/>
+          </p:cNvSpPr>
+          <p:nvPr>
+            <p:ph type="title"/>
+          </p:nvPr>
+        </p:nvSpPr>
+        <p:spPr>
+          <a:xfrm>
+            <a:off x="173736" y="54864"/>
+            <a:ext cx="11155680" cy="722376"/>
+          </a:xfrm>
+        </p:spPr>
+        <p:txBody>
+          <a:bodyPr vert="horz" rIns="104652"/>
+          <a:lstStyle/>
+          <a:p>
+            <a:r>
+              <a:rPr lang="pt-BR" sz="1650" b="1" noProof="0" dirty="0">
+                <a:solidFill>
+                  <a:srgbClr val="002060"/>
+                </a:solidFill>
+                <a:latin typeface="Gadugi"/>
+              </a:rPr>
+              <a:t>A preços de 2026, o OM cai de R$ 427 MM em 2019 para R$ 281 MM na tendência de 2026 (-34%; -5,8% a.a.), puxado por Manutenção, Pessoal e Consultoria</a:t>
+            </a:r>
+          </a:p>
+        </p:txBody>
+      </p:sp>
+      <p:sp>
+        <p:nvSpPr>
+          <p:cNvPr id="3" name="TextBox 2"/>
+          <p:cNvSpPr txBox="1"/>
+          <p:nvPr/>
+        </p:nvSpPr>
+        <p:spPr>
+          <a:xfrm>
+            <a:off x="173736" y="786384"/>
+            <a:ext cx="11795760" cy="413959"/>
+          </a:xfrm>
+          <a:prstGeom prst="rect">
+            <a:avLst/>
+          </a:prstGeom>
+          <a:noFill/>
+        </p:spPr>
+        <p:txBody>
+          <a:bodyPr wrap="square" lIns="18288" tIns="18288" rIns="18288" bIns="18288" anchor="t">
+            <a:spAutoFit/>
+          </a:bodyPr>
+          <a:lstStyle/>
+          <a:p>
+            <a:pPr algn="l">
+              <a:spcAft>
+                <a:spcPts val="300"/>
+              </a:spcAft>
+            </a:pPr>
+            <a:r>
+              <a:rPr lang="pt-BR" sz="1200" b="1" i="0" noProof="0" dirty="0">
+                <a:solidFill>
+                  <a:srgbClr val="002060"/>
+                </a:solidFill>
+                <a:latin typeface="Gadugi"/>
+              </a:rPr>
+              <a:t>SANTO ANTÔNIO ENERGIA | EVOLUÇÃO PLURIANUAL DO OM AJUSTADA PELA INFLAÇÃO</a:t>
+            </a:r>
+          </a:p>
+          <a:p>
+            <a:pPr algn="l">
+              <a:spcAft>
+                <a:spcPts val="300"/>
+              </a:spcAft>
+            </a:pPr>
+            <a:r>
+              <a:rPr lang="pt-BR" sz="1000" b="1" i="0" noProof="0" dirty="0">
+                <a:solidFill>
+                  <a:srgbClr val="002060"/>
+                </a:solidFill>
+                <a:latin typeface="Gadugi"/>
+              </a:rPr>
+              <a:t>R$ MM; valores de cada ano trazidos a preços de 2026 pelo IPCA anual</a:t>
+            </a:r>
+          </a:p>
+        </p:txBody>
+      </p:sp>
+      <p:sp>
+        <p:nvSpPr>
+          <p:cNvPr id="5" name="TextBox 4"/>
+          <p:cNvSpPr txBox="1"/>
+          <p:nvPr/>
+        </p:nvSpPr>
+        <p:spPr>
+          <a:xfrm>
+            <a:off x="365760" y="1325880"/>
+            <a:ext cx="6766560" cy="206210"/>
+          </a:xfrm>
+          <a:prstGeom prst="rect">
+            <a:avLst/>
+          </a:prstGeom>
+          <a:noFill/>
+        </p:spPr>
+        <p:txBody>
+          <a:bodyPr wrap="square" lIns="18288" tIns="18288" rIns="18288" bIns="18288" anchor="t">
+            <a:spAutoFit/>
+          </a:bodyPr>
+          <a:lstStyle/>
+          <a:p>
+            <a:pPr algn="l">
+              <a:spcAft>
+                <a:spcPts val="300"/>
+              </a:spcAft>
+            </a:pPr>
+            <a:r>
+              <a:rPr lang="pt-BR" sz="1100" b="1" i="0" noProof="0" dirty="0">
+                <a:solidFill>
+                  <a:srgbClr val="002060"/>
+                </a:solidFill>
+                <a:latin typeface="Gadugi"/>
+              </a:rPr>
+              <a:t>Orçado x realizado por ano, desde o início da base (2018)</a:t>
+            </a:r>
+          </a:p>
+        </p:txBody>
+      </p:sp>
+      <p:graphicFrame>
+        <p:nvGraphicFramePr>
+          <p:cNvPr id="6" name="Table 5"/>
+          <p:cNvGraphicFramePr>
+            <a:graphicFrameLocks noGrp="1"/>
+          </p:cNvGraphicFramePr>
+          <p:nvPr>
+            <p:extLst>
+              <p:ext uri="{D42A27DB-BD31-4B8C-83A1-F6EECF244321}">
+                <p14:modId xmlns:p14="http://schemas.microsoft.com/office/powerpoint/2010/main" val="226578511"/>
+              </p:ext>
+            </p:extLst>
+          </p:nvPr>
+        </p:nvGraphicFramePr>
+        <p:xfrm>
+          <a:off x="365760" y="1618488"/>
+          <a:ext cx="6766556" cy="3236976"/>
+        </p:xfrm>
+        <a:graphic>
+          <a:graphicData uri="http://schemas.openxmlformats.org/drawingml/2006/table">
+            <a:tbl>
+              <a:tblPr/>
+              <a:tblGrid>
+                <a:gridCol w="2212144">
+                  <a:extLst>
+                    <a:ext uri="{9D8B030D-6E8A-4147-A177-3AD203B41FA5}">
+                      <a16:colId xmlns:a16="http://schemas.microsoft.com/office/drawing/2014/main" val="20000"/>
+                    </a:ext>
+                  </a:extLst>
+                </a:gridCol>
+                <a:gridCol w="867507">
+                  <a:extLst>
+                    <a:ext uri="{9D8B030D-6E8A-4147-A177-3AD203B41FA5}">
+                      <a16:colId xmlns:a16="http://schemas.microsoft.com/office/drawing/2014/main" val="20001"/>
+                    </a:ext>
+                  </a:extLst>
+                </a:gridCol>
+                <a:gridCol w="1171135">
+                  <a:extLst>
+                    <a:ext uri="{9D8B030D-6E8A-4147-A177-3AD203B41FA5}">
+                      <a16:colId xmlns:a16="http://schemas.microsoft.com/office/drawing/2014/main" val="20002"/>
+                    </a:ext>
+                  </a:extLst>
+                </a:gridCol>
+                <a:gridCol w="867507">
+                  <a:extLst>
+                    <a:ext uri="{9D8B030D-6E8A-4147-A177-3AD203B41FA5}">
+                      <a16:colId xmlns:a16="http://schemas.microsoft.com/office/drawing/2014/main" val="20003"/>
+                    </a:ext>
+                  </a:extLst>
+                </a:gridCol>
+                <a:gridCol w="867507">
+                  <a:extLst>
+                    <a:ext uri="{9D8B030D-6E8A-4147-A177-3AD203B41FA5}">
+                      <a16:colId xmlns:a16="http://schemas.microsoft.com/office/drawing/2014/main" val="20004"/>
+                    </a:ext>
+                  </a:extLst>
+                </a:gridCol>
+                <a:gridCol w="780756">
+                  <a:extLst>
+                    <a:ext uri="{9D8B030D-6E8A-4147-A177-3AD203B41FA5}">
+                      <a16:colId xmlns:a16="http://schemas.microsoft.com/office/drawing/2014/main" val="20005"/>
+                    </a:ext>
+                  </a:extLst>
+                </a:gridCol>
+              </a:tblGrid>
+              <a:tr h="246888">
+                <a:tc>
+                  <a:txBody>
+                    <a:bodyPr/>
+                    <a:lstStyle/>
+                    <a:p>
+                      <a:pPr algn="l" rtl="0"/>
+                      <a:r>
+                        <a:rPr lang="pt-BR" sz="1100" b="1" noProof="0" dirty="0">
+                          <a:solidFill>
+                            <a:srgbClr val="002060"/>
+                          </a:solidFill>
+                          <a:latin typeface="Gadugi"/>
+                        </a:rPr>
+                        <a:t>Ano</a:t>
+                      </a:r>
+                    </a:p>
+                  </a:txBody>
+                  <a:tcPr marL="27432" marR="27432" marT="9144" marB="9144" anchor="ctr">
+                    <a:lnL w="12700" cmpd="sng">
+                      <a:noFill/>
+                      <a:prstDash val="solid"/>
+                    </a:lnL>
+                    <a:lnR w="12700" cmpd="sng">
+                      <a:noFill/>
+                      <a:prstDash val="solid"/>
+                    </a:lnR>
+                    <a:lnT w="12700" cmpd="sng">
+                      <a:noFill/>
+                      <a:prstDash val="solid"/>
+                    </a:lnT>
+                    <a:lnB w="12700" cap="flat" cmpd="sng" algn="ctr">
+                      <a:solidFill>
+                        <a:schemeClr val="tx1"/>
+                      </a:solidFill>
+                      <a:prstDash val="solid"/>
+                      <a:round/>
+                      <a:headEnd type="none" w="med" len="med"/>
+                      <a:tailEnd type="none" w="med" len="med"/>
+                    </a:lnB>
+                    <a:lnTlToBr w="12700" cmpd="sng">
+                      <a:noFill/>
+                      <a:prstDash val="solid"/>
+                    </a:lnTlToBr>
+                    <a:lnBlToTr w="12700" cmpd="sng">
+                      <a:noFill/>
+                      <a:prstDash val="solid"/>
+                    </a:lnBlToTr>
+                    <a:noFill/>
+                  </a:tcPr>
+                </a:tc>
+                <a:tc>
+                  <a:txBody>
+                    <a:bodyPr/>
+                    <a:lstStyle/>
+                    <a:p>
+                      <a:pPr algn="ctr" rtl="0"/>
+                      <a:r>
+                        <a:rPr lang="pt-BR" sz="1100" b="1" noProof="0" dirty="0">
+                          <a:solidFill>
+                            <a:srgbClr val="002060"/>
+                          </a:solidFill>
+                          <a:latin typeface="Gadugi"/>
+                        </a:rPr>
+                        <a:t>Orçado</a:t>
+                      </a:r>
+                    </a:p>
+                  </a:txBody>
+                  <a:tcPr marL="27432" marR="27432" marT="9144" marB="9144" anchor="ctr">
+                    <a:lnL w="12700" cmpd="sng">
+                      <a:noFill/>
+                      <a:prstDash val="solid"/>
+                    </a:lnL>
+                    <a:lnR w="12700" cmpd="sng">
+                      <a:noFill/>
+                      <a:prstDash val="solid"/>
+                    </a:lnR>
+                    <a:lnT w="12700" cmpd="sng">
+                      <a:noFill/>
+                      <a:prstDash val="solid"/>
+                    </a:lnT>
+                    <a:lnB w="12700" cap="flat" cmpd="sng" algn="ctr">
+                      <a:solidFill>
+                        <a:schemeClr val="tx1"/>
+                      </a:solidFill>
+                      <a:prstDash val="solid"/>
+                      <a:round/>
+                      <a:headEnd type="none" w="med" len="med"/>
+                      <a:tailEnd type="none" w="med" len="med"/>
+                    </a:lnB>
+                    <a:lnTlToBr w="12700" cmpd="sng">
+                      <a:noFill/>
+                      <a:prstDash val="solid"/>
+                    </a:lnTlToBr>
+                    <a:lnBlToTr w="12700" cmpd="sng">
+                      <a:noFill/>
+                      <a:prstDash val="solid"/>
+                    </a:lnBlToTr>
+                    <a:noFill/>
+                  </a:tcPr>
+                </a:tc>
+                <a:tc>
+                  <a:txBody>
+                    <a:bodyPr/>
+                    <a:lstStyle/>
+                    <a:p>
+                      <a:pPr algn="ctr" rtl="0"/>
+                      <a:r>
+                        <a:rPr lang="pt-BR" sz="1100" b="1" noProof="0" dirty="0">
+                          <a:solidFill>
+                            <a:srgbClr val="002060"/>
+                          </a:solidFill>
+                          <a:latin typeface="Gadugi"/>
+                        </a:rPr>
+                        <a:t>Realizado / tendência</a:t>
+                      </a:r>
+                    </a:p>
+                  </a:txBody>
+                  <a:tcPr marL="27432" marR="27432" marT="9144" marB="9144" anchor="ctr">
+                    <a:lnL w="12700" cmpd="sng">
+                      <a:noFill/>
+                      <a:prstDash val="solid"/>
+                    </a:lnL>
+                    <a:lnR w="12700" cmpd="sng">
+                      <a:noFill/>
+                      <a:prstDash val="solid"/>
+                    </a:lnR>
+                    <a:lnT w="12700" cmpd="sng">
+                      <a:noFill/>
+                      <a:prstDash val="solid"/>
+                    </a:lnT>
+                    <a:lnB w="12700" cap="flat" cmpd="sng" algn="ctr">
+                      <a:solidFill>
+                        <a:schemeClr val="tx1"/>
+                      </a:solidFill>
+                      <a:prstDash val="solid"/>
+                      <a:round/>
+                      <a:headEnd type="none" w="med" len="med"/>
+                      <a:tailEnd type="none" w="med" len="med"/>
+                    </a:lnB>
+                    <a:lnTlToBr w="12700" cmpd="sng">
+                      <a:noFill/>
+                      <a:prstDash val="solid"/>
+                    </a:lnTlToBr>
+                    <a:lnBlToTr w="12700" cmpd="sng">
+                      <a:noFill/>
+                      <a:prstDash val="solid"/>
+                    </a:lnBlToTr>
+                    <a:noFill/>
+                  </a:tcPr>
+                </a:tc>
+                <a:tc>
+                  <a:txBody>
+                    <a:bodyPr/>
+                    <a:lstStyle/>
+                    <a:p>
+                      <a:pPr algn="ctr" rtl="0"/>
+                      <a:r>
+                        <a:rPr lang="pt-BR" sz="1100" b="1" noProof="0" dirty="0">
+                          <a:solidFill>
+                            <a:srgbClr val="002060"/>
+                          </a:solidFill>
+                          <a:latin typeface="Gadugi"/>
+                        </a:rPr>
+                        <a:t>Desvio s/ orçado</a:t>
+                      </a:r>
+                    </a:p>
+                  </a:txBody>
+                  <a:tcPr marL="27432" marR="27432" marT="9144" marB="9144" anchor="ctr">
+                    <a:lnL w="12700" cmpd="sng">
+                      <a:noFill/>
+                      <a:prstDash val="solid"/>
+                    </a:lnL>
+                    <a:lnR w="12700" cmpd="sng">
+                      <a:noFill/>
+                      <a:prstDash val="solid"/>
+                    </a:lnR>
+                    <a:lnT w="12700" cmpd="sng">
+                      <a:noFill/>
+                      <a:prstDash val="solid"/>
+                    </a:lnT>
+                    <a:lnB w="12700" cap="flat" cmpd="sng" algn="ctr">
+                      <a:solidFill>
+                        <a:schemeClr val="tx1"/>
+                      </a:solidFill>
+                      <a:prstDash val="solid"/>
+                      <a:round/>
+                      <a:headEnd type="none" w="med" len="med"/>
+                      <a:tailEnd type="none" w="med" len="med"/>
+                    </a:lnB>
+                    <a:lnTlToBr w="12700" cmpd="sng">
+                      <a:noFill/>
+                      <a:prstDash val="solid"/>
+                    </a:lnTlToBr>
+                    <a:lnBlToTr w="12700" cmpd="sng">
+                      <a:noFill/>
+                      <a:prstDash val="solid"/>
+                    </a:lnBlToTr>
+                    <a:noFill/>
+                  </a:tcPr>
+                </a:tc>
+                <a:tc>
+                  <a:txBody>
+                    <a:bodyPr/>
+                    <a:lstStyle/>
+                    <a:p>
+                      <a:pPr algn="ctr" rtl="0"/>
+                      <a:r>
+                        <a:rPr lang="pt-BR" sz="1100" b="1" noProof="0" dirty="0">
+                          <a:solidFill>
+                            <a:srgbClr val="002060"/>
+                          </a:solidFill>
+                          <a:latin typeface="Gadugi"/>
+                        </a:rPr>
+                        <a:t>Realizado a preços de 2026</a:t>
+                      </a:r>
+                    </a:p>
+                  </a:txBody>
+                  <a:tcPr marL="27432" marR="27432" marT="9144" marB="9144" anchor="ctr">
+                    <a:lnL w="12700" cmpd="sng">
+                      <a:noFill/>
+                      <a:prstDash val="solid"/>
+                    </a:lnL>
+                    <a:lnR w="12700" cmpd="sng">
+                      <a:noFill/>
+                      <a:prstDash val="solid"/>
+                    </a:lnR>
+                    <a:lnT w="12700" cmpd="sng">
+                      <a:noFill/>
+                      <a:prstDash val="solid"/>
+                    </a:lnT>
+                    <a:lnB w="12700" cap="flat" cmpd="sng" algn="ctr">
+                      <a:solidFill>
+                        <a:schemeClr val="tx1"/>
+                      </a:solidFill>
+                      <a:prstDash val="solid"/>
+                      <a:round/>
+                      <a:headEnd type="none" w="med" len="med"/>
+                      <a:tailEnd type="none" w="med" len="med"/>
+                    </a:lnB>
+                    <a:lnTlToBr w="12700" cmpd="sng">
+                      <a:noFill/>
+                      <a:prstDash val="solid"/>
+                    </a:lnTlToBr>
+                    <a:lnBlToTr w="12700" cmpd="sng">
+                      <a:noFill/>
+                      <a:prstDash val="solid"/>
+                    </a:lnBlToTr>
+                    <a:noFill/>
+                  </a:tcPr>
+                </a:tc>
+                <a:tc>
+                  <a:txBody>
+                    <a:bodyPr/>
+                    <a:lstStyle/>
+                    <a:p>
+                      <a:pPr algn="ctr" rtl="0"/>
+                      <a:r>
+                        <a:rPr lang="pt-BR" sz="1100" b="1" noProof="0" dirty="0">
+                          <a:solidFill>
+                            <a:srgbClr val="002060"/>
+                          </a:solidFill>
+                          <a:latin typeface="Gadugi"/>
+                        </a:rPr>
+                        <a:t>Var. real a/a</a:t>
+                      </a:r>
+                    </a:p>
+                  </a:txBody>
+                  <a:tcPr marL="27432" marR="27432" marT="9144" marB="9144" anchor="ctr">
+                    <a:lnL w="12700" cmpd="sng">
+                      <a:noFill/>
+                      <a:prstDash val="solid"/>
+                    </a:lnL>
+                    <a:lnR w="12700" cmpd="sng">
+                      <a:noFill/>
+                      <a:prstDash val="solid"/>
+                    </a:lnR>
+                    <a:lnT w="12700" cmpd="sng">
+                      <a:noFill/>
+                      <a:prstDash val="solid"/>
+                    </a:lnT>
+                    <a:lnB w="12700" cap="flat" cmpd="sng" algn="ctr">
+                      <a:solidFill>
+                        <a:schemeClr val="tx1"/>
+                      </a:solidFill>
+                      <a:prstDash val="solid"/>
+                      <a:round/>
+                      <a:headEnd type="none" w="med" len="med"/>
+                      <a:tailEnd type="none" w="med" len="med"/>
+                    </a:lnB>
+                    <a:lnTlToBr w="12700" cmpd="sng">
+                      <a:noFill/>
+                      <a:prstDash val="solid"/>
+                    </a:lnTlToBr>
+                    <a:lnBlToTr w="12700" cmpd="sng">
+                      <a:noFill/>
+                      <a:prstDash val="solid"/>
+                    </a:lnBlToTr>
+                    <a:noFill/>
+                  </a:tcPr>
+                </a:tc>
+                <a:extLst>
+                  <a:ext uri="{0D108BD9-81ED-4DB2-BD59-A6C34878D82A}">
+                    <a16:rowId xmlns:a16="http://schemas.microsoft.com/office/drawing/2014/main" val="10000"/>
+                  </a:ext>
+                </a:extLst>
+              </a:tr>
+              <a:tr h="246888">
+                <a:tc>
+                  <a:txBody>
+                    <a:bodyPr/>
+                    <a:lstStyle/>
+                    <a:p>
+                      <a:pPr marL="171450" indent="-171450" algn="l" rtl="0">
+                        <a:buFont typeface="Arial" panose="020B0604020202020204" pitchFamily="34" charset="0"/>
+                        <a:buChar char="•"/>
+                      </a:pPr>
+                      <a:r>
+                        <a:rPr lang="pt-BR" sz="1100" b="0" noProof="0" dirty="0">
+                          <a:solidFill>
+                            <a:schemeClr val="tx1"/>
+                          </a:solidFill>
+                          <a:latin typeface="Gadugi"/>
+                        </a:rPr>
+                        <a:t>2018¹</a:t>
+                      </a:r>
+                    </a:p>
+                  </a:txBody>
+                  <a:tcPr marL="27432" marR="27432" marT="9144" marB="9144" anchor="ctr">
+                    <a:lnL w="12700" cmpd="sng">
+                      <a:noFill/>
+                      <a:prstDash val="solid"/>
+                    </a:lnL>
+                    <a:lnR w="12700" cmpd="sng">
+                      <a:noFill/>
+                      <a:prstDash val="solid"/>
+                    </a:lnR>
+                    <a:lnT w="12700" cap="flat" cmpd="sng" algn="ctr">
+                      <a:solidFill>
+                        <a:schemeClr val="tx1"/>
+                      </a:solidFill>
+                      <a:prstDash val="solid"/>
+                      <a:round/>
+                      <a:headEnd type="none" w="med" len="med"/>
+                      <a:tailEnd type="none" w="med" len="med"/>
+                    </a:lnT>
+                    <a:lnB w="12700" cmpd="sng">
+                      <a:noFill/>
+                      <a:prstDash val="solid"/>
+                    </a:lnB>
+                    <a:lnTlToBr w="12700" cmpd="sng">
+                      <a:noFill/>
+                      <a:prstDash val="solid"/>
+                    </a:lnTlToBr>
+                    <a:lnBlToTr w="12700" cmpd="sng">
+                      <a:noFill/>
+                      <a:prstDash val="solid"/>
+                    </a:lnBlToTr>
+                    <a:noFill/>
+                  </a:tcPr>
+                </a:tc>
+                <a:tc>
+                  <a:txBody>
+                    <a:bodyPr/>
+                    <a:lstStyle/>
+                    <a:p>
+                      <a:pPr algn="r" rtl="0"/>
+                      <a:r>
+                        <a:rPr lang="pt-BR" sz="1100" b="0" noProof="0" dirty="0">
+                          <a:solidFill>
+                            <a:srgbClr val="002060"/>
+                          </a:solidFill>
+                          <a:latin typeface="Gadugi"/>
+                        </a:rPr>
+                        <a:t>222,1</a:t>
+                      </a:r>
+                    </a:p>
+                  </a:txBody>
+                  <a:tcPr marL="27432" marR="27432" marT="9144" marB="9144" anchor="ctr">
+                    <a:lnL w="12700" cmpd="sng">
+                      <a:noFill/>
+                      <a:prstDash val="solid"/>
+                    </a:lnL>
+                    <a:lnR w="12700" cmpd="sng">
+                      <a:noFill/>
+                      <a:prstDash val="solid"/>
+                    </a:lnR>
+                    <a:lnT w="12700" cap="flat" cmpd="sng" algn="ctr">
+                      <a:solidFill>
+                        <a:schemeClr val="tx1"/>
+                      </a:solidFill>
+                      <a:prstDash val="solid"/>
+                      <a:round/>
+                      <a:headEnd type="none" w="med" len="med"/>
+                      <a:tailEnd type="none" w="med" len="med"/>
+                    </a:lnT>
+                    <a:lnB w="12700" cmpd="sng">
+                      <a:noFill/>
+                      <a:prstDash val="solid"/>
+                    </a:lnB>
+                    <a:lnTlToBr w="12700" cmpd="sng">
+                      <a:noFill/>
+                      <a:prstDash val="solid"/>
+                    </a:lnTlToBr>
+                    <a:lnBlToTr w="12700" cmpd="sng">
+                      <a:noFill/>
+                      <a:prstDash val="solid"/>
+                    </a:lnBlToTr>
+                    <a:noFill/>
+                  </a:tcPr>
+                </a:tc>
+                <a:tc>
+                  <a:txBody>
+                    <a:bodyPr/>
+                    <a:lstStyle/>
+                    <a:p>
+                      <a:pPr algn="r" rtl="0"/>
+                      <a:r>
+                        <a:rPr lang="pt-BR" sz="1100" b="0" noProof="0" dirty="0">
+                          <a:solidFill>
+                            <a:srgbClr val="002060"/>
+                          </a:solidFill>
+                          <a:latin typeface="Gadugi"/>
+                        </a:rPr>
+                        <a:t>184,1</a:t>
+                      </a:r>
+                    </a:p>
+                  </a:txBody>
+                  <a:tcPr marL="27432" marR="27432" marT="9144" marB="9144" anchor="ctr">
+                    <a:lnL w="12700" cmpd="sng">
+                      <a:noFill/>
+                      <a:prstDash val="solid"/>
+                    </a:lnL>
+                    <a:lnR w="12700" cmpd="sng">
+                      <a:noFill/>
+                      <a:prstDash val="solid"/>
+                    </a:lnR>
+                    <a:lnT w="12700" cap="flat" cmpd="sng" algn="ctr">
+                      <a:solidFill>
+                        <a:schemeClr val="tx1"/>
+                      </a:solidFill>
+                      <a:prstDash val="solid"/>
+                      <a:round/>
+                      <a:headEnd type="none" w="med" len="med"/>
+                      <a:tailEnd type="none" w="med" len="med"/>
+                    </a:lnT>
+                    <a:lnB w="12700" cmpd="sng">
+                      <a:noFill/>
+                      <a:prstDash val="solid"/>
+                    </a:lnB>
+                    <a:lnTlToBr w="12700" cmpd="sng">
+                      <a:noFill/>
+                      <a:prstDash val="solid"/>
+                    </a:lnTlToBr>
+                    <a:lnBlToTr w="12700" cmpd="sng">
+                      <a:noFill/>
+                      <a:prstDash val="solid"/>
+                    </a:lnBlToTr>
+                    <a:noFill/>
+                  </a:tcPr>
+                </a:tc>
+                <a:tc>
+                  <a:txBody>
+                    <a:bodyPr/>
+                    <a:lstStyle/>
+                    <a:p>
+                      <a:pPr algn="r" rtl="0"/>
+                      <a:r>
+                        <a:rPr lang="pt-BR" sz="1100" b="0" noProof="0" dirty="0">
+                          <a:solidFill>
+                            <a:srgbClr val="00803C"/>
+                          </a:solidFill>
+                          <a:latin typeface="Gadugi"/>
+                        </a:rPr>
+                        <a:t>-17%</a:t>
+                      </a:r>
+                    </a:p>
+                  </a:txBody>
+                  <a:tcPr marL="27432" marR="27432" marT="9144" marB="9144" anchor="ctr">
+                    <a:lnL w="12700" cmpd="sng">
+                      <a:noFill/>
+                      <a:prstDash val="solid"/>
+                    </a:lnL>
+                    <a:lnR w="12700" cmpd="sng">
+                      <a:noFill/>
+                      <a:prstDash val="solid"/>
+                    </a:lnR>
+                    <a:lnT w="12700" cap="flat" cmpd="sng" algn="ctr">
+                      <a:solidFill>
+                        <a:schemeClr val="tx1"/>
+                      </a:solidFill>
+                      <a:prstDash val="solid"/>
+                      <a:round/>
+                      <a:headEnd type="none" w="med" len="med"/>
+                      <a:tailEnd type="none" w="med" len="med"/>
+                    </a:lnT>
+                    <a:lnB w="12700" cmpd="sng">
+                      <a:noFill/>
+                      <a:prstDash val="solid"/>
+                    </a:lnB>
+                    <a:lnTlToBr w="12700" cmpd="sng">
+                      <a:noFill/>
+                      <a:prstDash val="solid"/>
+                    </a:lnTlToBr>
+                    <a:lnBlToTr w="12700" cmpd="sng">
+                      <a:noFill/>
+                      <a:prstDash val="solid"/>
+                    </a:lnBlToTr>
+                    <a:noFill/>
+                  </a:tcPr>
+                </a:tc>
+                <a:tc>
+                  <a:txBody>
+                    <a:bodyPr/>
+                    <a:lstStyle/>
+                    <a:p>
+                      <a:pPr algn="r" rtl="0"/>
+                      <a:r>
+                        <a:rPr lang="pt-BR" sz="1100" b="1" noProof="0" dirty="0">
+                          <a:solidFill>
+                            <a:srgbClr val="002060"/>
+                          </a:solidFill>
+                          <a:latin typeface="Gadugi"/>
+                        </a:rPr>
+                        <a:t>278,5</a:t>
+                      </a:r>
+                    </a:p>
+                  </a:txBody>
+                  <a:tcPr marL="27432" marR="27432" marT="9144" marB="9144" anchor="ctr">
+                    <a:lnL w="12700" cmpd="sng">
+                      <a:noFill/>
+                      <a:prstDash val="solid"/>
+                    </a:lnL>
+                    <a:lnR w="12700" cmpd="sng">
+                      <a:noFill/>
+                      <a:prstDash val="solid"/>
+                    </a:lnR>
+                    <a:lnT w="12700" cap="flat" cmpd="sng" algn="ctr">
+                      <a:solidFill>
+                        <a:schemeClr val="tx1"/>
+                      </a:solidFill>
+                      <a:prstDash val="solid"/>
+                      <a:round/>
+                      <a:headEnd type="none" w="med" len="med"/>
+                      <a:tailEnd type="none" w="med" len="med"/>
+                    </a:lnT>
+                    <a:lnB w="12700" cmpd="sng">
+                      <a:noFill/>
+                      <a:prstDash val="solid"/>
+                    </a:lnB>
+                    <a:lnTlToBr w="12700" cmpd="sng">
+                      <a:noFill/>
+                      <a:prstDash val="solid"/>
+                    </a:lnTlToBr>
+                    <a:lnBlToTr w="12700" cmpd="sng">
+                      <a:noFill/>
+                      <a:prstDash val="solid"/>
+                    </a:lnBlToTr>
+                    <a:noFill/>
+                  </a:tcPr>
+                </a:tc>
+                <a:tc>
+                  <a:txBody>
+                    <a:bodyPr/>
+                    <a:lstStyle/>
+                    <a:p>
+                      <a:pPr algn="r" rtl="0"/>
+                      <a:r>
+                        <a:rPr lang="pt-BR" sz="1100" b="1" noProof="0" dirty="0">
+                          <a:solidFill>
+                            <a:srgbClr val="595959"/>
+                          </a:solidFill>
+                          <a:latin typeface="Gadugi"/>
+                        </a:rPr>
+                        <a:t>–</a:t>
+                      </a:r>
+                    </a:p>
+                  </a:txBody>
+                  <a:tcPr marL="27432" marR="27432" marT="9144" marB="9144" anchor="ctr">
+                    <a:lnL w="12700" cmpd="sng">
+                      <a:noFill/>
+                      <a:prstDash val="solid"/>
+                    </a:lnL>
+                    <a:lnR w="12700" cmpd="sng">
+                      <a:noFill/>
+                      <a:prstDash val="solid"/>
+                    </a:lnR>
+                    <a:lnT w="12700" cap="flat" cmpd="sng" algn="ctr">
+                      <a:solidFill>
+                        <a:schemeClr val="tx1"/>
+                      </a:solidFill>
+                      <a:prstDash val="solid"/>
+                      <a:round/>
+                      <a:headEnd type="none" w="med" len="med"/>
+                      <a:tailEnd type="none" w="med" len="med"/>
+                    </a:lnT>
+                    <a:lnB w="12700" cmpd="sng">
+                      <a:noFill/>
+                      <a:prstDash val="solid"/>
+                    </a:lnB>
+                    <a:lnTlToBr w="12700" cmpd="sng">
+                      <a:noFill/>
+                      <a:prstDash val="solid"/>
+                    </a:lnTlToBr>
+                    <a:lnBlToTr w="12700" cmpd="sng">
+                      <a:noFill/>
+                      <a:prstDash val="solid"/>
+                    </a:lnBlToTr>
+                    <a:noFill/>
+                  </a:tcPr>
+                </a:tc>
+                <a:extLst>
+                  <a:ext uri="{0D108BD9-81ED-4DB2-BD59-A6C34878D82A}">
+                    <a16:rowId xmlns:a16="http://schemas.microsoft.com/office/drawing/2014/main" val="10005"/>
+                  </a:ext>
+                </a:extLst>
+              </a:tr>
+              <a:tr h="246888">
+                <a:tc>
+                  <a:txBody>
+                    <a:bodyPr/>
+                    <a:lstStyle/>
+                    <a:p>
+                      <a:pPr marL="171450" indent="-171450" algn="l" rtl="0">
+                        <a:buFont typeface="Arial" panose="020B0604020202020204" pitchFamily="34" charset="0"/>
+                        <a:buChar char="•"/>
+                      </a:pPr>
+                      <a:r>
+                        <a:rPr lang="pt-BR" sz="1100" b="0" noProof="0" dirty="0">
+                          <a:solidFill>
+                            <a:schemeClr val="tx1"/>
+                          </a:solidFill>
+                          <a:latin typeface="Gadugi"/>
+                        </a:rPr>
+                        <a:t>2019</a:t>
+                      </a:r>
+                    </a:p>
+                  </a:txBody>
+                  <a:tcPr marL="27432" marR="27432" marT="9144" marB="9144" anchor="ctr">
+                    <a:lnL w="12700" cmpd="sng">
+                      <a:noFill/>
+                      <a:prstDash val="solid"/>
+                    </a:lnL>
+                    <a:lnR w="12700" cmpd="sng">
+                      <a:noFill/>
+                      <a:prstDash val="solid"/>
+                    </a:lnR>
+                    <a:lnT w="12700" cmpd="sng">
+                      <a:noFill/>
+                      <a:prstDash val="solid"/>
+                    </a:lnT>
+                    <a:lnB w="12700" cmpd="sng">
+                      <a:noFill/>
+                      <a:prstDash val="solid"/>
+                    </a:lnB>
+                    <a:lnTlToBr w="12700" cmpd="sng">
+                      <a:noFill/>
+                      <a:prstDash val="solid"/>
+                    </a:lnTlToBr>
+                    <a:lnBlToTr w="12700" cmpd="sng">
+                      <a:noFill/>
+                      <a:prstDash val="solid"/>
+                    </a:lnBlToTr>
+                    <a:noFill/>
+                  </a:tcPr>
+                </a:tc>
+                <a:tc>
+                  <a:txBody>
+                    <a:bodyPr/>
+                    <a:lstStyle/>
+                    <a:p>
+                      <a:pPr algn="r" rtl="0"/>
+                      <a:r>
+                        <a:rPr lang="pt-BR" sz="1100" b="0" noProof="0" dirty="0">
+                          <a:solidFill>
+                            <a:srgbClr val="002060"/>
+                          </a:solidFill>
+                          <a:latin typeface="Gadugi"/>
+                        </a:rPr>
+                        <a:t>316,5</a:t>
+                      </a:r>
+                    </a:p>
+                  </a:txBody>
+                  <a:tcPr marL="27432" marR="27432" marT="9144" marB="9144" anchor="ctr">
+                    <a:lnL w="12700" cmpd="sng">
+                      <a:noFill/>
+                      <a:prstDash val="solid"/>
+                    </a:lnL>
+                    <a:lnR w="12700" cmpd="sng">
+                      <a:noFill/>
+                      <a:prstDash val="solid"/>
+                    </a:lnR>
+                    <a:lnT w="12700" cmpd="sng">
+                      <a:noFill/>
+                      <a:prstDash val="solid"/>
+                    </a:lnT>
+                    <a:lnB w="12700" cmpd="sng">
+                      <a:noFill/>
+                      <a:prstDash val="solid"/>
+                    </a:lnB>
+                    <a:lnTlToBr w="12700" cmpd="sng">
+                      <a:noFill/>
+                      <a:prstDash val="solid"/>
+                    </a:lnTlToBr>
+                    <a:lnBlToTr w="12700" cmpd="sng">
+                      <a:noFill/>
+                      <a:prstDash val="solid"/>
+                    </a:lnBlToTr>
+                    <a:noFill/>
+                  </a:tcPr>
+                </a:tc>
+                <a:tc>
+                  <a:txBody>
+                    <a:bodyPr/>
+                    <a:lstStyle/>
+                    <a:p>
+                      <a:pPr algn="r" rtl="0"/>
+                      <a:r>
+                        <a:rPr lang="pt-BR" sz="1100" b="0" noProof="0" dirty="0">
+                          <a:solidFill>
+                            <a:srgbClr val="002060"/>
+                          </a:solidFill>
+                          <a:latin typeface="Gadugi"/>
+                        </a:rPr>
+                        <a:t>294,6</a:t>
+                      </a:r>
+                    </a:p>
+                  </a:txBody>
+                  <a:tcPr marL="27432" marR="27432" marT="9144" marB="9144" anchor="ctr">
+                    <a:lnL w="12700" cmpd="sng">
+                      <a:noFill/>
+                      <a:prstDash val="solid"/>
+                    </a:lnL>
+                    <a:lnR w="12700" cmpd="sng">
+                      <a:noFill/>
+                      <a:prstDash val="solid"/>
+                    </a:lnR>
+                    <a:lnT w="12700" cmpd="sng">
+                      <a:noFill/>
+                      <a:prstDash val="solid"/>
+                    </a:lnT>
+                    <a:lnB w="12700" cmpd="sng">
+                      <a:noFill/>
+                      <a:prstDash val="solid"/>
+                    </a:lnB>
+                    <a:lnTlToBr w="12700" cmpd="sng">
+                      <a:noFill/>
+                      <a:prstDash val="solid"/>
+                    </a:lnTlToBr>
+                    <a:lnBlToTr w="12700" cmpd="sng">
+                      <a:noFill/>
+                      <a:prstDash val="solid"/>
+                    </a:lnBlToTr>
+                    <a:noFill/>
+                  </a:tcPr>
+                </a:tc>
+                <a:tc>
+                  <a:txBody>
+                    <a:bodyPr/>
+                    <a:lstStyle/>
+                    <a:p>
+                      <a:pPr algn="r" rtl="0"/>
+                      <a:r>
+                        <a:rPr lang="pt-BR" sz="1100" b="0" noProof="0" dirty="0">
+                          <a:solidFill>
+                            <a:srgbClr val="00803C"/>
+                          </a:solidFill>
+                          <a:latin typeface="Gadugi"/>
+                        </a:rPr>
+                        <a:t>-7%</a:t>
+                      </a:r>
+                    </a:p>
+                  </a:txBody>
+                  <a:tcPr marL="27432" marR="27432" marT="9144" marB="9144" anchor="ctr">
+                    <a:lnL w="12700" cmpd="sng">
+                      <a:noFill/>
+                      <a:prstDash val="solid"/>
+                    </a:lnL>
+                    <a:lnR w="12700" cmpd="sng">
+                      <a:noFill/>
+                      <a:prstDash val="solid"/>
+                    </a:lnR>
+                    <a:lnT w="12700" cmpd="sng">
+                      <a:noFill/>
+                      <a:prstDash val="solid"/>
+                    </a:lnT>
+                    <a:lnB w="12700" cmpd="sng">
+                      <a:noFill/>
+                      <a:prstDash val="solid"/>
+                    </a:lnB>
+                    <a:lnTlToBr w="12700" cmpd="sng">
+                      <a:noFill/>
+                      <a:prstDash val="solid"/>
+                    </a:lnTlToBr>
+                    <a:lnBlToTr w="12700" cmpd="sng">
+                      <a:noFill/>
+                      <a:prstDash val="solid"/>
+                    </a:lnBlToTr>
+                    <a:noFill/>
+                  </a:tcPr>
+                </a:tc>
+                <a:tc>
+                  <a:txBody>
+                    <a:bodyPr/>
+                    <a:lstStyle/>
+                    <a:p>
+                      <a:pPr algn="r" rtl="0"/>
+                      <a:r>
+                        <a:rPr lang="pt-BR" sz="1100" b="1" noProof="0" dirty="0">
+                          <a:solidFill>
+                            <a:srgbClr val="002060"/>
+                          </a:solidFill>
+                          <a:latin typeface="Gadugi"/>
+                        </a:rPr>
+                        <a:t>427,3</a:t>
+                      </a:r>
+                    </a:p>
+                  </a:txBody>
+                  <a:tcPr marL="27432" marR="27432" marT="9144" marB="9144" anchor="ctr">
+                    <a:lnL w="12700" cmpd="sng">
+                      <a:noFill/>
+                      <a:prstDash val="solid"/>
+                    </a:lnL>
+                    <a:lnR w="12700" cmpd="sng">
+                      <a:noFill/>
+                      <a:prstDash val="solid"/>
+                    </a:lnR>
+                    <a:lnT w="12700" cmpd="sng">
+                      <a:noFill/>
+                      <a:prstDash val="solid"/>
+                    </a:lnT>
+                    <a:lnB w="12700" cmpd="sng">
+                      <a:noFill/>
+                      <a:prstDash val="solid"/>
+                    </a:lnB>
+                    <a:lnTlToBr w="12700" cmpd="sng">
+                      <a:noFill/>
+                      <a:prstDash val="solid"/>
+                    </a:lnTlToBr>
+                    <a:lnBlToTr w="12700" cmpd="sng">
+                      <a:noFill/>
+                      <a:prstDash val="solid"/>
+                    </a:lnBlToTr>
+                    <a:noFill/>
+                  </a:tcPr>
+                </a:tc>
+                <a:tc>
+                  <a:txBody>
+                    <a:bodyPr/>
+                    <a:lstStyle/>
+                    <a:p>
+                      <a:pPr algn="r" rtl="0"/>
+                      <a:r>
+                        <a:rPr lang="pt-BR" sz="1100" b="1" noProof="0" dirty="0">
+                          <a:solidFill>
+                            <a:srgbClr val="595959"/>
+                          </a:solidFill>
+                          <a:latin typeface="Gadugi"/>
+                        </a:rPr>
+                        <a:t>–</a:t>
+                      </a:r>
+                    </a:p>
+                  </a:txBody>
+                  <a:tcPr marL="27432" marR="27432" marT="9144" marB="9144" anchor="ctr">
+                    <a:lnL w="12700" cmpd="sng">
+                      <a:noFill/>
+                      <a:prstDash val="solid"/>
+                    </a:lnL>
+                    <a:lnR w="12700" cmpd="sng">
+                      <a:noFill/>
+                      <a:prstDash val="solid"/>
+                    </a:lnR>
+                    <a:lnT w="12700" cmpd="sng">
+                      <a:noFill/>
+                      <a:prstDash val="solid"/>
+                    </a:lnT>
+                    <a:lnB w="12700" cmpd="sng">
+                      <a:noFill/>
+                      <a:prstDash val="solid"/>
+                    </a:lnB>
+                    <a:lnTlToBr w="12700" cmpd="sng">
+                      <a:noFill/>
+                      <a:prstDash val="solid"/>
+                    </a:lnTlToBr>
+                    <a:lnBlToTr w="12700" cmpd="sng">
+                      <a:noFill/>
+                      <a:prstDash val="solid"/>
+                    </a:lnBlToTr>
+                    <a:noFill/>
+                  </a:tcPr>
+                </a:tc>
+                <a:extLst>
+                  <a:ext uri="{0D108BD9-81ED-4DB2-BD59-A6C34878D82A}">
+                    <a16:rowId xmlns:a16="http://schemas.microsoft.com/office/drawing/2014/main" val="10006"/>
+                  </a:ext>
+                </a:extLst>
+              </a:tr>
+              <a:tr h="246888">
+                <a:tc>
+                  <a:txBody>
+                    <a:bodyPr/>
+                    <a:lstStyle/>
+                    <a:p>
+                      <a:pPr marL="171450" indent="-171450" algn="l" rtl="0">
+                        <a:buFont typeface="Arial" panose="020B0604020202020204" pitchFamily="34" charset="0"/>
+                        <a:buChar char="•"/>
+                      </a:pPr>
+                      <a:r>
+                        <a:rPr lang="pt-BR" sz="1100" b="0" noProof="0" dirty="0">
+                          <a:solidFill>
+                            <a:schemeClr val="tx1"/>
+                          </a:solidFill>
+                          <a:latin typeface="Gadugi"/>
+                        </a:rPr>
+                        <a:t>2020</a:t>
+                      </a:r>
+                    </a:p>
+                  </a:txBody>
+                  <a:tcPr marL="27432" marR="27432" marT="9144" marB="9144" anchor="ctr">
+                    <a:lnL w="12700" cmpd="sng">
+                      <a:noFill/>
+                      <a:prstDash val="solid"/>
+                    </a:lnL>
+                    <a:lnR w="12700" cmpd="sng">
+                      <a:noFill/>
+                      <a:prstDash val="solid"/>
+                    </a:lnR>
+                    <a:lnT w="12700" cmpd="sng">
+                      <a:noFill/>
+                      <a:prstDash val="solid"/>
+                    </a:lnT>
+                    <a:lnB w="12700" cmpd="sng">
+                      <a:noFill/>
+                      <a:prstDash val="solid"/>
+                    </a:lnB>
+                    <a:lnTlToBr w="12700" cmpd="sng">
+                      <a:noFill/>
+                      <a:prstDash val="solid"/>
+                    </a:lnTlToBr>
+                    <a:lnBlToTr w="12700" cmpd="sng">
+                      <a:noFill/>
+                      <a:prstDash val="solid"/>
+                    </a:lnBlToTr>
+                    <a:noFill/>
+                  </a:tcPr>
+                </a:tc>
+                <a:tc>
+                  <a:txBody>
+                    <a:bodyPr/>
+                    <a:lstStyle/>
+                    <a:p>
+                      <a:pPr algn="r" rtl="0"/>
+                      <a:r>
+                        <a:rPr lang="pt-BR" sz="1100" b="0" noProof="0" dirty="0">
+                          <a:solidFill>
+                            <a:srgbClr val="002060"/>
+                          </a:solidFill>
+                          <a:latin typeface="Gadugi"/>
+                        </a:rPr>
+                        <a:t>338,9</a:t>
+                      </a:r>
+                    </a:p>
+                  </a:txBody>
+                  <a:tcPr marL="27432" marR="27432" marT="9144" marB="9144" anchor="ctr">
+                    <a:lnL w="12700" cmpd="sng">
+                      <a:noFill/>
+                      <a:prstDash val="solid"/>
+                    </a:lnL>
+                    <a:lnR w="12700" cmpd="sng">
+                      <a:noFill/>
+                      <a:prstDash val="solid"/>
+                    </a:lnR>
+                    <a:lnT w="12700" cmpd="sng">
+                      <a:noFill/>
+                      <a:prstDash val="solid"/>
+                    </a:lnT>
+                    <a:lnB w="12700" cmpd="sng">
+                      <a:noFill/>
+                      <a:prstDash val="solid"/>
+                    </a:lnB>
+                    <a:lnTlToBr w="12700" cmpd="sng">
+                      <a:noFill/>
+                      <a:prstDash val="solid"/>
+                    </a:lnTlToBr>
+                    <a:lnBlToTr w="12700" cmpd="sng">
+                      <a:noFill/>
+                      <a:prstDash val="solid"/>
+                    </a:lnBlToTr>
+                    <a:noFill/>
+                  </a:tcPr>
+                </a:tc>
+                <a:tc>
+                  <a:txBody>
+                    <a:bodyPr/>
+                    <a:lstStyle/>
+                    <a:p>
+                      <a:pPr algn="r" rtl="0"/>
+                      <a:r>
+                        <a:rPr lang="pt-BR" sz="1100" b="0" noProof="0" dirty="0">
+                          <a:solidFill>
+                            <a:srgbClr val="002060"/>
+                          </a:solidFill>
+                          <a:latin typeface="Gadugi"/>
+                        </a:rPr>
+                        <a:t>252,6</a:t>
+                      </a:r>
+                    </a:p>
+                  </a:txBody>
+                  <a:tcPr marL="27432" marR="27432" marT="9144" marB="9144" anchor="ctr">
+                    <a:lnL w="12700" cmpd="sng">
+                      <a:noFill/>
+                      <a:prstDash val="solid"/>
+                    </a:lnL>
+                    <a:lnR w="12700" cmpd="sng">
+                      <a:noFill/>
+                      <a:prstDash val="solid"/>
+                    </a:lnR>
+                    <a:lnT w="12700" cmpd="sng">
+                      <a:noFill/>
+                      <a:prstDash val="solid"/>
+                    </a:lnT>
+                    <a:lnB w="12700" cmpd="sng">
+                      <a:noFill/>
+                      <a:prstDash val="solid"/>
+                    </a:lnB>
+                    <a:lnTlToBr w="12700" cmpd="sng">
+                      <a:noFill/>
+                      <a:prstDash val="solid"/>
+                    </a:lnTlToBr>
+                    <a:lnBlToTr w="12700" cmpd="sng">
+                      <a:noFill/>
+                      <a:prstDash val="solid"/>
+                    </a:lnBlToTr>
+                    <a:noFill/>
+                  </a:tcPr>
+                </a:tc>
+                <a:tc>
+                  <a:txBody>
+                    <a:bodyPr/>
+                    <a:lstStyle/>
+                    <a:p>
+                      <a:pPr algn="r" rtl="0"/>
+                      <a:r>
+                        <a:rPr lang="pt-BR" sz="1100" b="0" noProof="0" dirty="0">
+                          <a:solidFill>
+                            <a:srgbClr val="00803C"/>
+                          </a:solidFill>
+                          <a:latin typeface="Gadugi"/>
+                        </a:rPr>
+                        <a:t>-25%</a:t>
+                      </a:r>
+                    </a:p>
+                  </a:txBody>
+                  <a:tcPr marL="27432" marR="27432" marT="9144" marB="9144" anchor="ctr">
+                    <a:lnL w="12700" cmpd="sng">
+                      <a:noFill/>
+                      <a:prstDash val="solid"/>
+                    </a:lnL>
+                    <a:lnR w="12700" cmpd="sng">
+                      <a:noFill/>
+                      <a:prstDash val="solid"/>
+                    </a:lnR>
+                    <a:lnT w="12700" cmpd="sng">
+                      <a:noFill/>
+                      <a:prstDash val="solid"/>
+                    </a:lnT>
+                    <a:lnB w="12700" cmpd="sng">
+                      <a:noFill/>
+                      <a:prstDash val="solid"/>
+                    </a:lnB>
+                    <a:lnTlToBr w="12700" cmpd="sng">
+                      <a:noFill/>
+                      <a:prstDash val="solid"/>
+                    </a:lnTlToBr>
+                    <a:lnBlToTr w="12700" cmpd="sng">
+                      <a:noFill/>
+                      <a:prstDash val="solid"/>
+                    </a:lnBlToTr>
+                    <a:noFill/>
+                  </a:tcPr>
+                </a:tc>
+                <a:tc>
+                  <a:txBody>
+                    <a:bodyPr/>
+                    <a:lstStyle/>
+                    <a:p>
+                      <a:pPr algn="r" rtl="0"/>
+                      <a:r>
+                        <a:rPr lang="pt-BR" sz="1100" b="1" noProof="0" dirty="0">
+                          <a:solidFill>
+                            <a:srgbClr val="002060"/>
+                          </a:solidFill>
+                          <a:latin typeface="Gadugi"/>
+                        </a:rPr>
+                        <a:t>350,5</a:t>
+                      </a:r>
+                    </a:p>
+                  </a:txBody>
+                  <a:tcPr marL="27432" marR="27432" marT="9144" marB="9144" anchor="ctr">
+                    <a:lnL w="12700" cmpd="sng">
+                      <a:noFill/>
+                      <a:prstDash val="solid"/>
+                    </a:lnL>
+                    <a:lnR w="12700" cmpd="sng">
+                      <a:noFill/>
+                      <a:prstDash val="solid"/>
+                    </a:lnR>
+                    <a:lnT w="12700" cmpd="sng">
+                      <a:noFill/>
+                      <a:prstDash val="solid"/>
+                    </a:lnT>
+                    <a:lnB w="12700" cmpd="sng">
+                      <a:noFill/>
+                      <a:prstDash val="solid"/>
+                    </a:lnB>
+                    <a:lnTlToBr w="12700" cmpd="sng">
+                      <a:noFill/>
+                      <a:prstDash val="solid"/>
+                    </a:lnTlToBr>
+                    <a:lnBlToTr w="12700" cmpd="sng">
+                      <a:noFill/>
+                      <a:prstDash val="solid"/>
+                    </a:lnBlToTr>
+                    <a:noFill/>
+                  </a:tcPr>
+                </a:tc>
+                <a:tc>
+                  <a:txBody>
+                    <a:bodyPr/>
+                    <a:lstStyle/>
+                    <a:p>
+                      <a:pPr algn="r" rtl="0"/>
+                      <a:r>
+                        <a:rPr lang="pt-BR" sz="1100" b="1" noProof="0" dirty="0">
+                          <a:solidFill>
+                            <a:srgbClr val="00803C"/>
+                          </a:solidFill>
+                          <a:latin typeface="Gadugi"/>
+                        </a:rPr>
+                        <a:t>-18%</a:t>
+                      </a:r>
+                    </a:p>
+                  </a:txBody>
+                  <a:tcPr marL="27432" marR="27432" marT="9144" marB="9144" anchor="ctr">
+                    <a:lnL w="12700" cmpd="sng">
+                      <a:noFill/>
+                      <a:prstDash val="solid"/>
+                    </a:lnL>
+                    <a:lnR w="12700" cmpd="sng">
+                      <a:noFill/>
+                      <a:prstDash val="solid"/>
+                    </a:lnR>
+                    <a:lnT w="12700" cmpd="sng">
+                      <a:noFill/>
+                      <a:prstDash val="solid"/>
+                    </a:lnT>
+                    <a:lnB w="12700" cmpd="sng">
+                      <a:noFill/>
+                      <a:prstDash val="solid"/>
+                    </a:lnB>
+                    <a:lnTlToBr w="12700" cmpd="sng">
+                      <a:noFill/>
+                      <a:prstDash val="solid"/>
+                    </a:lnTlToBr>
+                    <a:lnBlToTr w="12700" cmpd="sng">
+                      <a:noFill/>
+                      <a:prstDash val="solid"/>
+                    </a:lnBlToTr>
+                    <a:noFill/>
+                  </a:tcPr>
+                </a:tc>
+                <a:extLst>
+                  <a:ext uri="{0D108BD9-81ED-4DB2-BD59-A6C34878D82A}">
+                    <a16:rowId xmlns:a16="http://schemas.microsoft.com/office/drawing/2014/main" val="10007"/>
+                  </a:ext>
+                </a:extLst>
+              </a:tr>
+              <a:tr h="246888">
+                <a:tc>
+                  <a:txBody>
+                    <a:bodyPr/>
+                    <a:lstStyle/>
+                    <a:p>
+                      <a:pPr marL="171450" indent="-171450" algn="l" rtl="0">
+                        <a:buFont typeface="Arial" panose="020B0604020202020204" pitchFamily="34" charset="0"/>
+                        <a:buChar char="•"/>
+                      </a:pPr>
+                      <a:r>
+                        <a:rPr lang="pt-BR" sz="1100" b="0" noProof="0" dirty="0">
+                          <a:solidFill>
+                            <a:schemeClr val="tx1"/>
+                          </a:solidFill>
+                          <a:latin typeface="Gadugi"/>
+                        </a:rPr>
+                        <a:t>2021</a:t>
+                      </a:r>
+                    </a:p>
+                  </a:txBody>
+                  <a:tcPr marL="27432" marR="27432" marT="9144" marB="9144" anchor="ctr">
+                    <a:lnL w="12700" cmpd="sng">
+                      <a:noFill/>
+                      <a:prstDash val="solid"/>
+                    </a:lnL>
+                    <a:lnR w="12700" cmpd="sng">
+                      <a:noFill/>
+                      <a:prstDash val="solid"/>
+                    </a:lnR>
+                    <a:lnT w="12700" cmpd="sng">
+                      <a:noFill/>
+                      <a:prstDash val="solid"/>
+                    </a:lnT>
+                    <a:lnB w="12700" cmpd="sng">
+                      <a:noFill/>
+                      <a:prstDash val="solid"/>
+                    </a:lnB>
+                    <a:lnTlToBr w="12700" cmpd="sng">
+                      <a:noFill/>
+                      <a:prstDash val="solid"/>
+                    </a:lnTlToBr>
+                    <a:lnBlToTr w="12700" cmpd="sng">
+                      <a:noFill/>
+                      <a:prstDash val="solid"/>
+                    </a:lnBlToTr>
+                    <a:noFill/>
+                  </a:tcPr>
+                </a:tc>
+                <a:tc>
+                  <a:txBody>
+                    <a:bodyPr/>
+                    <a:lstStyle/>
+                    <a:p>
+                      <a:pPr algn="r" rtl="0"/>
+                      <a:r>
+                        <a:rPr lang="pt-BR" sz="1100" b="0" noProof="0" dirty="0">
+                          <a:solidFill>
+                            <a:srgbClr val="002060"/>
+                          </a:solidFill>
+                          <a:latin typeface="Gadugi"/>
+                        </a:rPr>
+                        <a:t>358,6</a:t>
+                      </a:r>
+                    </a:p>
+                  </a:txBody>
+                  <a:tcPr marL="27432" marR="27432" marT="9144" marB="9144" anchor="ctr">
+                    <a:lnL w="12700" cmpd="sng">
+                      <a:noFill/>
+                      <a:prstDash val="solid"/>
+                    </a:lnL>
+                    <a:lnR w="12700" cmpd="sng">
+                      <a:noFill/>
+                      <a:prstDash val="solid"/>
+                    </a:lnR>
+                    <a:lnT w="12700" cmpd="sng">
+                      <a:noFill/>
+                      <a:prstDash val="solid"/>
+                    </a:lnT>
+                    <a:lnB w="12700" cmpd="sng">
+                      <a:noFill/>
+                      <a:prstDash val="solid"/>
+                    </a:lnB>
+                    <a:lnTlToBr w="12700" cmpd="sng">
+                      <a:noFill/>
+                      <a:prstDash val="solid"/>
+                    </a:lnTlToBr>
+                    <a:lnBlToTr w="12700" cmpd="sng">
+                      <a:noFill/>
+                      <a:prstDash val="solid"/>
+                    </a:lnBlToTr>
+                    <a:noFill/>
+                  </a:tcPr>
+                </a:tc>
+                <a:tc>
+                  <a:txBody>
+                    <a:bodyPr/>
+                    <a:lstStyle/>
+                    <a:p>
+                      <a:pPr algn="r" rtl="0"/>
+                      <a:r>
+                        <a:rPr lang="pt-BR" sz="1100" b="0" noProof="0" dirty="0">
+                          <a:solidFill>
+                            <a:srgbClr val="002060"/>
+                          </a:solidFill>
+                          <a:latin typeface="Gadugi"/>
+                        </a:rPr>
+                        <a:t>254,9</a:t>
+                      </a:r>
+                    </a:p>
+                  </a:txBody>
+                  <a:tcPr marL="27432" marR="27432" marT="9144" marB="9144" anchor="ctr">
+                    <a:lnL w="12700" cmpd="sng">
+                      <a:noFill/>
+                      <a:prstDash val="solid"/>
+                    </a:lnL>
+                    <a:lnR w="12700" cmpd="sng">
+                      <a:noFill/>
+                      <a:prstDash val="solid"/>
+                    </a:lnR>
+                    <a:lnT w="12700" cmpd="sng">
+                      <a:noFill/>
+                      <a:prstDash val="solid"/>
+                    </a:lnT>
+                    <a:lnB w="12700" cmpd="sng">
+                      <a:noFill/>
+                      <a:prstDash val="solid"/>
+                    </a:lnB>
+                    <a:lnTlToBr w="12700" cmpd="sng">
+                      <a:noFill/>
+                      <a:prstDash val="solid"/>
+                    </a:lnTlToBr>
+                    <a:lnBlToTr w="12700" cmpd="sng">
+                      <a:noFill/>
+                      <a:prstDash val="solid"/>
+                    </a:lnBlToTr>
+                    <a:noFill/>
+                  </a:tcPr>
+                </a:tc>
+                <a:tc>
+                  <a:txBody>
+                    <a:bodyPr/>
+                    <a:lstStyle/>
+                    <a:p>
+                      <a:pPr algn="r" rtl="0"/>
+                      <a:r>
+                        <a:rPr lang="pt-BR" sz="1100" b="0" noProof="0" dirty="0">
+                          <a:solidFill>
+                            <a:srgbClr val="00803C"/>
+                          </a:solidFill>
+                          <a:latin typeface="Gadugi"/>
+                        </a:rPr>
+                        <a:t>-29%</a:t>
+                      </a:r>
+                    </a:p>
+                  </a:txBody>
+                  <a:tcPr marL="27432" marR="27432" marT="9144" marB="9144" anchor="ctr">
+                    <a:lnL w="12700" cmpd="sng">
+                      <a:noFill/>
+                      <a:prstDash val="solid"/>
+                    </a:lnL>
+                    <a:lnR w="12700" cmpd="sng">
+                      <a:noFill/>
+                      <a:prstDash val="solid"/>
+                    </a:lnR>
+                    <a:lnT w="12700" cmpd="sng">
+                      <a:noFill/>
+                      <a:prstDash val="solid"/>
+                    </a:lnT>
+                    <a:lnB w="12700" cmpd="sng">
+                      <a:noFill/>
+                      <a:prstDash val="solid"/>
+                    </a:lnB>
+                    <a:lnTlToBr w="12700" cmpd="sng">
+                      <a:noFill/>
+                      <a:prstDash val="solid"/>
+                    </a:lnTlToBr>
+                    <a:lnBlToTr w="12700" cmpd="sng">
+                      <a:noFill/>
+                      <a:prstDash val="solid"/>
+                    </a:lnBlToTr>
+                    <a:noFill/>
+                  </a:tcPr>
+                </a:tc>
+                <a:tc>
+                  <a:txBody>
+                    <a:bodyPr/>
+                    <a:lstStyle/>
+                    <a:p>
+                      <a:pPr algn="r" rtl="0"/>
+                      <a:r>
+                        <a:rPr lang="pt-BR" sz="1100" b="1" noProof="0" dirty="0">
+                          <a:solidFill>
+                            <a:srgbClr val="002060"/>
+                          </a:solidFill>
+                          <a:latin typeface="Gadugi"/>
+                        </a:rPr>
+                        <a:t>321,4</a:t>
+                      </a:r>
+                    </a:p>
+                  </a:txBody>
+                  <a:tcPr marL="27432" marR="27432" marT="9144" marB="9144" anchor="ctr">
+                    <a:lnL w="12700" cmpd="sng">
+                      <a:noFill/>
+                      <a:prstDash val="solid"/>
+                    </a:lnL>
+                    <a:lnR w="12700" cmpd="sng">
+                      <a:noFill/>
+                      <a:prstDash val="solid"/>
+                    </a:lnR>
+                    <a:lnT w="12700" cmpd="sng">
+                      <a:noFill/>
+                      <a:prstDash val="solid"/>
+                    </a:lnT>
+                    <a:lnB w="12700" cmpd="sng">
+                      <a:noFill/>
+                      <a:prstDash val="solid"/>
+                    </a:lnB>
+                    <a:lnTlToBr w="12700" cmpd="sng">
+                      <a:noFill/>
+                      <a:prstDash val="solid"/>
+                    </a:lnTlToBr>
+                    <a:lnBlToTr w="12700" cmpd="sng">
+                      <a:noFill/>
+                      <a:prstDash val="solid"/>
+                    </a:lnBlToTr>
+                    <a:noFill/>
+                  </a:tcPr>
+                </a:tc>
+                <a:tc>
+                  <a:txBody>
+                    <a:bodyPr/>
+                    <a:lstStyle/>
+                    <a:p>
+                      <a:pPr algn="r" rtl="0"/>
+                      <a:r>
+                        <a:rPr lang="pt-BR" sz="1100" b="1" noProof="0" dirty="0">
+                          <a:solidFill>
+                            <a:srgbClr val="00803C"/>
+                          </a:solidFill>
+                          <a:latin typeface="Gadugi"/>
+                        </a:rPr>
+                        <a:t>-8%</a:t>
+                      </a:r>
+                    </a:p>
+                  </a:txBody>
+                  <a:tcPr marL="27432" marR="27432" marT="9144" marB="9144" anchor="ctr">
+                    <a:lnL w="12700" cmpd="sng">
+                      <a:noFill/>
+                      <a:prstDash val="solid"/>
+                    </a:lnL>
+                    <a:lnR w="12700" cmpd="sng">
+                      <a:noFill/>
+                      <a:prstDash val="solid"/>
+                    </a:lnR>
+                    <a:lnT w="12700" cmpd="sng">
+                      <a:noFill/>
+                      <a:prstDash val="solid"/>
+                    </a:lnT>
+                    <a:lnB w="12700" cmpd="sng">
+                      <a:noFill/>
+                      <a:prstDash val="solid"/>
+                    </a:lnB>
+                    <a:lnTlToBr w="12700" cmpd="sng">
+                      <a:noFill/>
+                      <a:prstDash val="solid"/>
+                    </a:lnTlToBr>
+                    <a:lnBlToTr w="12700" cmpd="sng">
+                      <a:noFill/>
+                      <a:prstDash val="solid"/>
+                    </a:lnBlToTr>
+                    <a:noFill/>
+                  </a:tcPr>
+                </a:tc>
+                <a:extLst>
+                  <a:ext uri="{0D108BD9-81ED-4DB2-BD59-A6C34878D82A}">
+                    <a16:rowId xmlns:a16="http://schemas.microsoft.com/office/drawing/2014/main" val="10008"/>
+                  </a:ext>
+                </a:extLst>
+              </a:tr>
+              <a:tr h="246888">
+                <a:tc>
+                  <a:txBody>
+                    <a:bodyPr/>
+                    <a:lstStyle/>
+                    <a:p>
+                      <a:pPr marL="171450" indent="-171450" algn="l" rtl="0">
+                        <a:buFont typeface="Arial" panose="020B0604020202020204" pitchFamily="34" charset="0"/>
+                        <a:buChar char="•"/>
+                      </a:pPr>
+                      <a:r>
+                        <a:rPr lang="pt-BR" sz="1100" b="0" noProof="0" dirty="0">
+                          <a:solidFill>
+                            <a:schemeClr val="tx1"/>
+                          </a:solidFill>
+                          <a:latin typeface="Gadugi"/>
+                        </a:rPr>
+                        <a:t>2022</a:t>
+                      </a:r>
+                    </a:p>
+                  </a:txBody>
+                  <a:tcPr marL="27432" marR="27432" marT="9144" marB="9144" anchor="ctr">
+                    <a:lnL w="12700" cmpd="sng">
+                      <a:noFill/>
+                      <a:prstDash val="solid"/>
+                    </a:lnL>
+                    <a:lnR w="12700" cmpd="sng">
+                      <a:noFill/>
+                      <a:prstDash val="solid"/>
+                    </a:lnR>
+                    <a:lnT w="12700" cmpd="sng">
+                      <a:noFill/>
+                      <a:prstDash val="solid"/>
+                    </a:lnT>
+                    <a:lnB w="12700" cmpd="sng">
+                      <a:noFill/>
+                      <a:prstDash val="solid"/>
+                    </a:lnB>
+                    <a:lnTlToBr w="12700" cmpd="sng">
+                      <a:noFill/>
+                      <a:prstDash val="solid"/>
+                    </a:lnTlToBr>
+                    <a:lnBlToTr w="12700" cmpd="sng">
+                      <a:noFill/>
+                      <a:prstDash val="solid"/>
+                    </a:lnBlToTr>
+                    <a:noFill/>
+                  </a:tcPr>
+                </a:tc>
+                <a:tc>
+                  <a:txBody>
+                    <a:bodyPr/>
+                    <a:lstStyle/>
+                    <a:p>
+                      <a:pPr algn="r" rtl="0"/>
+                      <a:r>
+                        <a:rPr lang="pt-BR" sz="1100" b="0" noProof="0" dirty="0">
+                          <a:solidFill>
+                            <a:srgbClr val="002060"/>
+                          </a:solidFill>
+                          <a:latin typeface="Gadugi"/>
+                        </a:rPr>
+                        <a:t>386,9</a:t>
+                      </a:r>
+                    </a:p>
+                  </a:txBody>
+                  <a:tcPr marL="27432" marR="27432" marT="9144" marB="9144" anchor="ctr">
+                    <a:lnL w="12700" cmpd="sng">
+                      <a:noFill/>
+                      <a:prstDash val="solid"/>
+                    </a:lnL>
+                    <a:lnR w="12700" cmpd="sng">
+                      <a:noFill/>
+                      <a:prstDash val="solid"/>
+                    </a:lnR>
+                    <a:lnT w="12700" cmpd="sng">
+                      <a:noFill/>
+                      <a:prstDash val="solid"/>
+                    </a:lnT>
+                    <a:lnB w="12700" cmpd="sng">
+                      <a:noFill/>
+                      <a:prstDash val="solid"/>
+                    </a:lnB>
+                    <a:lnTlToBr w="12700" cmpd="sng">
+                      <a:noFill/>
+                      <a:prstDash val="solid"/>
+                    </a:lnTlToBr>
+                    <a:lnBlToTr w="12700" cmpd="sng">
+                      <a:noFill/>
+                      <a:prstDash val="solid"/>
+                    </a:lnBlToTr>
+                    <a:noFill/>
+                  </a:tcPr>
+                </a:tc>
+                <a:tc>
+                  <a:txBody>
+                    <a:bodyPr/>
+                    <a:lstStyle/>
+                    <a:p>
+                      <a:pPr algn="r" rtl="0"/>
+                      <a:r>
+                        <a:rPr lang="pt-BR" sz="1100" b="0" noProof="0" dirty="0">
+                          <a:solidFill>
+                            <a:srgbClr val="002060"/>
+                          </a:solidFill>
+                          <a:latin typeface="Gadugi"/>
+                        </a:rPr>
+                        <a:t>351,3</a:t>
+                      </a:r>
+                    </a:p>
+                  </a:txBody>
+                  <a:tcPr marL="27432" marR="27432" marT="9144" marB="9144" anchor="ctr">
+                    <a:lnL w="12700" cmpd="sng">
+                      <a:noFill/>
+                      <a:prstDash val="solid"/>
+                    </a:lnL>
+                    <a:lnR w="12700" cmpd="sng">
+                      <a:noFill/>
+                      <a:prstDash val="solid"/>
+                    </a:lnR>
+                    <a:lnT w="12700" cmpd="sng">
+                      <a:noFill/>
+                      <a:prstDash val="solid"/>
+                    </a:lnT>
+                    <a:lnB w="12700" cmpd="sng">
+                      <a:noFill/>
+                      <a:prstDash val="solid"/>
+                    </a:lnB>
+                    <a:lnTlToBr w="12700" cmpd="sng">
+                      <a:noFill/>
+                      <a:prstDash val="solid"/>
+                    </a:lnTlToBr>
+                    <a:lnBlToTr w="12700" cmpd="sng">
+                      <a:noFill/>
+                      <a:prstDash val="solid"/>
+                    </a:lnBlToTr>
+                    <a:noFill/>
+                  </a:tcPr>
+                </a:tc>
+                <a:tc>
+                  <a:txBody>
+                    <a:bodyPr/>
+                    <a:lstStyle/>
+                    <a:p>
+                      <a:pPr algn="r" rtl="0"/>
+                      <a:r>
+                        <a:rPr lang="pt-BR" sz="1100" b="0" noProof="0" dirty="0">
+                          <a:solidFill>
+                            <a:srgbClr val="00803C"/>
+                          </a:solidFill>
+                          <a:latin typeface="Gadugi"/>
+                        </a:rPr>
+                        <a:t>-9%</a:t>
+                      </a:r>
+                    </a:p>
+                  </a:txBody>
+                  <a:tcPr marL="27432" marR="27432" marT="9144" marB="9144" anchor="ctr">
+                    <a:lnL w="12700" cmpd="sng">
+                      <a:noFill/>
+                      <a:prstDash val="solid"/>
+                    </a:lnL>
+                    <a:lnR w="12700" cmpd="sng">
+                      <a:noFill/>
+                      <a:prstDash val="solid"/>
+                    </a:lnR>
+                    <a:lnT w="12700" cmpd="sng">
+                      <a:noFill/>
+                      <a:prstDash val="solid"/>
+                    </a:lnT>
+                    <a:lnB w="12700" cmpd="sng">
+                      <a:noFill/>
+                      <a:prstDash val="solid"/>
+                    </a:lnB>
+                    <a:lnTlToBr w="12700" cmpd="sng">
+                      <a:noFill/>
+                      <a:prstDash val="solid"/>
+                    </a:lnTlToBr>
+                    <a:lnBlToTr w="12700" cmpd="sng">
+                      <a:noFill/>
+                      <a:prstDash val="solid"/>
+                    </a:lnBlToTr>
+                    <a:noFill/>
+                  </a:tcPr>
+                </a:tc>
+                <a:tc>
+                  <a:txBody>
+                    <a:bodyPr/>
+                    <a:lstStyle/>
+                    <a:p>
+                      <a:pPr algn="r" rtl="0"/>
+                      <a:r>
+                        <a:rPr lang="pt-BR" sz="1100" b="1" noProof="0" dirty="0">
+                          <a:solidFill>
+                            <a:srgbClr val="002060"/>
+                          </a:solidFill>
+                          <a:latin typeface="Gadugi"/>
+                        </a:rPr>
+                        <a:t>418,7</a:t>
+                      </a:r>
+                    </a:p>
+                  </a:txBody>
+                  <a:tcPr marL="27432" marR="27432" marT="9144" marB="9144" anchor="ctr">
+                    <a:lnL w="12700" cmpd="sng">
+                      <a:noFill/>
+                      <a:prstDash val="solid"/>
+                    </a:lnL>
+                    <a:lnR w="12700" cmpd="sng">
+                      <a:noFill/>
+                      <a:prstDash val="solid"/>
+                    </a:lnR>
+                    <a:lnT w="12700" cmpd="sng">
+                      <a:noFill/>
+                      <a:prstDash val="solid"/>
+                    </a:lnT>
+                    <a:lnB w="12700" cmpd="sng">
+                      <a:noFill/>
+                      <a:prstDash val="solid"/>
+                    </a:lnB>
+                    <a:lnTlToBr w="12700" cmpd="sng">
+                      <a:noFill/>
+                      <a:prstDash val="solid"/>
+                    </a:lnTlToBr>
+                    <a:lnBlToTr w="12700" cmpd="sng">
+                      <a:noFill/>
+                      <a:prstDash val="solid"/>
+                    </a:lnBlToTr>
+                    <a:noFill/>
+                  </a:tcPr>
+                </a:tc>
+                <a:tc>
+                  <a:txBody>
+                    <a:bodyPr/>
+                    <a:lstStyle/>
+                    <a:p>
+                      <a:pPr algn="r" rtl="0"/>
+                      <a:r>
+                        <a:rPr lang="pt-BR" sz="1100" b="1" noProof="0" dirty="0">
+                          <a:solidFill>
+                            <a:srgbClr val="C00000"/>
+                          </a:solidFill>
+                          <a:latin typeface="Gadugi"/>
+                        </a:rPr>
+                        <a:t>+30%</a:t>
+                      </a:r>
+                    </a:p>
+                  </a:txBody>
+                  <a:tcPr marL="27432" marR="27432" marT="9144" marB="9144" anchor="ctr">
+                    <a:lnL w="12700" cmpd="sng">
+                      <a:noFill/>
+                      <a:prstDash val="solid"/>
+                    </a:lnL>
+                    <a:lnR w="12700" cmpd="sng">
+                      <a:noFill/>
+                      <a:prstDash val="solid"/>
+                    </a:lnR>
+                    <a:lnT w="12700" cmpd="sng">
+                      <a:noFill/>
+                      <a:prstDash val="solid"/>
+                    </a:lnT>
+                    <a:lnB w="12700" cmpd="sng">
+                      <a:noFill/>
+                      <a:prstDash val="solid"/>
+                    </a:lnB>
+                    <a:lnTlToBr w="12700" cmpd="sng">
+                      <a:noFill/>
+                      <a:prstDash val="solid"/>
+                    </a:lnTlToBr>
+                    <a:lnBlToTr w="12700" cmpd="sng">
+                      <a:noFill/>
+                      <a:prstDash val="solid"/>
+                    </a:lnBlToTr>
+                    <a:noFill/>
+                  </a:tcPr>
+                </a:tc>
+                <a:extLst>
+                  <a:ext uri="{0D108BD9-81ED-4DB2-BD59-A6C34878D82A}">
+                    <a16:rowId xmlns:a16="http://schemas.microsoft.com/office/drawing/2014/main" val="10009"/>
+                  </a:ext>
+                </a:extLst>
+              </a:tr>
+              <a:tr h="246888">
+                <a:tc>
+                  <a:txBody>
+                    <a:bodyPr/>
+                    <a:lstStyle/>
+                    <a:p>
+                      <a:pPr marL="171450" indent="-171450" algn="l" rtl="0">
+                        <a:buFont typeface="Arial" panose="020B0604020202020204" pitchFamily="34" charset="0"/>
+                        <a:buChar char="•"/>
+                      </a:pPr>
+                      <a:r>
+                        <a:rPr lang="pt-BR" sz="1100" b="0" noProof="0" dirty="0">
+                          <a:solidFill>
+                            <a:schemeClr val="tx1"/>
+                          </a:solidFill>
+                          <a:latin typeface="Gadugi"/>
+                        </a:rPr>
+                        <a:t>2023</a:t>
+                      </a:r>
+                    </a:p>
+                  </a:txBody>
+                  <a:tcPr marL="27432" marR="27432" marT="9144" marB="9144" anchor="ctr">
+                    <a:lnL w="12700" cmpd="sng">
+                      <a:noFill/>
+                      <a:prstDash val="solid"/>
+                    </a:lnL>
+                    <a:lnR w="12700" cmpd="sng">
+                      <a:noFill/>
+                      <a:prstDash val="solid"/>
+                    </a:lnR>
+                    <a:lnT w="12700" cmpd="sng">
+                      <a:noFill/>
+                      <a:prstDash val="solid"/>
+                    </a:lnT>
+                    <a:lnB w="12700" cmpd="sng">
+                      <a:noFill/>
+                      <a:prstDash val="solid"/>
+                    </a:lnB>
+                    <a:lnTlToBr w="12700" cmpd="sng">
+                      <a:noFill/>
+                      <a:prstDash val="solid"/>
+                    </a:lnTlToBr>
+                    <a:lnBlToTr w="12700" cmpd="sng">
+                      <a:noFill/>
+                      <a:prstDash val="solid"/>
+                    </a:lnBlToTr>
+                    <a:noFill/>
+                  </a:tcPr>
+                </a:tc>
+                <a:tc>
+                  <a:txBody>
+                    <a:bodyPr/>
+                    <a:lstStyle/>
+                    <a:p>
+                      <a:pPr algn="r" rtl="0"/>
+                      <a:r>
+                        <a:rPr lang="pt-BR" sz="1100" b="0" noProof="0" dirty="0">
+                          <a:solidFill>
+                            <a:srgbClr val="002060"/>
+                          </a:solidFill>
+                          <a:latin typeface="Gadugi"/>
+                        </a:rPr>
+                        <a:t>375,3</a:t>
+                      </a:r>
+                    </a:p>
+                  </a:txBody>
+                  <a:tcPr marL="27432" marR="27432" marT="9144" marB="9144" anchor="ctr">
+                    <a:lnL w="12700" cmpd="sng">
+                      <a:noFill/>
+                      <a:prstDash val="solid"/>
+                    </a:lnL>
+                    <a:lnR w="12700" cmpd="sng">
+                      <a:noFill/>
+                      <a:prstDash val="solid"/>
+                    </a:lnR>
+                    <a:lnT w="12700" cmpd="sng">
+                      <a:noFill/>
+                      <a:prstDash val="solid"/>
+                    </a:lnT>
+                    <a:lnB w="12700" cmpd="sng">
+                      <a:noFill/>
+                      <a:prstDash val="solid"/>
+                    </a:lnB>
+                    <a:lnTlToBr w="12700" cmpd="sng">
+                      <a:noFill/>
+                      <a:prstDash val="solid"/>
+                    </a:lnTlToBr>
+                    <a:lnBlToTr w="12700" cmpd="sng">
+                      <a:noFill/>
+                      <a:prstDash val="solid"/>
+                    </a:lnBlToTr>
+                    <a:noFill/>
+                  </a:tcPr>
+                </a:tc>
+                <a:tc>
+                  <a:txBody>
+                    <a:bodyPr/>
+                    <a:lstStyle/>
+                    <a:p>
+                      <a:pPr algn="r" rtl="0"/>
+                      <a:r>
+                        <a:rPr lang="pt-BR" sz="1100" b="0" noProof="0" dirty="0">
+                          <a:solidFill>
+                            <a:srgbClr val="002060"/>
+                          </a:solidFill>
+                          <a:latin typeface="Gadugi"/>
+                        </a:rPr>
+                        <a:t>364,7</a:t>
+                      </a:r>
+                    </a:p>
+                  </a:txBody>
+                  <a:tcPr marL="27432" marR="27432" marT="9144" marB="9144" anchor="ctr">
+                    <a:lnL w="12700" cmpd="sng">
+                      <a:noFill/>
+                      <a:prstDash val="solid"/>
+                    </a:lnL>
+                    <a:lnR w="12700" cmpd="sng">
+                      <a:noFill/>
+                      <a:prstDash val="solid"/>
+                    </a:lnR>
+                    <a:lnT w="12700" cmpd="sng">
+                      <a:noFill/>
+                      <a:prstDash val="solid"/>
+                    </a:lnT>
+                    <a:lnB w="12700" cmpd="sng">
+                      <a:noFill/>
+                      <a:prstDash val="solid"/>
+                    </a:lnB>
+                    <a:lnTlToBr w="12700" cmpd="sng">
+                      <a:noFill/>
+                      <a:prstDash val="solid"/>
+                    </a:lnTlToBr>
+                    <a:lnBlToTr w="12700" cmpd="sng">
+                      <a:noFill/>
+                      <a:prstDash val="solid"/>
+                    </a:lnBlToTr>
+                    <a:noFill/>
+                  </a:tcPr>
+                </a:tc>
+                <a:tc>
+                  <a:txBody>
+                    <a:bodyPr/>
+                    <a:lstStyle/>
+                    <a:p>
+                      <a:pPr algn="r" rtl="0"/>
+                      <a:r>
+                        <a:rPr lang="pt-BR" sz="1100" b="0" noProof="0" dirty="0">
+                          <a:solidFill>
+                            <a:srgbClr val="00803C"/>
+                          </a:solidFill>
+                          <a:latin typeface="Gadugi"/>
+                        </a:rPr>
+                        <a:t>-3%</a:t>
+                      </a:r>
+                    </a:p>
+                  </a:txBody>
+                  <a:tcPr marL="27432" marR="27432" marT="9144" marB="9144" anchor="ctr">
+                    <a:lnL w="12700" cmpd="sng">
+                      <a:noFill/>
+                      <a:prstDash val="solid"/>
+                    </a:lnL>
+                    <a:lnR w="12700" cmpd="sng">
+                      <a:noFill/>
+                      <a:prstDash val="solid"/>
+                    </a:lnR>
+                    <a:lnT w="12700" cmpd="sng">
+                      <a:noFill/>
+                      <a:prstDash val="solid"/>
+                    </a:lnT>
+                    <a:lnB w="12700" cmpd="sng">
+                      <a:noFill/>
+                      <a:prstDash val="solid"/>
+                    </a:lnB>
+                    <a:lnTlToBr w="12700" cmpd="sng">
+                      <a:noFill/>
+                      <a:prstDash val="solid"/>
+                    </a:lnTlToBr>
+                    <a:lnBlToTr w="12700" cmpd="sng">
+                      <a:noFill/>
+                      <a:prstDash val="solid"/>
+                    </a:lnBlToTr>
+                    <a:noFill/>
+                  </a:tcPr>
+                </a:tc>
+                <a:tc>
+                  <a:txBody>
+                    <a:bodyPr/>
+                    <a:lstStyle/>
+                    <a:p>
+                      <a:pPr algn="r" rtl="0"/>
+                      <a:r>
+                        <a:rPr lang="pt-BR" sz="1100" b="1" noProof="0" dirty="0">
+                          <a:solidFill>
+                            <a:srgbClr val="002060"/>
+                          </a:solidFill>
+                          <a:latin typeface="Gadugi"/>
+                        </a:rPr>
+                        <a:t>415,4</a:t>
+                      </a:r>
+                    </a:p>
+                  </a:txBody>
+                  <a:tcPr marL="27432" marR="27432" marT="9144" marB="9144" anchor="ctr">
+                    <a:lnL w="12700" cmpd="sng">
+                      <a:noFill/>
+                      <a:prstDash val="solid"/>
+                    </a:lnL>
+                    <a:lnR w="12700" cmpd="sng">
+                      <a:noFill/>
+                      <a:prstDash val="solid"/>
+                    </a:lnR>
+                    <a:lnT w="12700" cmpd="sng">
+                      <a:noFill/>
+                      <a:prstDash val="solid"/>
+                    </a:lnT>
+                    <a:lnB w="12700" cmpd="sng">
+                      <a:noFill/>
+                      <a:prstDash val="solid"/>
+                    </a:lnB>
+                    <a:lnTlToBr w="12700" cmpd="sng">
+                      <a:noFill/>
+                      <a:prstDash val="solid"/>
+                    </a:lnTlToBr>
+                    <a:lnBlToTr w="12700" cmpd="sng">
+                      <a:noFill/>
+                      <a:prstDash val="solid"/>
+                    </a:lnBlToTr>
+                    <a:noFill/>
+                  </a:tcPr>
+                </a:tc>
+                <a:tc>
+                  <a:txBody>
+                    <a:bodyPr/>
+                    <a:lstStyle/>
+                    <a:p>
+                      <a:pPr algn="r" rtl="0"/>
+                      <a:r>
+                        <a:rPr lang="pt-BR" sz="1100" b="1" noProof="0" dirty="0">
+                          <a:solidFill>
+                            <a:srgbClr val="00803C"/>
+                          </a:solidFill>
+                          <a:latin typeface="Gadugi"/>
+                        </a:rPr>
+                        <a:t>-1%</a:t>
+                      </a:r>
+                    </a:p>
+                  </a:txBody>
+                  <a:tcPr marL="27432" marR="27432" marT="9144" marB="9144" anchor="ctr">
+                    <a:lnL w="12700" cmpd="sng">
+                      <a:noFill/>
+                      <a:prstDash val="solid"/>
+                    </a:lnL>
+                    <a:lnR w="12700" cmpd="sng">
+                      <a:noFill/>
+                      <a:prstDash val="solid"/>
+                    </a:lnR>
+                    <a:lnT w="12700" cmpd="sng">
+                      <a:noFill/>
+                      <a:prstDash val="solid"/>
+                    </a:lnT>
+                    <a:lnB w="12700" cmpd="sng">
+                      <a:noFill/>
+                      <a:prstDash val="solid"/>
+                    </a:lnB>
+                    <a:lnTlToBr w="12700" cmpd="sng">
+                      <a:noFill/>
+                      <a:prstDash val="solid"/>
+                    </a:lnTlToBr>
+                    <a:lnBlToTr w="12700" cmpd="sng">
+                      <a:noFill/>
+                      <a:prstDash val="solid"/>
+                    </a:lnBlToTr>
+                    <a:noFill/>
+                  </a:tcPr>
+                </a:tc>
+                <a:extLst>
+                  <a:ext uri="{0D108BD9-81ED-4DB2-BD59-A6C34878D82A}">
+                    <a16:rowId xmlns:a16="http://schemas.microsoft.com/office/drawing/2014/main" val="10010"/>
+                  </a:ext>
+                </a:extLst>
+              </a:tr>
+              <a:tr h="246888">
+                <a:tc>
+                  <a:txBody>
+                    <a:bodyPr/>
+                    <a:lstStyle/>
+                    <a:p>
+                      <a:pPr marL="171450" indent="-171450" algn="l" rtl="0">
+                        <a:buFont typeface="Arial" panose="020B0604020202020204" pitchFamily="34" charset="0"/>
+                        <a:buChar char="•"/>
+                      </a:pPr>
+                      <a:r>
+                        <a:rPr lang="pt-BR" sz="1100" b="0" noProof="0" dirty="0">
+                          <a:solidFill>
+                            <a:schemeClr val="tx1"/>
+                          </a:solidFill>
+                          <a:latin typeface="Gadugi"/>
+                        </a:rPr>
+                        <a:t>2024</a:t>
+                      </a:r>
+                    </a:p>
+                  </a:txBody>
+                  <a:tcPr marL="27432" marR="27432" marT="9144" marB="9144" anchor="ctr">
+                    <a:lnL w="12700" cmpd="sng">
+                      <a:noFill/>
+                      <a:prstDash val="solid"/>
+                    </a:lnL>
+                    <a:lnR w="12700" cmpd="sng">
+                      <a:noFill/>
+                      <a:prstDash val="solid"/>
+                    </a:lnR>
+                    <a:lnT w="12700" cmpd="sng">
+                      <a:noFill/>
+                      <a:prstDash val="solid"/>
+                    </a:lnT>
+                    <a:lnB w="12700" cmpd="sng">
+                      <a:noFill/>
+                      <a:prstDash val="solid"/>
+                    </a:lnB>
+                    <a:lnTlToBr w="12700" cmpd="sng">
+                      <a:noFill/>
+                      <a:prstDash val="solid"/>
+                    </a:lnTlToBr>
+                    <a:lnBlToTr w="12700" cmpd="sng">
+                      <a:noFill/>
+                      <a:prstDash val="solid"/>
+                    </a:lnBlToTr>
+                    <a:noFill/>
+                  </a:tcPr>
+                </a:tc>
+                <a:tc>
+                  <a:txBody>
+                    <a:bodyPr/>
+                    <a:lstStyle/>
+                    <a:p>
+                      <a:pPr algn="r" rtl="0"/>
+                      <a:r>
+                        <a:rPr lang="pt-BR" sz="1100" b="0" noProof="0" dirty="0">
+                          <a:solidFill>
+                            <a:srgbClr val="002060"/>
+                          </a:solidFill>
+                          <a:latin typeface="Gadugi"/>
+                        </a:rPr>
+                        <a:t>298,2</a:t>
+                      </a:r>
+                    </a:p>
+                  </a:txBody>
+                  <a:tcPr marL="27432" marR="27432" marT="9144" marB="9144" anchor="ctr">
+                    <a:lnL w="12700" cmpd="sng">
+                      <a:noFill/>
+                      <a:prstDash val="solid"/>
+                    </a:lnL>
+                    <a:lnR w="12700" cmpd="sng">
+                      <a:noFill/>
+                      <a:prstDash val="solid"/>
+                    </a:lnR>
+                    <a:lnT w="12700" cmpd="sng">
+                      <a:noFill/>
+                      <a:prstDash val="solid"/>
+                    </a:lnT>
+                    <a:lnB w="12700" cmpd="sng">
+                      <a:noFill/>
+                      <a:prstDash val="solid"/>
+                    </a:lnB>
+                    <a:lnTlToBr w="12700" cmpd="sng">
+                      <a:noFill/>
+                      <a:prstDash val="solid"/>
+                    </a:lnTlToBr>
+                    <a:lnBlToTr w="12700" cmpd="sng">
+                      <a:noFill/>
+                      <a:prstDash val="solid"/>
+                    </a:lnBlToTr>
+                    <a:noFill/>
+                  </a:tcPr>
+                </a:tc>
+                <a:tc>
+                  <a:txBody>
+                    <a:bodyPr/>
+                    <a:lstStyle/>
+                    <a:p>
+                      <a:pPr algn="r" rtl="0"/>
+                      <a:r>
+                        <a:rPr lang="pt-BR" sz="1100" b="0" noProof="0" dirty="0">
+                          <a:solidFill>
+                            <a:srgbClr val="002060"/>
+                          </a:solidFill>
+                          <a:latin typeface="Gadugi"/>
+                        </a:rPr>
+                        <a:t>288,1</a:t>
+                      </a:r>
+                    </a:p>
+                  </a:txBody>
+                  <a:tcPr marL="27432" marR="27432" marT="9144" marB="9144" anchor="ctr">
+                    <a:lnL w="12700" cmpd="sng">
+                      <a:noFill/>
+                      <a:prstDash val="solid"/>
+                    </a:lnL>
+                    <a:lnR w="12700" cmpd="sng">
+                      <a:noFill/>
+                      <a:prstDash val="solid"/>
+                    </a:lnR>
+                    <a:lnT w="12700" cmpd="sng">
+                      <a:noFill/>
+                      <a:prstDash val="solid"/>
+                    </a:lnT>
+                    <a:lnB w="12700" cmpd="sng">
+                      <a:noFill/>
+                      <a:prstDash val="solid"/>
+                    </a:lnB>
+                    <a:lnTlToBr w="12700" cmpd="sng">
+                      <a:noFill/>
+                      <a:prstDash val="solid"/>
+                    </a:lnTlToBr>
+                    <a:lnBlToTr w="12700" cmpd="sng">
+                      <a:noFill/>
+                      <a:prstDash val="solid"/>
+                    </a:lnBlToTr>
+                    <a:noFill/>
+                  </a:tcPr>
+                </a:tc>
+                <a:tc>
+                  <a:txBody>
+                    <a:bodyPr/>
+                    <a:lstStyle/>
+                    <a:p>
+                      <a:pPr algn="r" rtl="0"/>
+                      <a:r>
+                        <a:rPr lang="pt-BR" sz="1100" b="0" noProof="0" dirty="0">
+                          <a:solidFill>
+                            <a:srgbClr val="00803C"/>
+                          </a:solidFill>
+                          <a:latin typeface="Gadugi"/>
+                        </a:rPr>
+                        <a:t>-3%</a:t>
+                      </a:r>
+                    </a:p>
+                  </a:txBody>
+                  <a:tcPr marL="27432" marR="27432" marT="9144" marB="9144" anchor="ctr">
+                    <a:lnL w="12700" cmpd="sng">
+                      <a:noFill/>
+                      <a:prstDash val="solid"/>
+                    </a:lnL>
+                    <a:lnR w="12700" cmpd="sng">
+                      <a:noFill/>
+                      <a:prstDash val="solid"/>
+                    </a:lnR>
+                    <a:lnT w="12700" cmpd="sng">
+                      <a:noFill/>
+                      <a:prstDash val="solid"/>
+                    </a:lnT>
+                    <a:lnB w="12700" cmpd="sng">
+                      <a:noFill/>
+                      <a:prstDash val="solid"/>
+                    </a:lnB>
+                    <a:lnTlToBr w="12700" cmpd="sng">
+                      <a:noFill/>
+                      <a:prstDash val="solid"/>
+                    </a:lnTlToBr>
+                    <a:lnBlToTr w="12700" cmpd="sng">
+                      <a:noFill/>
+                      <a:prstDash val="solid"/>
+                    </a:lnBlToTr>
+                    <a:noFill/>
+                  </a:tcPr>
+                </a:tc>
+                <a:tc>
+                  <a:txBody>
+                    <a:bodyPr/>
+                    <a:lstStyle/>
+                    <a:p>
+                      <a:pPr algn="r" rtl="0"/>
+                      <a:r>
+                        <a:rPr lang="pt-BR" sz="1100" b="1" noProof="0" dirty="0">
+                          <a:solidFill>
+                            <a:srgbClr val="002060"/>
+                          </a:solidFill>
+                          <a:latin typeface="Gadugi"/>
+                        </a:rPr>
+                        <a:t>313,1</a:t>
+                      </a:r>
+                    </a:p>
+                  </a:txBody>
+                  <a:tcPr marL="27432" marR="27432" marT="9144" marB="9144" anchor="ctr">
+                    <a:lnL w="12700" cmpd="sng">
+                      <a:noFill/>
+                      <a:prstDash val="solid"/>
+                    </a:lnL>
+                    <a:lnR w="12700" cmpd="sng">
+                      <a:noFill/>
+                      <a:prstDash val="solid"/>
+                    </a:lnR>
+                    <a:lnT w="12700" cmpd="sng">
+                      <a:noFill/>
+                      <a:prstDash val="solid"/>
+                    </a:lnT>
+                    <a:lnB w="12700" cmpd="sng">
+                      <a:noFill/>
+                      <a:prstDash val="solid"/>
+                    </a:lnB>
+                    <a:lnTlToBr w="12700" cmpd="sng">
+                      <a:noFill/>
+                      <a:prstDash val="solid"/>
+                    </a:lnTlToBr>
+                    <a:lnBlToTr w="12700" cmpd="sng">
+                      <a:noFill/>
+                      <a:prstDash val="solid"/>
+                    </a:lnBlToTr>
+                    <a:noFill/>
+                  </a:tcPr>
+                </a:tc>
+                <a:tc>
+                  <a:txBody>
+                    <a:bodyPr/>
+                    <a:lstStyle/>
+                    <a:p>
+                      <a:pPr algn="r" rtl="0"/>
+                      <a:r>
+                        <a:rPr lang="pt-BR" sz="1100" b="1" noProof="0" dirty="0">
+                          <a:solidFill>
+                            <a:srgbClr val="00803C"/>
+                          </a:solidFill>
+                          <a:latin typeface="Gadugi"/>
+                        </a:rPr>
+                        <a:t>-25%</a:t>
+                      </a:r>
+                    </a:p>
+                  </a:txBody>
+                  <a:tcPr marL="27432" marR="27432" marT="9144" marB="9144" anchor="ctr">
+                    <a:lnL w="12700" cmpd="sng">
+                      <a:noFill/>
+                      <a:prstDash val="solid"/>
+                    </a:lnL>
+                    <a:lnR w="12700" cmpd="sng">
+                      <a:noFill/>
+                      <a:prstDash val="solid"/>
+                    </a:lnR>
+                    <a:lnT w="12700" cmpd="sng">
+                      <a:noFill/>
+                      <a:prstDash val="solid"/>
+                    </a:lnT>
+                    <a:lnB w="12700" cmpd="sng">
+                      <a:noFill/>
+                      <a:prstDash val="solid"/>
+                    </a:lnB>
+                    <a:lnTlToBr w="12700" cmpd="sng">
+                      <a:noFill/>
+                      <a:prstDash val="solid"/>
+                    </a:lnTlToBr>
+                    <a:lnBlToTr w="12700" cmpd="sng">
+                      <a:noFill/>
+                      <a:prstDash val="solid"/>
+                    </a:lnBlToTr>
+                    <a:noFill/>
+                  </a:tcPr>
+                </a:tc>
+                <a:extLst>
+                  <a:ext uri="{0D108BD9-81ED-4DB2-BD59-A6C34878D82A}">
+                    <a16:rowId xmlns:a16="http://schemas.microsoft.com/office/drawing/2014/main" val="20006"/>
+                  </a:ext>
+                </a:extLst>
+              </a:tr>
+              <a:tr h="246888">
+                <a:tc>
+                  <a:txBody>
+                    <a:bodyPr/>
+                    <a:lstStyle/>
+                    <a:p>
+                      <a:pPr marL="171450" indent="-171450" algn="l" rtl="0">
+                        <a:buFont typeface="Arial" panose="020B0604020202020204" pitchFamily="34" charset="0"/>
+                        <a:buChar char="•"/>
+                      </a:pPr>
+                      <a:r>
+                        <a:rPr lang="pt-BR" sz="1100" b="0" noProof="0" dirty="0">
+                          <a:solidFill>
+                            <a:schemeClr val="tx1"/>
+                          </a:solidFill>
+                          <a:latin typeface="Gadugi"/>
+                        </a:rPr>
+                        <a:t>2025</a:t>
+                      </a:r>
+                    </a:p>
+                  </a:txBody>
+                  <a:tcPr marL="27432" marR="27432" marT="9144" marB="9144" anchor="ctr">
+                    <a:lnL w="12700" cmpd="sng">
+                      <a:noFill/>
+                      <a:prstDash val="solid"/>
+                    </a:lnL>
+                    <a:lnR w="12700" cmpd="sng">
+                      <a:noFill/>
+                      <a:prstDash val="solid"/>
+                    </a:lnR>
+                    <a:lnT w="12700" cmpd="sng">
+                      <a:noFill/>
+                      <a:prstDash val="solid"/>
+                    </a:lnT>
+                    <a:lnB w="12700" cmpd="sng">
+                      <a:noFill/>
+                      <a:prstDash val="solid"/>
+                    </a:lnB>
+                    <a:lnTlToBr w="12700" cmpd="sng">
+                      <a:noFill/>
+                      <a:prstDash val="solid"/>
+                    </a:lnTlToBr>
+                    <a:lnBlToTr w="12700" cmpd="sng">
+                      <a:noFill/>
+                      <a:prstDash val="solid"/>
+                    </a:lnBlToTr>
+                    <a:noFill/>
+                  </a:tcPr>
+                </a:tc>
+                <a:tc>
+                  <a:txBody>
+                    <a:bodyPr/>
+                    <a:lstStyle/>
+                    <a:p>
+                      <a:pPr algn="r" rtl="0"/>
+                      <a:r>
+                        <a:rPr lang="pt-BR" sz="1100" b="0" noProof="0" dirty="0">
+                          <a:solidFill>
+                            <a:srgbClr val="002060"/>
+                          </a:solidFill>
+                          <a:latin typeface="Gadugi"/>
+                        </a:rPr>
+                        <a:t>317,6</a:t>
+                      </a:r>
+                    </a:p>
+                  </a:txBody>
+                  <a:tcPr marL="27432" marR="27432" marT="9144" marB="9144" anchor="ctr">
+                    <a:lnL w="12700" cmpd="sng">
+                      <a:noFill/>
+                      <a:prstDash val="solid"/>
+                    </a:lnL>
+                    <a:lnR w="12700" cmpd="sng">
+                      <a:noFill/>
+                      <a:prstDash val="solid"/>
+                    </a:lnR>
+                    <a:lnT w="12700" cmpd="sng">
+                      <a:noFill/>
+                      <a:prstDash val="solid"/>
+                    </a:lnT>
+                    <a:lnB w="12700" cmpd="sng">
+                      <a:noFill/>
+                      <a:prstDash val="solid"/>
+                    </a:lnB>
+                    <a:lnTlToBr w="12700" cmpd="sng">
+                      <a:noFill/>
+                      <a:prstDash val="solid"/>
+                    </a:lnTlToBr>
+                    <a:lnBlToTr w="12700" cmpd="sng">
+                      <a:noFill/>
+                      <a:prstDash val="solid"/>
+                    </a:lnBlToTr>
+                    <a:noFill/>
+                  </a:tcPr>
+                </a:tc>
+                <a:tc>
+                  <a:txBody>
+                    <a:bodyPr/>
+                    <a:lstStyle/>
+                    <a:p>
+                      <a:pPr algn="r" rtl="0"/>
+                      <a:r>
+                        <a:rPr lang="pt-BR" sz="1100" b="0" noProof="0" dirty="0">
+                          <a:solidFill>
+                            <a:srgbClr val="002060"/>
+                          </a:solidFill>
+                          <a:latin typeface="Gadugi"/>
+                        </a:rPr>
+                        <a:t>302,9</a:t>
+                      </a:r>
+                    </a:p>
+                  </a:txBody>
+                  <a:tcPr marL="27432" marR="27432" marT="9144" marB="9144" anchor="ctr">
+                    <a:lnL w="12700" cmpd="sng">
+                      <a:noFill/>
+                      <a:prstDash val="solid"/>
+                    </a:lnL>
+                    <a:lnR w="12700" cmpd="sng">
+                      <a:noFill/>
+                      <a:prstDash val="solid"/>
+                    </a:lnR>
+                    <a:lnT w="12700" cmpd="sng">
+                      <a:noFill/>
+                      <a:prstDash val="solid"/>
+                    </a:lnT>
+                    <a:lnB w="12700" cmpd="sng">
+                      <a:noFill/>
+                      <a:prstDash val="solid"/>
+                    </a:lnB>
+                    <a:lnTlToBr w="12700" cmpd="sng">
+                      <a:noFill/>
+                      <a:prstDash val="solid"/>
+                    </a:lnTlToBr>
+                    <a:lnBlToTr w="12700" cmpd="sng">
+                      <a:noFill/>
+                      <a:prstDash val="solid"/>
+                    </a:lnBlToTr>
+                    <a:noFill/>
+                  </a:tcPr>
+                </a:tc>
+                <a:tc>
+                  <a:txBody>
+                    <a:bodyPr/>
+                    <a:lstStyle/>
+                    <a:p>
+                      <a:pPr algn="r" rtl="0"/>
+                      <a:r>
+                        <a:rPr lang="pt-BR" sz="1100" b="0" noProof="0" dirty="0">
+                          <a:solidFill>
+                            <a:srgbClr val="00803C"/>
+                          </a:solidFill>
+                          <a:latin typeface="Gadugi"/>
+                        </a:rPr>
+                        <a:t>-5%</a:t>
+                      </a:r>
+                    </a:p>
+                  </a:txBody>
+                  <a:tcPr marL="27432" marR="27432" marT="9144" marB="9144" anchor="ctr">
+                    <a:lnL w="12700" cmpd="sng">
+                      <a:noFill/>
+                      <a:prstDash val="solid"/>
+                    </a:lnL>
+                    <a:lnR w="12700" cmpd="sng">
+                      <a:noFill/>
+                      <a:prstDash val="solid"/>
+                    </a:lnR>
+                    <a:lnT w="12700" cmpd="sng">
+                      <a:noFill/>
+                      <a:prstDash val="solid"/>
+                    </a:lnT>
+                    <a:lnB w="12700" cmpd="sng">
+                      <a:noFill/>
+                      <a:prstDash val="solid"/>
+                    </a:lnB>
+                    <a:lnTlToBr w="12700" cmpd="sng">
+                      <a:noFill/>
+                      <a:prstDash val="solid"/>
+                    </a:lnTlToBr>
+                    <a:lnBlToTr w="12700" cmpd="sng">
+                      <a:noFill/>
+                      <a:prstDash val="solid"/>
+                    </a:lnBlToTr>
+                    <a:noFill/>
+                  </a:tcPr>
+                </a:tc>
+                <a:tc>
+                  <a:txBody>
+                    <a:bodyPr/>
+                    <a:lstStyle/>
+                    <a:p>
+                      <a:pPr algn="r" rtl="0"/>
+                      <a:r>
+                        <a:rPr lang="pt-BR" sz="1100" b="1" noProof="0" dirty="0">
+                          <a:solidFill>
+                            <a:srgbClr val="002060"/>
+                          </a:solidFill>
+                          <a:latin typeface="Gadugi"/>
+                        </a:rPr>
+                        <a:t>315,7</a:t>
+                      </a:r>
+                    </a:p>
+                  </a:txBody>
+                  <a:tcPr marL="27432" marR="27432" marT="9144" marB="9144" anchor="ctr">
+                    <a:lnL w="12700" cmpd="sng">
+                      <a:noFill/>
+                      <a:prstDash val="solid"/>
+                    </a:lnL>
+                    <a:lnR w="12700" cmpd="sng">
+                      <a:noFill/>
+                      <a:prstDash val="solid"/>
+                    </a:lnR>
+                    <a:lnT w="12700" cmpd="sng">
+                      <a:noFill/>
+                      <a:prstDash val="solid"/>
+                    </a:lnT>
+                    <a:lnB w="12700" cmpd="sng">
+                      <a:noFill/>
+                      <a:prstDash val="solid"/>
+                    </a:lnB>
+                    <a:lnTlToBr w="12700" cmpd="sng">
+                      <a:noFill/>
+                      <a:prstDash val="solid"/>
+                    </a:lnTlToBr>
+                    <a:lnBlToTr w="12700" cmpd="sng">
+                      <a:noFill/>
+                      <a:prstDash val="solid"/>
+                    </a:lnBlToTr>
+                    <a:noFill/>
+                  </a:tcPr>
+                </a:tc>
+                <a:tc>
+                  <a:txBody>
+                    <a:bodyPr/>
+                    <a:lstStyle/>
+                    <a:p>
+                      <a:pPr algn="r" rtl="0"/>
+                      <a:r>
+                        <a:rPr lang="pt-BR" sz="1100" b="1" noProof="0" dirty="0">
+                          <a:solidFill>
+                            <a:srgbClr val="C00000"/>
+                          </a:solidFill>
+                          <a:latin typeface="Gadugi"/>
+                        </a:rPr>
+                        <a:t>+1%</a:t>
+                      </a:r>
+                    </a:p>
+                  </a:txBody>
+                  <a:tcPr marL="27432" marR="27432" marT="9144" marB="9144" anchor="ctr">
+                    <a:lnL w="12700" cmpd="sng">
+                      <a:noFill/>
+                      <a:prstDash val="solid"/>
+                    </a:lnL>
+                    <a:lnR w="12700" cmpd="sng">
+                      <a:noFill/>
+                      <a:prstDash val="solid"/>
+                    </a:lnR>
+                    <a:lnT w="12700" cmpd="sng">
+                      <a:noFill/>
+                      <a:prstDash val="solid"/>
+                    </a:lnT>
+                    <a:lnB w="12700" cmpd="sng">
+                      <a:noFill/>
+                      <a:prstDash val="solid"/>
+                    </a:lnB>
+                    <a:lnTlToBr w="12700" cmpd="sng">
+                      <a:noFill/>
+                      <a:prstDash val="solid"/>
+                    </a:lnTlToBr>
+                    <a:lnBlToTr w="12700" cmpd="sng">
+                      <a:noFill/>
+                      <a:prstDash val="solid"/>
+                    </a:lnBlToTr>
+                    <a:noFill/>
+                  </a:tcPr>
+                </a:tc>
+                <a:extLst>
+                  <a:ext uri="{0D108BD9-81ED-4DB2-BD59-A6C34878D82A}">
+                    <a16:rowId xmlns:a16="http://schemas.microsoft.com/office/drawing/2014/main" val="20007"/>
+                  </a:ext>
+                </a:extLst>
+              </a:tr>
+              <a:tr h="246888">
+                <a:tc>
+                  <a:txBody>
+                    <a:bodyPr/>
+                    <a:lstStyle/>
+                    <a:p>
+                      <a:pPr marL="171450" indent="-171450" algn="l" rtl="0">
+                        <a:buFont typeface="Arial" panose="020B0604020202020204" pitchFamily="34" charset="0"/>
+                        <a:buChar char="•"/>
+                      </a:pPr>
+                      <a:r>
+                        <a:rPr lang="pt-BR" sz="1100" b="0" noProof="0" dirty="0">
+                          <a:solidFill>
+                            <a:schemeClr val="tx1"/>
+                          </a:solidFill>
+                          <a:latin typeface="Gadugi"/>
+                        </a:rPr>
+                        <a:t>2026²</a:t>
+                      </a:r>
+                    </a:p>
+                  </a:txBody>
+                  <a:tcPr marL="27432" marR="27432" marT="9144" marB="9144" anchor="ctr">
+                    <a:lnL w="12700" cmpd="sng">
+                      <a:noFill/>
+                      <a:prstDash val="solid"/>
+                    </a:lnL>
+                    <a:lnR w="12700" cmpd="sng">
+                      <a:noFill/>
+                      <a:prstDash val="solid"/>
+                    </a:lnR>
+                    <a:lnT w="12700" cmpd="sng">
+                      <a:noFill/>
+                      <a:prstDash val="solid"/>
+                    </a:lnT>
+                    <a:lnB w="12700" cap="flat" cmpd="sng" algn="ctr">
+                      <a:solidFill>
+                        <a:schemeClr val="tx1"/>
+                      </a:solidFill>
+                      <a:prstDash val="solid"/>
+                      <a:round/>
+                      <a:headEnd type="none" w="med" len="med"/>
+                      <a:tailEnd type="none" w="med" len="med"/>
+                    </a:lnB>
+                    <a:lnTlToBr w="12700" cmpd="sng">
+                      <a:noFill/>
+                      <a:prstDash val="solid"/>
+                    </a:lnTlToBr>
+                    <a:lnBlToTr w="12700" cmpd="sng">
+                      <a:noFill/>
+                      <a:prstDash val="solid"/>
+                    </a:lnBlToTr>
+                    <a:noFill/>
+                  </a:tcPr>
+                </a:tc>
+                <a:tc>
+                  <a:txBody>
+                    <a:bodyPr/>
+                    <a:lstStyle/>
+                    <a:p>
+                      <a:pPr algn="r" rtl="0"/>
+                      <a:r>
+                        <a:rPr lang="pt-BR" sz="1100" b="0" noProof="0" dirty="0">
+                          <a:solidFill>
+                            <a:srgbClr val="002060"/>
+                          </a:solidFill>
+                          <a:latin typeface="Gadugi"/>
+                        </a:rPr>
+                        <a:t>275,4</a:t>
+                      </a:r>
+                    </a:p>
+                  </a:txBody>
+                  <a:tcPr marL="27432" marR="27432" marT="9144" marB="9144" anchor="ctr">
+                    <a:lnL w="12700" cmpd="sng">
+                      <a:noFill/>
+                      <a:prstDash val="solid"/>
+                    </a:lnL>
+                    <a:lnR w="12700" cmpd="sng">
+                      <a:noFill/>
+                      <a:prstDash val="solid"/>
+                    </a:lnR>
+                    <a:lnT w="12700" cmpd="sng">
+                      <a:noFill/>
+                      <a:prstDash val="solid"/>
+                    </a:lnT>
+                    <a:lnB w="12700" cap="flat" cmpd="sng" algn="ctr">
+                      <a:solidFill>
+                        <a:schemeClr val="tx1"/>
+                      </a:solidFill>
+                      <a:prstDash val="solid"/>
+                      <a:round/>
+                      <a:headEnd type="none" w="med" len="med"/>
+                      <a:tailEnd type="none" w="med" len="med"/>
+                    </a:lnB>
+                    <a:lnTlToBr w="12700" cmpd="sng">
+                      <a:noFill/>
+                      <a:prstDash val="solid"/>
+                    </a:lnTlToBr>
+                    <a:lnBlToTr w="12700" cmpd="sng">
+                      <a:noFill/>
+                      <a:prstDash val="solid"/>
+                    </a:lnBlToTr>
+                    <a:noFill/>
+                  </a:tcPr>
+                </a:tc>
+                <a:tc>
+                  <a:txBody>
+                    <a:bodyPr/>
+                    <a:lstStyle/>
+                    <a:p>
+                      <a:pPr algn="r" rtl="0"/>
+                      <a:r>
+                        <a:rPr lang="pt-BR" sz="1100" b="0" noProof="0" dirty="0">
+                          <a:solidFill>
+                            <a:srgbClr val="002060"/>
+                          </a:solidFill>
+                          <a:latin typeface="Gadugi"/>
+                        </a:rPr>
+                        <a:t>280,6</a:t>
+                      </a:r>
+                    </a:p>
+                  </a:txBody>
+                  <a:tcPr marL="27432" marR="27432" marT="9144" marB="9144" anchor="ctr">
+                    <a:lnL w="12700" cmpd="sng">
+                      <a:noFill/>
+                      <a:prstDash val="solid"/>
+                    </a:lnL>
+                    <a:lnR w="12700" cmpd="sng">
+                      <a:noFill/>
+                      <a:prstDash val="solid"/>
+                    </a:lnR>
+                    <a:lnT w="12700" cmpd="sng">
+                      <a:noFill/>
+                      <a:prstDash val="solid"/>
+                    </a:lnT>
+                    <a:lnB w="12700" cap="flat" cmpd="sng" algn="ctr">
+                      <a:solidFill>
+                        <a:schemeClr val="tx1"/>
+                      </a:solidFill>
+                      <a:prstDash val="solid"/>
+                      <a:round/>
+                      <a:headEnd type="none" w="med" len="med"/>
+                      <a:tailEnd type="none" w="med" len="med"/>
+                    </a:lnB>
+                    <a:lnTlToBr w="12700" cmpd="sng">
+                      <a:noFill/>
+                      <a:prstDash val="solid"/>
+                    </a:lnTlToBr>
+                    <a:lnBlToTr w="12700" cmpd="sng">
+                      <a:noFill/>
+                      <a:prstDash val="solid"/>
+                    </a:lnBlToTr>
+                    <a:noFill/>
+                  </a:tcPr>
+                </a:tc>
+                <a:tc>
+                  <a:txBody>
+                    <a:bodyPr/>
+                    <a:lstStyle/>
+                    <a:p>
+                      <a:pPr algn="r" rtl="0"/>
+                      <a:r>
+                        <a:rPr lang="pt-BR" sz="1100" b="0" noProof="0" dirty="0">
+                          <a:solidFill>
+                            <a:srgbClr val="C00000"/>
+                          </a:solidFill>
+                          <a:latin typeface="Gadugi"/>
+                        </a:rPr>
+                        <a:t>+2%</a:t>
+                      </a:r>
+                    </a:p>
+                  </a:txBody>
+                  <a:tcPr marL="27432" marR="27432" marT="9144" marB="9144" anchor="ctr">
+                    <a:lnL w="12700" cmpd="sng">
+                      <a:noFill/>
+                      <a:prstDash val="solid"/>
+                    </a:lnL>
+                    <a:lnR w="12700" cmpd="sng">
+                      <a:noFill/>
+                      <a:prstDash val="solid"/>
+                    </a:lnR>
+                    <a:lnT w="12700" cmpd="sng">
+                      <a:noFill/>
+                      <a:prstDash val="solid"/>
+                    </a:lnT>
+                    <a:lnB w="12700" cap="flat" cmpd="sng" algn="ctr">
+                      <a:solidFill>
+                        <a:schemeClr val="tx1"/>
+                      </a:solidFill>
+                      <a:prstDash val="solid"/>
+                      <a:round/>
+                      <a:headEnd type="none" w="med" len="med"/>
+                      <a:tailEnd type="none" w="med" len="med"/>
+                    </a:lnB>
+                    <a:lnTlToBr w="12700" cmpd="sng">
+                      <a:noFill/>
+                      <a:prstDash val="solid"/>
+                    </a:lnTlToBr>
+                    <a:lnBlToTr w="12700" cmpd="sng">
+                      <a:noFill/>
+                      <a:prstDash val="solid"/>
+                    </a:lnBlToTr>
+                    <a:noFill/>
+                  </a:tcPr>
+                </a:tc>
+                <a:tc>
+                  <a:txBody>
+                    <a:bodyPr/>
+                    <a:lstStyle/>
+                    <a:p>
+                      <a:pPr algn="r" rtl="0"/>
+                      <a:r>
+                        <a:rPr lang="pt-BR" sz="1100" b="1" noProof="0" dirty="0">
+                          <a:solidFill>
+                            <a:srgbClr val="002060"/>
+                          </a:solidFill>
+                          <a:latin typeface="Gadugi"/>
+                        </a:rPr>
+                        <a:t>280,6</a:t>
+                      </a:r>
+                    </a:p>
+                  </a:txBody>
+                  <a:tcPr marL="27432" marR="27432" marT="9144" marB="9144" anchor="ctr">
+                    <a:lnL w="12700" cmpd="sng">
+                      <a:noFill/>
+                      <a:prstDash val="solid"/>
+                    </a:lnL>
+                    <a:lnR w="12700" cmpd="sng">
+                      <a:noFill/>
+                      <a:prstDash val="solid"/>
+                    </a:lnR>
+                    <a:lnT w="12700" cmpd="sng">
+                      <a:noFill/>
+                      <a:prstDash val="solid"/>
+                    </a:lnT>
+                    <a:lnB w="12700" cap="flat" cmpd="sng" algn="ctr">
+                      <a:solidFill>
+                        <a:schemeClr val="tx1"/>
+                      </a:solidFill>
+                      <a:prstDash val="solid"/>
+                      <a:round/>
+                      <a:headEnd type="none" w="med" len="med"/>
+                      <a:tailEnd type="none" w="med" len="med"/>
+                    </a:lnB>
+                    <a:lnTlToBr w="12700" cmpd="sng">
+                      <a:noFill/>
+                      <a:prstDash val="solid"/>
+                    </a:lnTlToBr>
+                    <a:lnBlToTr w="12700" cmpd="sng">
+                      <a:noFill/>
+                      <a:prstDash val="solid"/>
+                    </a:lnBlToTr>
+                    <a:noFill/>
+                  </a:tcPr>
+                </a:tc>
+                <a:tc>
+                  <a:txBody>
+                    <a:bodyPr/>
+                    <a:lstStyle/>
+                    <a:p>
+                      <a:pPr algn="r" rtl="0"/>
+                      <a:r>
+                        <a:rPr lang="pt-BR" sz="1100" b="1" noProof="0" dirty="0">
+                          <a:solidFill>
+                            <a:srgbClr val="00803C"/>
+                          </a:solidFill>
+                          <a:latin typeface="Gadugi"/>
+                        </a:rPr>
+                        <a:t>-11%</a:t>
+                      </a:r>
+                    </a:p>
+                  </a:txBody>
+                  <a:tcPr marL="27432" marR="27432" marT="9144" marB="9144" anchor="ctr">
+                    <a:lnL w="12700" cmpd="sng">
+                      <a:noFill/>
+                      <a:prstDash val="solid"/>
+                    </a:lnL>
+                    <a:lnR w="12700" cmpd="sng">
+                      <a:noFill/>
+                      <a:prstDash val="solid"/>
+                    </a:lnR>
+                    <a:lnT w="12700" cmpd="sng">
+                      <a:noFill/>
+                      <a:prstDash val="solid"/>
+                    </a:lnT>
+                    <a:lnB w="12700" cap="flat" cmpd="sng" algn="ctr">
+                      <a:solidFill>
+                        <a:schemeClr val="tx1"/>
+                      </a:solidFill>
+                      <a:prstDash val="solid"/>
+                      <a:round/>
+                      <a:headEnd type="none" w="med" len="med"/>
+                      <a:tailEnd type="none" w="med" len="med"/>
+                    </a:lnB>
+                    <a:lnTlToBr w="12700" cmpd="sng">
+                      <a:noFill/>
+                      <a:prstDash val="solid"/>
+                    </a:lnTlToBr>
+                    <a:lnBlToTr w="12700" cmpd="sng">
+                      <a:noFill/>
+                      <a:prstDash val="solid"/>
+                    </a:lnBlToTr>
+                    <a:noFill/>
+                  </a:tcPr>
+                </a:tc>
+                <a:extLst>
+                  <a:ext uri="{0D108BD9-81ED-4DB2-BD59-A6C34878D82A}">
+                    <a16:rowId xmlns:a16="http://schemas.microsoft.com/office/drawing/2014/main" val="20008"/>
+                  </a:ext>
+                </a:extLst>
+              </a:tr>
+              <a:tr h="246888">
+                <a:tc>
+                  <a:txBody>
+                    <a:bodyPr/>
+                    <a:lstStyle/>
+                    <a:p>
+                      <a:pPr algn="l" rtl="0"/>
+                      <a:r>
+                        <a:rPr lang="pt-BR" sz="1100" b="1" noProof="0" dirty="0">
+                          <a:solidFill>
+                            <a:schemeClr val="tx1"/>
+                          </a:solidFill>
+                          <a:latin typeface="Gadugi"/>
+                        </a:rPr>
+                        <a:t>2019 → 2026</a:t>
+                      </a:r>
+                    </a:p>
+                  </a:txBody>
+                  <a:tcPr marL="27432" marR="27432" marT="9144" marB="9144" anchor="ctr">
+                    <a:lnL w="12700" cmpd="sng">
+                      <a:noFill/>
+                      <a:prstDash val="solid"/>
+                    </a:lnL>
+                    <a:lnR w="12700" cmpd="sng">
+                      <a:noFill/>
+                      <a:prstDash val="solid"/>
+                    </a:lnR>
+                    <a:lnT w="12700" cap="flat" cmpd="sng" algn="ctr">
+                      <a:solidFill>
+                        <a:schemeClr val="tx1"/>
+                      </a:solidFill>
+                      <a:prstDash val="solid"/>
+                      <a:round/>
+                      <a:headEnd type="none" w="med" len="med"/>
+                      <a:tailEnd type="none" w="med" len="med"/>
+                    </a:lnT>
+                    <a:lnB w="12700" cmpd="sng">
+                      <a:noFill/>
+                      <a:prstDash val="solid"/>
+                    </a:lnB>
+                    <a:lnTlToBr w="12700" cmpd="sng">
+                      <a:noFill/>
+                      <a:prstDash val="solid"/>
+                    </a:lnTlToBr>
+                    <a:lnBlToTr w="12700" cmpd="sng">
+                      <a:noFill/>
+                      <a:prstDash val="solid"/>
+                    </a:lnBlToTr>
+                    <a:noFill/>
+                  </a:tcPr>
+                </a:tc>
+                <a:tc>
+                  <a:txBody>
+                    <a:bodyPr/>
+                    <a:lstStyle/>
+                    <a:p>
+                      <a:pPr algn="r" rtl="0"/>
+                      <a:r>
+                        <a:rPr lang="pt-BR" sz="1100" b="1" noProof="0" dirty="0">
+                          <a:solidFill>
+                            <a:srgbClr val="002060"/>
+                          </a:solidFill>
+                          <a:latin typeface="Gadugi"/>
+                        </a:rPr>
+                        <a:t>-13%</a:t>
+                      </a:r>
+                    </a:p>
+                  </a:txBody>
+                  <a:tcPr marL="27432" marR="27432" marT="9144" marB="9144" anchor="ctr">
+                    <a:lnL w="12700" cmpd="sng">
+                      <a:noFill/>
+                      <a:prstDash val="solid"/>
+                    </a:lnL>
+                    <a:lnR w="12700" cmpd="sng">
+                      <a:noFill/>
+                      <a:prstDash val="solid"/>
+                    </a:lnR>
+                    <a:lnT w="12700" cap="flat" cmpd="sng" algn="ctr">
+                      <a:solidFill>
+                        <a:schemeClr val="tx1"/>
+                      </a:solidFill>
+                      <a:prstDash val="solid"/>
+                      <a:round/>
+                      <a:headEnd type="none" w="med" len="med"/>
+                      <a:tailEnd type="none" w="med" len="med"/>
+                    </a:lnT>
+                    <a:lnB w="12700" cmpd="sng">
+                      <a:noFill/>
+                      <a:prstDash val="solid"/>
+                    </a:lnB>
+                    <a:lnTlToBr w="12700" cmpd="sng">
+                      <a:noFill/>
+                      <a:prstDash val="solid"/>
+                    </a:lnTlToBr>
+                    <a:lnBlToTr w="12700" cmpd="sng">
+                      <a:noFill/>
+                      <a:prstDash val="solid"/>
+                    </a:lnBlToTr>
+                    <a:noFill/>
+                  </a:tcPr>
+                </a:tc>
+                <a:tc>
+                  <a:txBody>
+                    <a:bodyPr/>
+                    <a:lstStyle/>
+                    <a:p>
+                      <a:pPr algn="r" rtl="0"/>
+                      <a:r>
+                        <a:rPr lang="pt-BR" sz="1100" b="1" noProof="0" dirty="0">
+                          <a:solidFill>
+                            <a:srgbClr val="002060"/>
+                          </a:solidFill>
+                          <a:latin typeface="Gadugi"/>
+                        </a:rPr>
+                        <a:t>-5%</a:t>
+                      </a:r>
+                    </a:p>
+                  </a:txBody>
+                  <a:tcPr marL="27432" marR="27432" marT="9144" marB="9144" anchor="ctr">
+                    <a:lnL w="12700" cmpd="sng">
+                      <a:noFill/>
+                      <a:prstDash val="solid"/>
+                    </a:lnL>
+                    <a:lnR w="12700" cmpd="sng">
+                      <a:noFill/>
+                      <a:prstDash val="solid"/>
+                    </a:lnR>
+                    <a:lnT w="12700" cap="flat" cmpd="sng" algn="ctr">
+                      <a:solidFill>
+                        <a:schemeClr val="tx1"/>
+                      </a:solidFill>
+                      <a:prstDash val="solid"/>
+                      <a:round/>
+                      <a:headEnd type="none" w="med" len="med"/>
+                      <a:tailEnd type="none" w="med" len="med"/>
+                    </a:lnT>
+                    <a:lnB w="12700" cmpd="sng">
+                      <a:noFill/>
+                      <a:prstDash val="solid"/>
+                    </a:lnB>
+                    <a:lnTlToBr w="12700" cmpd="sng">
+                      <a:noFill/>
+                      <a:prstDash val="solid"/>
+                    </a:lnTlToBr>
+                    <a:lnBlToTr w="12700" cmpd="sng">
+                      <a:noFill/>
+                      <a:prstDash val="solid"/>
+                    </a:lnBlToTr>
+                    <a:noFill/>
+                  </a:tcPr>
+                </a:tc>
+                <a:tc>
+                  <a:txBody>
+                    <a:bodyPr/>
+                    <a:lstStyle/>
+                    <a:p>
+                      <a:pPr algn="r" rtl="0"/>
+                      <a:r>
+                        <a:rPr lang="pt-BR" sz="1100" b="1" noProof="0" dirty="0">
+                          <a:solidFill>
+                            <a:srgbClr val="002060"/>
+                          </a:solidFill>
+                          <a:latin typeface="Gadugi"/>
+                        </a:rPr>
+                        <a:t>–</a:t>
+                      </a:r>
+                    </a:p>
+                  </a:txBody>
+                  <a:tcPr marL="27432" marR="27432" marT="9144" marB="9144" anchor="ctr">
+                    <a:lnL w="12700" cmpd="sng">
+                      <a:noFill/>
+                      <a:prstDash val="solid"/>
+                    </a:lnL>
+                    <a:lnR w="12700" cmpd="sng">
+                      <a:noFill/>
+                      <a:prstDash val="solid"/>
+                    </a:lnR>
+                    <a:lnT w="12700" cap="flat" cmpd="sng" algn="ctr">
+                      <a:solidFill>
+                        <a:schemeClr val="tx1"/>
+                      </a:solidFill>
+                      <a:prstDash val="solid"/>
+                      <a:round/>
+                      <a:headEnd type="none" w="med" len="med"/>
+                      <a:tailEnd type="none" w="med" len="med"/>
+                    </a:lnT>
+                    <a:lnB w="12700" cmpd="sng">
+                      <a:noFill/>
+                      <a:prstDash val="solid"/>
+                    </a:lnB>
+                    <a:lnTlToBr w="12700" cmpd="sng">
+                      <a:noFill/>
+                      <a:prstDash val="solid"/>
+                    </a:lnTlToBr>
+                    <a:lnBlToTr w="12700" cmpd="sng">
+                      <a:noFill/>
+                      <a:prstDash val="solid"/>
+                    </a:lnBlToTr>
+                    <a:noFill/>
+                  </a:tcPr>
+                </a:tc>
+                <a:tc>
+                  <a:txBody>
+                    <a:bodyPr/>
+                    <a:lstStyle/>
+                    <a:p>
+                      <a:pPr algn="r" rtl="0"/>
+                      <a:r>
+                        <a:rPr lang="pt-BR" sz="1100" b="1" noProof="0" dirty="0">
+                          <a:solidFill>
+                            <a:srgbClr val="00803C"/>
+                          </a:solidFill>
+                          <a:latin typeface="Gadugi"/>
+                        </a:rPr>
+                        <a:t>-34%</a:t>
+                      </a:r>
+                    </a:p>
+                  </a:txBody>
+                  <a:tcPr marL="27432" marR="27432" marT="9144" marB="9144" anchor="ctr">
+                    <a:lnL w="12700" cmpd="sng">
+                      <a:noFill/>
+                      <a:prstDash val="solid"/>
+                    </a:lnL>
+                    <a:lnR w="12700" cmpd="sng">
+                      <a:noFill/>
+                      <a:prstDash val="solid"/>
+                    </a:lnR>
+                    <a:lnT w="12700" cap="flat" cmpd="sng" algn="ctr">
+                      <a:solidFill>
+                        <a:schemeClr val="tx1"/>
+                      </a:solidFill>
+                      <a:prstDash val="solid"/>
+                      <a:round/>
+                      <a:headEnd type="none" w="med" len="med"/>
+                      <a:tailEnd type="none" w="med" len="med"/>
+                    </a:lnT>
+                    <a:lnB w="12700" cmpd="sng">
+                      <a:noFill/>
+                      <a:prstDash val="solid"/>
+                    </a:lnB>
+                    <a:lnTlToBr w="12700" cmpd="sng">
+                      <a:noFill/>
+                      <a:prstDash val="solid"/>
+                    </a:lnTlToBr>
+                    <a:lnBlToTr w="12700" cmpd="sng">
+                      <a:noFill/>
+                      <a:prstDash val="solid"/>
+                    </a:lnBlToTr>
+                    <a:noFill/>
+                  </a:tcPr>
+                </a:tc>
+                <a:tc>
+                  <a:txBody>
+                    <a:bodyPr/>
+                    <a:lstStyle/>
+                    <a:p>
+                      <a:pPr algn="r" rtl="0"/>
+                      <a:r>
+                        <a:rPr lang="pt-BR" sz="1100" b="1" noProof="0" dirty="0">
+                          <a:solidFill>
+                            <a:srgbClr val="00803C"/>
+                          </a:solidFill>
+                          <a:latin typeface="Gadugi"/>
+                        </a:rPr>
+                        <a:t>-5,8% a.a.</a:t>
+                      </a:r>
+                    </a:p>
+                  </a:txBody>
+                  <a:tcPr marL="27432" marR="27432" marT="9144" marB="9144" anchor="ctr">
+                    <a:lnL w="12700" cmpd="sng">
+                      <a:noFill/>
+                      <a:prstDash val="solid"/>
+                    </a:lnL>
+                    <a:lnR w="12700" cmpd="sng">
+                      <a:noFill/>
+                      <a:prstDash val="solid"/>
+                    </a:lnR>
+                    <a:lnT w="12700" cap="flat" cmpd="sng" algn="ctr">
+                      <a:solidFill>
+                        <a:schemeClr val="tx1"/>
+                      </a:solidFill>
+                      <a:prstDash val="solid"/>
+                      <a:round/>
+                      <a:headEnd type="none" w="med" len="med"/>
+                      <a:tailEnd type="none" w="med" len="med"/>
+                    </a:lnT>
+                    <a:lnB w="12700" cmpd="sng">
+                      <a:noFill/>
+                      <a:prstDash val="solid"/>
+                    </a:lnB>
+                    <a:lnTlToBr w="12700" cmpd="sng">
+                      <a:noFill/>
+                      <a:prstDash val="solid"/>
+                    </a:lnTlToBr>
+                    <a:lnBlToTr w="12700" cmpd="sng">
+                      <a:noFill/>
+                      <a:prstDash val="solid"/>
+                    </a:lnBlToTr>
+                    <a:noFill/>
+                  </a:tcPr>
+                </a:tc>
+                <a:extLst>
+                  <a:ext uri="{0D108BD9-81ED-4DB2-BD59-A6C34878D82A}">
+                    <a16:rowId xmlns:a16="http://schemas.microsoft.com/office/drawing/2014/main" val="10011"/>
+                  </a:ext>
+                </a:extLst>
+              </a:tr>
+            </a:tbl>
+          </a:graphicData>
+        </a:graphic>
+      </p:graphicFrame>
+      <p:graphicFrame>
+        <p:nvGraphicFramePr>
+          <p:cNvPr id="7" name="Chart 6"/>
+          <p:cNvGraphicFramePr>
+            <a:graphicFrameLocks noGrp="1"/>
+          </p:cNvGraphicFramePr>
+          <p:nvPr>
+            <p:extLst>
+              <p:ext uri="{D42A27DB-BD31-4B8C-83A1-F6EECF244321}">
+                <p14:modId xmlns:p14="http://schemas.microsoft.com/office/powerpoint/2010/main" val="1827273313"/>
+              </p:ext>
+            </p:extLst>
+          </p:nvPr>
+        </p:nvGraphicFramePr>
+        <p:xfrm>
+          <a:off x="7360920" y="1325880"/>
+          <a:ext cx="4526280" cy="2240280"/>
+        </p:xfrm>
+        <a:graphic>
+          <a:graphicData uri="http://schemas.openxmlformats.org/drawingml/2006/chart">
+            <c:chart xmlns:c="http://schemas.openxmlformats.org/drawingml/2006/chart" xmlns:r="http://schemas.openxmlformats.org/officeDocument/2006/relationships" r:id="rId6"/>
+          </a:graphicData>
+        </a:graphic>
+      </p:graphicFrame>
+      <p:sp>
+        <p:nvSpPr>
+          <p:cNvPr id="8" name="Rectangle 7"/>
+          <p:cNvSpPr/>
+          <p:nvPr/>
+        </p:nvSpPr>
+        <p:spPr>
+          <a:xfrm>
+            <a:off x="7360920" y="3703320"/>
+            <a:ext cx="4526280" cy="2743200"/>
+          </a:xfrm>
+          <a:prstGeom prst="rect">
+            <a:avLst/>
+          </a:prstGeom>
+          <a:solidFill>
+            <a:srgbClr val="EEF1F7"/>
+          </a:solidFill>
+          <a:ln>
+            <a:noFill/>
+          </a:ln>
+          <a:effectLst/>
+        </p:spPr>
+        <p:style>
+          <a:lnRef idx="1">
+            <a:schemeClr val="accent1"/>
+          </a:lnRef>
+          <a:fillRef idx="3">
+            <a:schemeClr val="accent1"/>
+          </a:fillRef>
+          <a:effectRef idx="2">
+            <a:schemeClr val="accent1"/>
+          </a:effectRef>
+          <a:fontRef idx="minor">
+            <a:schemeClr val="lt1"/>
+          </a:fontRef>
+        </p:style>
+        <p:txBody>
+          <a:bodyPr rtlCol="0" anchor="ctr"/>
+          <a:lstStyle/>
+          <a:p>
+            <a:pPr algn="ctr"/>
+            <a:endParaRPr lang="pt-BR" noProof="0" dirty="0"/>
+          </a:p>
+        </p:txBody>
+      </p:sp>
+      <p:sp>
+        <p:nvSpPr>
+          <p:cNvPr id="9" name="TextBox 8"/>
+          <p:cNvSpPr txBox="1"/>
+          <p:nvPr/>
+        </p:nvSpPr>
+        <p:spPr>
+          <a:xfrm>
+            <a:off x="7470648" y="3767328"/>
+            <a:ext cx="4297680" cy="2337563"/>
+          </a:xfrm>
+          <a:prstGeom prst="rect">
+            <a:avLst/>
+          </a:prstGeom>
+          <a:noFill/>
+        </p:spPr>
+        <p:txBody>
+          <a:bodyPr wrap="square" lIns="18288" tIns="18288" rIns="18288" bIns="18288" anchor="t">
+            <a:spAutoFit/>
+          </a:bodyPr>
+          <a:lstStyle/>
+          <a:p>
+            <a:pPr algn="l">
+              <a:spcAft>
+                <a:spcPts val="300"/>
+              </a:spcAft>
+            </a:pPr>
+            <a:r>
+              <a:rPr lang="pt-BR" sz="1100" b="1" i="0" noProof="0" dirty="0">
+                <a:solidFill>
+                  <a:srgbClr val="002060"/>
+                </a:solidFill>
+                <a:latin typeface="Gadugi"/>
+              </a:rPr>
+              <a:t>Leitura</a:t>
+            </a:r>
+          </a:p>
+          <a:p>
+            <a:pPr algn="l">
+              <a:spcAft>
+                <a:spcPts val="300"/>
+              </a:spcAft>
+            </a:pPr>
+            <a:r>
+              <a:rPr lang="pt-BR" sz="950" b="0" i="0" noProof="0" dirty="0">
+                <a:solidFill>
+                  <a:srgbClr val="000000"/>
+                </a:solidFill>
+                <a:latin typeface="Gadugi"/>
+              </a:rPr>
+              <a:t>▪ Dois patamares: </a:t>
+            </a:r>
+            <a:r>
+              <a:rPr lang="pt-BR" sz="950" b="1" i="0" noProof="0" dirty="0">
+                <a:solidFill>
+                  <a:srgbClr val="000000"/>
+                </a:solidFill>
+                <a:latin typeface="Gadugi"/>
+              </a:rPr>
+              <a:t>R$ 415–427 MM</a:t>
+            </a:r>
+            <a:r>
+              <a:rPr lang="pt-BR" sz="950" b="0" i="0" noProof="0" dirty="0">
+                <a:solidFill>
+                  <a:srgbClr val="000000"/>
+                </a:solidFill>
+                <a:latin typeface="Gadugi"/>
+              </a:rPr>
+              <a:t> reais em 2019 e 2022–23 e </a:t>
+            </a:r>
+            <a:r>
+              <a:rPr lang="pt-BR" sz="950" b="1" i="0" noProof="0" dirty="0">
+                <a:solidFill>
+                  <a:srgbClr val="000000"/>
+                </a:solidFill>
+                <a:latin typeface="Gadugi"/>
+              </a:rPr>
+              <a:t>R$ 313–316 MM</a:t>
+            </a:r>
+            <a:r>
+              <a:rPr lang="pt-BR" sz="950" b="0" i="0" noProof="0" dirty="0">
+                <a:solidFill>
+                  <a:srgbClr val="000000"/>
+                </a:solidFill>
+                <a:latin typeface="Gadugi"/>
+              </a:rPr>
+              <a:t> em 2024–25; a tendência de 2026 (</a:t>
+            </a:r>
+            <a:r>
+              <a:rPr lang="pt-BR" sz="950" b="1" i="0" noProof="0" dirty="0">
+                <a:solidFill>
+                  <a:srgbClr val="000000"/>
+                </a:solidFill>
+                <a:latin typeface="Gadugi"/>
+              </a:rPr>
+              <a:t>R$ 280,6 MM</a:t>
+            </a:r>
+            <a:r>
+              <a:rPr lang="pt-BR" sz="950" b="0" i="0" noProof="0" dirty="0">
+                <a:solidFill>
+                  <a:srgbClr val="000000"/>
+                </a:solidFill>
+                <a:latin typeface="Gadugi"/>
+              </a:rPr>
+              <a:t>) seria o menor valor da série</a:t>
+            </a:r>
+          </a:p>
+          <a:p>
+            <a:pPr algn="l">
+              <a:spcAft>
+                <a:spcPts val="300"/>
+              </a:spcAft>
+            </a:pPr>
+            <a:r>
+              <a:rPr lang="pt-BR" sz="950" b="0" i="0" noProof="0" dirty="0">
+                <a:solidFill>
+                  <a:srgbClr val="000000"/>
+                </a:solidFill>
+                <a:latin typeface="Gadugi"/>
+              </a:rPr>
+              <a:t>▪ Maiores reduções reais 2019→2026: Manutenção Operacional (</a:t>
+            </a:r>
+            <a:r>
+              <a:rPr lang="pt-BR" sz="950" b="1" i="0" noProof="0" dirty="0">
+                <a:solidFill>
+                  <a:srgbClr val="000000"/>
+                </a:solidFill>
+                <a:latin typeface="Gadugi"/>
+              </a:rPr>
+              <a:t>–R$ 52,5 MM</a:t>
+            </a:r>
+            <a:r>
+              <a:rPr lang="pt-BR" sz="950" b="0" i="0" noProof="0" dirty="0">
+                <a:solidFill>
+                  <a:srgbClr val="000000"/>
+                </a:solidFill>
+                <a:latin typeface="Gadugi"/>
+              </a:rPr>
+              <a:t>; –37%), Pessoal (</a:t>
+            </a:r>
+            <a:r>
+              <a:rPr lang="pt-BR" sz="950" b="1" i="0" noProof="0" dirty="0">
+                <a:solidFill>
+                  <a:srgbClr val="000000"/>
+                </a:solidFill>
+                <a:latin typeface="Gadugi"/>
+              </a:rPr>
+              <a:t>–R$ 41,5 MM</a:t>
+            </a:r>
+            <a:r>
+              <a:rPr lang="pt-BR" sz="950" b="0" i="0" noProof="0" dirty="0">
+                <a:solidFill>
+                  <a:srgbClr val="000000"/>
+                </a:solidFill>
+                <a:latin typeface="Gadugi"/>
+              </a:rPr>
+              <a:t>; –29%) e Consultoria/Serv. Legais (</a:t>
+            </a:r>
+            <a:r>
+              <a:rPr lang="pt-BR" sz="950" b="1" i="0" noProof="0" dirty="0">
+                <a:solidFill>
+                  <a:srgbClr val="000000"/>
+                </a:solidFill>
+                <a:latin typeface="Gadugi"/>
+              </a:rPr>
+              <a:t>–R$ 19,8 MM</a:t>
+            </a:r>
+            <a:r>
+              <a:rPr lang="pt-BR" sz="950" b="0" i="0" noProof="0" dirty="0">
+                <a:solidFill>
+                  <a:srgbClr val="000000"/>
+                </a:solidFill>
+                <a:latin typeface="Gadugi"/>
+              </a:rPr>
+              <a:t>; –37%)</a:t>
+            </a:r>
+          </a:p>
+          <a:p>
+            <a:pPr algn="l">
+              <a:spcAft>
+                <a:spcPts val="300"/>
+              </a:spcAft>
+            </a:pPr>
+            <a:r>
+              <a:rPr lang="pt-BR" sz="950" b="0" i="0" noProof="0" dirty="0">
+                <a:solidFill>
+                  <a:srgbClr val="000000"/>
+                </a:solidFill>
+                <a:latin typeface="Gadugi"/>
+              </a:rPr>
+              <a:t>▪ Em sentido contrário: Logística (+117%, transporte de pessoal), TI (+8%) e Não Recorrente (renovação da LO, R$ 3,4 MM em 2026)</a:t>
+            </a:r>
+          </a:p>
+          <a:p>
+            <a:pPr algn="l">
+              <a:spcAft>
+                <a:spcPts val="300"/>
+              </a:spcAft>
+            </a:pPr>
+            <a:r>
+              <a:rPr lang="pt-BR" sz="950" b="0" i="0" noProof="0" dirty="0">
+                <a:solidFill>
+                  <a:srgbClr val="000000"/>
+                </a:solidFill>
+                <a:latin typeface="Gadugi"/>
+              </a:rPr>
+              <a:t>▪ Gastos pontuais distorcem anos isolados: Covid em 2020–21 (R$ 24 MM nominais), arbitragem CCSA em 2022 (R$ 19 MM) e captação financeira em 2023 (R$ 12 MM)</a:t>
+            </a:r>
+          </a:p>
+          <a:p>
+            <a:pPr algn="l">
+              <a:spcAft>
+                <a:spcPts val="300"/>
+              </a:spcAft>
+            </a:pPr>
+            <a:r>
+              <a:rPr lang="pt-BR" sz="950" b="0" i="1" noProof="0" dirty="0">
+                <a:solidFill>
+                  <a:srgbClr val="595959"/>
+                </a:solidFill>
+                <a:latin typeface="Gadugi"/>
+              </a:rPr>
+              <a:t>▪ O realizado fica abaixo do orçado em todos os anos até 2025 (–3% a –29%); 2026 é o primeiro com tendência acima do orçamento (+1,9%)</a:t>
+            </a:r>
+          </a:p>
+        </p:txBody>
+      </p:sp>
+      <p:sp>
+        <p:nvSpPr>
+          <p:cNvPr id="901" name="Nota plurianual">
+            <a:extLst>
+              <a:ext uri="{FF2B5EF4-FFF2-40B4-BE49-F238E27FC236}">
+                <a16:creationId xmlns:a16="http://schemas.microsoft.com/office/drawing/2014/main" id="{E2AF034E-3CE2-DE58-0F30-1CDD048FE2FE}"/>
+              </a:ext>
+            </a:extLst>
+          </p:cNvPr>
+          <p:cNvSpPr txBox="1"/>
+          <p:nvPr/>
+        </p:nvSpPr>
+        <p:spPr>
+          <a:xfrm>
+            <a:off x="365760" y="4800000"/>
+            <a:ext cx="6766556" cy="160044"/>
+          </a:xfrm>
+          <a:prstGeom prst="rect">
+            <a:avLst/>
+          </a:prstGeom>
+          <a:noFill/>
+        </p:spPr>
+        <p:txBody>
+          <a:bodyPr wrap="square" lIns="18288" tIns="18288" rIns="18288" bIns="18288" anchor="t">
+            <a:spAutoFit/>
+          </a:bodyPr>
+          <a:lstStyle/>
+          <a:p>
+            <a:pPr algn="l">
+              <a:spcAft>
+                <a:spcPts val="300"/>
+              </a:spcAft>
+            </a:pPr>
+            <a:r>
+              <a:rPr lang="pt-BR" sz="800" b="0" i="0" noProof="0" dirty="0">
+                <a:solidFill>
+                  <a:srgbClr val="595959"/>
+                </a:solidFill>
+                <a:latin typeface="Gadugi"/>
+              </a:rPr>
+              <a:t>¹ 2018: só out–dez (início da base).  ² 2026: realizado jan–set + tendência out–dez.  IPCA anual: 2019 4,31%; 2020 4,52%; 2021 10,06%; 2022 5,79%; 2023 4,62%; 2024 4,83%; 2025 4,26%; 2026 4,22% (12 meses até ago).  Exclui Não Gerenciável e Multas, Condenações e Demais Perdas em todos os anos.</a:t>
+            </a:r>
+          </a:p>
+        </p:txBody>
+      </p:sp>
+      <p:sp>
+        <p:nvSpPr>
+          <p:cNvPr id="14" name="TextBox 3">
+            <a:extLst>
+              <a:ext uri="{FF2B5EF4-FFF2-40B4-BE49-F238E27FC236}">
+                <a16:creationId xmlns:a16="http://schemas.microsoft.com/office/drawing/2014/main" id="{E2AF034E-3CE2-DE58-0F30-1CDD048FE2FE}"/>
+              </a:ext>
+            </a:extLst>
+          </p:cNvPr>
+          <p:cNvSpPr txBox="1"/>
+          <p:nvPr/>
+        </p:nvSpPr>
+        <p:spPr>
+          <a:xfrm>
+            <a:off x="502920" y="6644680"/>
+            <a:ext cx="10515600" cy="160044"/>
+          </a:xfrm>
+          <a:prstGeom prst="rect">
+            <a:avLst/>
+          </a:prstGeom>
+          <a:noFill/>
+        </p:spPr>
+        <p:txBody>
+          <a:bodyPr wrap="square" lIns="18288" tIns="18288" rIns="18288" bIns="18288" anchor="t">
+            <a:spAutoFit/>
+          </a:bodyPr>
+          <a:lstStyle/>
+          <a:p>
+            <a:pPr algn="l">
+              <a:spcAft>
+                <a:spcPts val="300"/>
+              </a:spcAft>
+            </a:pPr>
+            <a:r>
+              <a:rPr lang="pt-BR" sz="800" b="0" i="0" noProof="0" dirty="0">
+                <a:solidFill>
+                  <a:srgbClr val="595959"/>
+                </a:solidFill>
+                <a:latin typeface="Gadugi"/>
+              </a:rPr>
+              <a:t>Fonte:  Sistema Matrix – Orç x Real x Tend 26, extraído em 06/10/2026; IBGE – IPCA anual 2019–25 e 12 meses até ago/26 (4,22%)</a:t>
+            </a:r>
+          </a:p>
+        </p:txBody>
+      </p:sp>
+    </p:spTree>
+  </p:cSld>
+  <p:clrMapOvr>
+    <a:masterClrMapping/>
+  </p:clrMapOvr>
+</p:sld>
+</file>
+
 <file path=ppt/tags/tag1.xml><?xml version="1.0" encoding="utf-8"?>
 <p:tagLst xmlns:a="http://schemas.openxmlformats.org/drawingml/2006/main" xmlns:r="http://schemas.openxmlformats.org/officeDocument/2006/relationships" xmlns:p="http://schemas.openxmlformats.org/presentationml/2006/main">
   <p:tag name="THINKCELLUNDODONOTDELETE" val="0"/>

</xml_diff>